<commit_message>
no-mistakes(review): slides: fix stale and mangled speaker notes in lectures 4 and 10
</commit_message>
<xml_diff>
--- a/slides/pptx/lecture04_training_practice.pptx
+++ b/slides/pptx/lecture04_training_practice.pptx
@@ -2156,7 +2156,7 @@
           <a:lstStyle/>
           <a:p>
             <a:r>
-              <a:t>The explicit formula, so the worked numbers on the next slides are COMPUTED, not read off a curve (rule 3: exercises must be solvable and exact). Walk it in two beats. General form: cross-entropy sums −yᵢ·log(ŷᵢ) over every class, where yᵢ is the true label (1 for the correct class, 0 otherwise) and ŷᵢ is the model's probability for class i. Because the label is one-hot, every term with yᵢ=0 vanishes and only the true class's term survives, leaving CE = −log(p_true): "how surprised were you by the truth," now as an equation. Do the one substitution on the slide out loud — truth R, model says p_true = 0.90, so CE = −ln(0.90) = 0.105 — and note we use the natural log (ln), the PyTorch default; the base only rescales the loss, it never changes which model wins. Tell them to keep this line: the next slide, the you-do, and Quiz 4 Q1 all just plug numbers into −ln(p_true).</a:t>
+              <a:t>The explicit formula, so the worked numbers on the next slides are COMPUTED, not read off a curve (rule 3: exercises must be solvable and exact). Walk it in two beats. General form: cross-entropy sums −yᵢ·log(ŷᵢ) over every class, where yᵢ is the true label (1 for the correct class, 0 otherwise) and ŷᵢ is the model's probability for class i. Because the label is one-hot, every term with yᵢ=0 vanishes and only the true class's term survives, leaving CE = −log(p_true): "how surprised were you by the truth," now as an equation. Do the one substitution on the slide out loud — truth R, model says p_true = 0.90, so CE = −ln(0.90) = 0.105 — and note we use the natural log (ln), the PyTorch default; the base only rescales the loss, it never changes which model wins. Tell them to keep this line: the penalty-shape curve next, the STEP 4 worked example, the you-do, and Quiz 4 Q1 all just plug numbers into −ln(p_true).</a:t>
             </a:r>
           </a:p>
           <a:p>
@@ -2229,7 +2229,7 @@
           <a:lstStyle/>
           <a:p>
             <a:r>
-              <a:t>This is the intuition to land, and it is the "penalize confident wrong answers" outcome verbatim. Read the curve right to left: give the true class a probability near 1 and you were right and sure, so the penalty is essentially zero; at 0.5 you were on the fence, a moderate penalty; as your probability for the truth heads toward zero — meaning you were confidently backing the WRONG class — the penalty shoots toward infinity. That asymmetry is deliberate and clinically sensible: a test that hedges is tolerable, a test that is loudly, confidently wrong is dangerous, and the loss reflects that. Name it plainly now: this curve is −log(p_true) — the next slide writes the full formula and does one substitution, so every number they compute later is exact, not eyeballed. One line of contrast with MSE: MSE treats 0.9-vs-1 and 0.1-vs-0 as similar-sized misses; cross- entropy blows the confident miss up enormously.</a:t>
+              <a:t>This is the intuition to land, and it is the "penalize confident wrong answers" outcome verbatim. Read the curve right to left: give the true class a probability near 1 and you were right and sure, so the penalty is essentially zero; at 0.5 you were on the fence, a moderate penalty; as your probability for the truth heads toward zero — meaning you were confidently backing the WRONG class — the penalty shoots toward infinity. That asymmetry is deliberate and clinically sensible: a test that hedges is tolerable, a test that is loudly, confidently wrong is dangerous, and the loss reflects that. Name it plainly now: this curve is −log(p_true) — the previous slide already wrote the full formula out and did one substitution, so every number they compute later is exact, not eyeballed. One line of contrast with MSE: MSE treats 0.9-vs-1 and 0.1-vs-0 as similar-sized misses; cross- entropy blows the confident miss up enormously.</a:t>
             </a:r>
           </a:p>
           <a:p>
@@ -6496,7 +6496,7 @@
 </file>
 
 <file path=ppt/slides/slide20.xml><?xml version="1.0" encoding="utf-8"?>
-<p:sld xmlns:a="http://schemas.openxmlformats.org/drawingml/2006/main" xmlns:r="http://schemas.openxmlformats.org/officeDocument/2006/relationships" xmlns:p="http://schemas.openxmlformats.org/presentationml/2006/main">
+<p:sld xmlns:a="http://schemas.openxmlformats.org/drawingml/2006/main" xmlns:p="http://schemas.openxmlformats.org/presentationml/2006/main" xmlns:r="http://schemas.openxmlformats.org/officeDocument/2006/relationships">
   <p:cSld>
     <p:spTree>
       <p:nvGrpSpPr>
@@ -6504,14 +6504,7 @@
         <p:cNvGrpSpPr/>
         <p:nvPr/>
       </p:nvGrpSpPr>
-      <p:grpSpPr>
-        <a:xfrm>
-          <a:off x="0" y="0"/>
-          <a:ext cx="0" cy="0"/>
-          <a:chOff x="0" y="0"/>
-          <a:chExt cx="0" cy="0"/>
-        </a:xfrm>
-      </p:grpSpPr>
+      <p:grpSpPr/>
       <p:sp>
         <p:nvSpPr>
           <p:cNvPr id="2" name="Rectangle 1"/>
@@ -6586,7 +6579,7 @@
                 </a:solidFill>
                 <a:latin typeface="Menlo"/>
               </a:rPr>
-              <a:t>PART 2 · TUNING · THE HYPERPARAMETERS</a:t>
+              <a:t>PART 2 · TUNING · YOUR TURN (YOU-DO = Q4)</a:t>
             </a:r>
           </a:p>
         </p:txBody>
@@ -6600,7 +6593,7 @@
         <p:spPr>
           <a:xfrm>
             <a:off x="548640" y="731520"/>
-            <a:ext cx="11064240" cy="1127760"/>
+            <a:ext cx="11064240" cy="1005840"/>
           </a:xfrm>
           <a:prstGeom prst="rect">
             <a:avLst/>
@@ -6620,155 +6613,7 @@
                 </a:solidFill>
                 <a:latin typeface="Avenir Next"/>
               </a:rPr>
-              <a:t>The knobs you set — tune the learning rate first</a:t>
-            </a:r>
-          </a:p>
-        </p:txBody>
-      </p:sp>
-      <p:sp>
-        <p:nvSpPr>
-          <p:cNvPr id="5" name="TextBox 4"/>
-          <p:cNvSpPr txBox="1"/>
-          <p:nvPr/>
-        </p:nvSpPr>
-        <p:spPr>
-          <a:xfrm>
-            <a:off x="548640" y="1920240"/>
-            <a:ext cx="10789920" cy="3794760"/>
-          </a:xfrm>
-          <a:prstGeom prst="rect">
-            <a:avLst/>
-          </a:prstGeom>
-          <a:noFill/>
-        </p:spPr>
-        <p:txBody>
-          <a:bodyPr wrap="square" anchor="t">
-            <a:spAutoFit/>
-          </a:bodyPr>
-          <a:lstStyle/>
-          <a:p>
-            <a:pPr>
-              <a:spcAft>
-                <a:spcPts val="1800"/>
-              </a:spcAft>
-            </a:pPr>
-            <a:r>
-              <a:rPr sz="2100" b="1" i="0" dirty="0">
-                <a:solidFill>
-                  <a:srgbClr val="0E7C7B"/>
-                </a:solidFill>
-                <a:latin typeface="Avenir Next"/>
-              </a:rPr>
-              <a:t>•  </a:t>
-            </a:r>
-            <a:r>
-              <a:rPr sz="2100" b="0" i="0" dirty="0">
-                <a:solidFill>
-                  <a:srgbClr val="1B2025"/>
-                </a:solidFill>
-                <a:latin typeface="Avenir Next"/>
-              </a:rPr>
-              <a:t>Hyperparameters = settings you choose BEFORE training (the weights are what training learns)</a:t>
-            </a:r>
-          </a:p>
-          <a:p>
-            <a:pPr>
-              <a:spcAft>
-                <a:spcPts val="1800"/>
-              </a:spcAft>
-            </a:pPr>
-            <a:r>
-              <a:rPr sz="2100" b="1" i="0" dirty="0">
-                <a:solidFill>
-                  <a:srgbClr val="0E7C7B"/>
-                </a:solidFill>
-                <a:latin typeface="Avenir Next"/>
-              </a:rPr>
-              <a:t>•  </a:t>
-            </a:r>
-            <a:r>
-              <a:rPr sz="2100" b="0" i="0" dirty="0">
-                <a:solidFill>
-                  <a:srgbClr val="1B2025"/>
-                </a:solidFill>
-                <a:latin typeface="Avenir Next"/>
-              </a:rPr>
-              <a:t>There are a huge number: depth · width · activation · optimizer · dropout · weight decay · schedule · batch size · epochs · …</a:t>
-            </a:r>
-          </a:p>
-          <a:p>
-            <a:pPr>
-              <a:spcAft>
-                <a:spcPts val="1800"/>
-              </a:spcAft>
-            </a:pPr>
-            <a:r>
-              <a:rPr sz="2100" b="1" i="0" dirty="0">
-                <a:solidFill>
-                  <a:srgbClr val="0E7C7B"/>
-                </a:solidFill>
-                <a:latin typeface="Avenir Next"/>
-              </a:rPr>
-              <a:t>•  </a:t>
-            </a:r>
-            <a:r>
-              <a:rPr sz="2100" b="0" i="0" dirty="0">
-                <a:solidFill>
-                  <a:srgbClr val="1B2025"/>
-                </a:solidFill>
-                <a:latin typeface="Avenir Next"/>
-              </a:rPr>
-              <a:t>1 · Learning rate — by far the most impactful (Lecture 2's three bowls)</a:t>
-            </a:r>
-          </a:p>
-          <a:p>
-            <a:pPr>
-              <a:spcAft>
-                <a:spcPts val="1800"/>
-              </a:spcAft>
-            </a:pPr>
-            <a:r>
-              <a:rPr sz="2100" b="1" i="0" dirty="0">
-                <a:solidFill>
-                  <a:srgbClr val="0E7C7B"/>
-                </a:solidFill>
-                <a:latin typeface="Avenir Next"/>
-              </a:rPr>
-              <a:t>•  </a:t>
-            </a:r>
-            <a:r>
-              <a:rPr sz="2100" b="0" i="0" dirty="0">
-                <a:solidFill>
-                  <a:srgbClr val="1B2025"/>
-                </a:solidFill>
-                <a:latin typeface="Avenir Next"/>
-              </a:rPr>
-              <a:t>2 · Batch size — memory and the trade-off, next two slides</a:t>
-            </a:r>
-          </a:p>
-          <a:p>
-            <a:pPr>
-              <a:spcAft>
-                <a:spcPts val="1800"/>
-              </a:spcAft>
-            </a:pPr>
-            <a:r>
-              <a:rPr sz="2100" b="1" i="0" dirty="0">
-                <a:solidFill>
-                  <a:srgbClr val="0E7C7B"/>
-                </a:solidFill>
-                <a:latin typeface="Avenir Next"/>
-              </a:rPr>
-              <a:t>•  </a:t>
-            </a:r>
-            <a:r>
-              <a:rPr sz="2100" b="0" i="0" dirty="0">
-                <a:solidFill>
-                  <a:srgbClr val="1B2025"/>
-                </a:solidFill>
-                <a:latin typeface="Avenir Next"/>
-              </a:rPr>
-              <a:t>3 · Model size / epochs — capacity and how long</a:t>
+              <a:t>Your turn — what gradient reaches layer 1?</a:t>
             </a:r>
           </a:p>
         </p:txBody>
@@ -6781,8 +6626,8 @@
         </p:nvSpPr>
         <p:spPr>
           <a:xfrm>
-            <a:off x="548640" y="5843016"/>
-            <a:ext cx="10515600" cy="923544"/>
+            <a:off x="548640" y="5538216"/>
+            <a:ext cx="10515600" cy="1182624"/>
           </a:xfrm>
           <a:prstGeom prst="rect">
             <a:avLst/>
@@ -6792,7 +6637,7 @@
           </a:solidFill>
           <a:ln w="12700">
             <a:solidFill>
-              <a:srgbClr val="3D444C"/>
+              <a:srgbClr val="E09E2F"/>
             </a:solidFill>
           </a:ln>
           <a:effectLst/>
@@ -6817,13 +6662,757 @@
           <a:p>
             <a:pPr algn="ctr"/>
             <a:r>
+              <a:rPr sz="1200" b="1" i="0">
+                <a:solidFill>
+                  <a:srgbClr val="E09E2F"/>
+                </a:solidFill>
+                <a:latin typeface="Menlo"/>
+              </a:rPr>
+              <a:t>CHECKPOINT · </a:t>
+            </a:r>
+            <a:r>
               <a:rPr sz="1700" b="0" i="0">
                 <a:solidFill>
                   <a:srgbClr val="3D444C"/>
                 </a:solidFill>
                 <a:latin typeface="Avenir Next"/>
               </a:rPr>
-              <a:t>Get the learning rate right and half your problems disappear; everything else can start at its library default. Order of attack: learning rate → batch size → model size / epochs.</a:t>
+              <a:t>Your turn → Quiz 4, Q4. Multiply the slopes down the chain: 1.0 leaves the loss and is multiplied by 0.5 at each of 5 layers. (a) What reaches layer 1? (b) Vanishing or exploding? (c) What does that mean for the earliest layers? Worked answer in the notes.</a:t>
+            </a:r>
+          </a:p>
+        </p:txBody>
+      </p:sp>
+      <p:sp>
+        <p:nvSpPr>
+          <p:cNvPr id="7" name="Rounded Rectangle 6"/>
+          <p:cNvSpPr/>
+          <p:nvPr/>
+        </p:nvSpPr>
+        <p:spPr>
+          <a:xfrm>
+            <a:off x="548640" y="1908800"/>
+            <a:ext cx="1000000" cy="560000"/>
+          </a:xfrm>
+          <a:prstGeom prst="roundRect">
+            <a:avLst>
+              <a:gd name="adj" fmla="val 8000"/>
+            </a:avLst>
+          </a:prstGeom>
+          <a:solidFill>
+            <a:srgbClr val="FBF1DC"/>
+          </a:solidFill>
+          <a:ln>
+            <a:noFill/>
+          </a:ln>
+          <a:effectLst/>
+        </p:spPr>
+        <p:style>
+          <a:lnRef idx="1">
+            <a:schemeClr val="accent1"/>
+          </a:lnRef>
+          <a:fillRef idx="3">
+            <a:schemeClr val="accent1"/>
+          </a:fillRef>
+          <a:effectRef idx="2">
+            <a:schemeClr val="accent1"/>
+          </a:effectRef>
+          <a:fontRef idx="minor">
+            <a:schemeClr val="lt1"/>
+          </a:fontRef>
+        </p:style>
+        <p:txBody>
+          <a:bodyPr rtlCol="0" anchor="ctr"/>
+          <a:lstStyle/>
+          <a:p>
+            <a:pPr algn="ctr"/>
+            <a:r>
+              <a:rPr sz="1500" b="1">
+                <a:solidFill>
+                  <a:srgbClr val="1B2025"/>
+                </a:solidFill>
+                <a:latin typeface="Avenir Next"/>
+              </a:rPr>
+              <a:t>loss</a:t>
+            </a:r>
+          </a:p>
+        </p:txBody>
+      </p:sp>
+      <p:sp>
+        <p:nvSpPr>
+          <p:cNvPr id="8" name="TextBox 7"/>
+          <p:cNvSpPr txBox="1"/>
+          <p:nvPr/>
+        </p:nvSpPr>
+        <p:spPr>
+          <a:xfrm>
+            <a:off x="97080" y="2488800"/>
+            <a:ext cx="1903120" cy="330000"/>
+          </a:xfrm>
+          <a:prstGeom prst="rect">
+            <a:avLst/>
+          </a:prstGeom>
+          <a:noFill/>
+        </p:spPr>
+        <p:txBody>
+          <a:bodyPr wrap="square" lIns="45720" rIns="45720" tIns="27432" bIns="27432" anchor="t">
+            <a:spAutoFit/>
+          </a:bodyPr>
+          <a:lstStyle/>
+          <a:p>
+            <a:pPr algn="ctr">
+              <a:spcAft>
+                <a:spcPts val="400"/>
+              </a:spcAft>
+            </a:pPr>
+            <a:r>
+              <a:rPr sz="1400" b="1">
+                <a:solidFill>
+                  <a:srgbClr val="3D444C"/>
+                </a:solidFill>
+                <a:latin typeface="Avenir Next"/>
+              </a:rPr>
+              <a:t>gradient 1.0</a:t>
+            </a:r>
+          </a:p>
+        </p:txBody>
+      </p:sp>
+      <p:sp>
+        <p:nvSpPr>
+          <p:cNvPr id="9" name="TextBox 8"/>
+          <p:cNvSpPr txBox="1"/>
+          <p:nvPr/>
+        </p:nvSpPr>
+        <p:spPr>
+          <a:xfrm>
+            <a:off x="1548640" y="1968800"/>
+            <a:ext cx="903120" cy="440000"/>
+          </a:xfrm>
+          <a:prstGeom prst="rect">
+            <a:avLst/>
+          </a:prstGeom>
+          <a:noFill/>
+        </p:spPr>
+        <p:txBody>
+          <a:bodyPr wrap="square" lIns="45720" rIns="45720" tIns="27432" bIns="27432" anchor="ctr">
+            <a:spAutoFit/>
+          </a:bodyPr>
+          <a:lstStyle/>
+          <a:p>
+            <a:pPr algn="ctr">
+              <a:spcAft>
+                <a:spcPts val="400"/>
+              </a:spcAft>
+            </a:pPr>
+            <a:r>
+              <a:rPr sz="1500" b="1">
+                <a:solidFill>
+                  <a:srgbClr val="0E7C7B"/>
+                </a:solidFill>
+                <a:latin typeface="Menlo"/>
+              </a:rPr>
+              <a:t>× 0.5</a:t>
+            </a:r>
+          </a:p>
+        </p:txBody>
+      </p:sp>
+      <p:sp>
+        <p:nvSpPr>
+          <p:cNvPr id="10" name="Rounded Rectangle 9"/>
+          <p:cNvSpPr/>
+          <p:nvPr/>
+        </p:nvSpPr>
+        <p:spPr>
+          <a:xfrm>
+            <a:off x="2451760" y="1908800"/>
+            <a:ext cx="1000000" cy="560000"/>
+          </a:xfrm>
+          <a:prstGeom prst="roundRect">
+            <a:avLst>
+              <a:gd name="adj" fmla="val 8000"/>
+            </a:avLst>
+          </a:prstGeom>
+          <a:solidFill>
+            <a:srgbClr val="E3F0EF"/>
+          </a:solidFill>
+          <a:ln>
+            <a:noFill/>
+          </a:ln>
+          <a:effectLst/>
+        </p:spPr>
+        <p:style>
+          <a:lnRef idx="1">
+            <a:schemeClr val="accent1"/>
+          </a:lnRef>
+          <a:fillRef idx="3">
+            <a:schemeClr val="accent1"/>
+          </a:fillRef>
+          <a:effectRef idx="2">
+            <a:schemeClr val="accent1"/>
+          </a:effectRef>
+          <a:fontRef idx="minor">
+            <a:schemeClr val="lt1"/>
+          </a:fontRef>
+        </p:style>
+        <p:txBody>
+          <a:bodyPr rtlCol="0" anchor="ctr"/>
+          <a:lstStyle/>
+          <a:p>
+            <a:pPr algn="ctr"/>
+            <a:r>
+              <a:rPr sz="1500" b="1">
+                <a:solidFill>
+                  <a:srgbClr val="1B2025"/>
+                </a:solidFill>
+                <a:latin typeface="Avenir Next"/>
+              </a:rPr>
+              <a:t>layer 5</a:t>
+            </a:r>
+          </a:p>
+        </p:txBody>
+      </p:sp>
+      <p:sp>
+        <p:nvSpPr>
+          <p:cNvPr id="11" name="TextBox 10"/>
+          <p:cNvSpPr txBox="1"/>
+          <p:nvPr/>
+        </p:nvSpPr>
+        <p:spPr>
+          <a:xfrm>
+            <a:off x="3451760" y="1968800"/>
+            <a:ext cx="903120" cy="440000"/>
+          </a:xfrm>
+          <a:prstGeom prst="rect">
+            <a:avLst/>
+          </a:prstGeom>
+          <a:noFill/>
+        </p:spPr>
+        <p:txBody>
+          <a:bodyPr wrap="square" lIns="45720" rIns="45720" tIns="27432" bIns="27432" anchor="ctr">
+            <a:spAutoFit/>
+          </a:bodyPr>
+          <a:lstStyle/>
+          <a:p>
+            <a:pPr algn="ctr">
+              <a:spcAft>
+                <a:spcPts val="400"/>
+              </a:spcAft>
+            </a:pPr>
+            <a:r>
+              <a:rPr sz="1500" b="1">
+                <a:solidFill>
+                  <a:srgbClr val="0E7C7B"/>
+                </a:solidFill>
+                <a:latin typeface="Menlo"/>
+              </a:rPr>
+              <a:t>× 0.5</a:t>
+            </a:r>
+          </a:p>
+        </p:txBody>
+      </p:sp>
+      <p:sp>
+        <p:nvSpPr>
+          <p:cNvPr id="12" name="Rounded Rectangle 11"/>
+          <p:cNvSpPr/>
+          <p:nvPr/>
+        </p:nvSpPr>
+        <p:spPr>
+          <a:xfrm>
+            <a:off x="4354880" y="1908800"/>
+            <a:ext cx="1000000" cy="560000"/>
+          </a:xfrm>
+          <a:prstGeom prst="roundRect">
+            <a:avLst>
+              <a:gd name="adj" fmla="val 8000"/>
+            </a:avLst>
+          </a:prstGeom>
+          <a:solidFill>
+            <a:srgbClr val="E3F0EF"/>
+          </a:solidFill>
+          <a:ln>
+            <a:noFill/>
+          </a:ln>
+          <a:effectLst/>
+        </p:spPr>
+        <p:style>
+          <a:lnRef idx="1">
+            <a:schemeClr val="accent1"/>
+          </a:lnRef>
+          <a:fillRef idx="3">
+            <a:schemeClr val="accent1"/>
+          </a:fillRef>
+          <a:effectRef idx="2">
+            <a:schemeClr val="accent1"/>
+          </a:effectRef>
+          <a:fontRef idx="minor">
+            <a:schemeClr val="lt1"/>
+          </a:fontRef>
+        </p:style>
+        <p:txBody>
+          <a:bodyPr rtlCol="0" anchor="ctr"/>
+          <a:lstStyle/>
+          <a:p>
+            <a:pPr algn="ctr"/>
+            <a:r>
+              <a:rPr sz="1500" b="1">
+                <a:solidFill>
+                  <a:srgbClr val="1B2025"/>
+                </a:solidFill>
+                <a:latin typeface="Avenir Next"/>
+              </a:rPr>
+              <a:t>layer 4</a:t>
+            </a:r>
+          </a:p>
+        </p:txBody>
+      </p:sp>
+      <p:sp>
+        <p:nvSpPr>
+          <p:cNvPr id="13" name="TextBox 12"/>
+          <p:cNvSpPr txBox="1"/>
+          <p:nvPr/>
+        </p:nvSpPr>
+        <p:spPr>
+          <a:xfrm>
+            <a:off x="5354880" y="1968800"/>
+            <a:ext cx="903120" cy="440000"/>
+          </a:xfrm>
+          <a:prstGeom prst="rect">
+            <a:avLst/>
+          </a:prstGeom>
+          <a:noFill/>
+        </p:spPr>
+        <p:txBody>
+          <a:bodyPr wrap="square" lIns="45720" rIns="45720" tIns="27432" bIns="27432" anchor="ctr">
+            <a:spAutoFit/>
+          </a:bodyPr>
+          <a:lstStyle/>
+          <a:p>
+            <a:pPr algn="ctr">
+              <a:spcAft>
+                <a:spcPts val="400"/>
+              </a:spcAft>
+            </a:pPr>
+            <a:r>
+              <a:rPr sz="1500" b="1">
+                <a:solidFill>
+                  <a:srgbClr val="0E7C7B"/>
+                </a:solidFill>
+                <a:latin typeface="Menlo"/>
+              </a:rPr>
+              <a:t>× 0.5</a:t>
+            </a:r>
+          </a:p>
+        </p:txBody>
+      </p:sp>
+      <p:sp>
+        <p:nvSpPr>
+          <p:cNvPr id="14" name="Rounded Rectangle 13"/>
+          <p:cNvSpPr/>
+          <p:nvPr/>
+        </p:nvSpPr>
+        <p:spPr>
+          <a:xfrm>
+            <a:off x="6258000" y="1908800"/>
+            <a:ext cx="1000000" cy="560000"/>
+          </a:xfrm>
+          <a:prstGeom prst="roundRect">
+            <a:avLst>
+              <a:gd name="adj" fmla="val 8000"/>
+            </a:avLst>
+          </a:prstGeom>
+          <a:solidFill>
+            <a:srgbClr val="E3F0EF"/>
+          </a:solidFill>
+          <a:ln>
+            <a:noFill/>
+          </a:ln>
+          <a:effectLst/>
+        </p:spPr>
+        <p:style>
+          <a:lnRef idx="1">
+            <a:schemeClr val="accent1"/>
+          </a:lnRef>
+          <a:fillRef idx="3">
+            <a:schemeClr val="accent1"/>
+          </a:fillRef>
+          <a:effectRef idx="2">
+            <a:schemeClr val="accent1"/>
+          </a:effectRef>
+          <a:fontRef idx="minor">
+            <a:schemeClr val="lt1"/>
+          </a:fontRef>
+        </p:style>
+        <p:txBody>
+          <a:bodyPr rtlCol="0" anchor="ctr"/>
+          <a:lstStyle/>
+          <a:p>
+            <a:pPr algn="ctr"/>
+            <a:r>
+              <a:rPr sz="1500" b="1">
+                <a:solidFill>
+                  <a:srgbClr val="1B2025"/>
+                </a:solidFill>
+                <a:latin typeface="Avenir Next"/>
+              </a:rPr>
+              <a:t>layer 3</a:t>
+            </a:r>
+          </a:p>
+        </p:txBody>
+      </p:sp>
+      <p:sp>
+        <p:nvSpPr>
+          <p:cNvPr id="15" name="TextBox 14"/>
+          <p:cNvSpPr txBox="1"/>
+          <p:nvPr/>
+        </p:nvSpPr>
+        <p:spPr>
+          <a:xfrm>
+            <a:off x="7258000" y="1968800"/>
+            <a:ext cx="903120" cy="440000"/>
+          </a:xfrm>
+          <a:prstGeom prst="rect">
+            <a:avLst/>
+          </a:prstGeom>
+          <a:noFill/>
+        </p:spPr>
+        <p:txBody>
+          <a:bodyPr wrap="square" lIns="45720" rIns="45720" tIns="27432" bIns="27432" anchor="ctr">
+            <a:spAutoFit/>
+          </a:bodyPr>
+          <a:lstStyle/>
+          <a:p>
+            <a:pPr algn="ctr">
+              <a:spcAft>
+                <a:spcPts val="400"/>
+              </a:spcAft>
+            </a:pPr>
+            <a:r>
+              <a:rPr sz="1500" b="1">
+                <a:solidFill>
+                  <a:srgbClr val="0E7C7B"/>
+                </a:solidFill>
+                <a:latin typeface="Menlo"/>
+              </a:rPr>
+              <a:t>× 0.5</a:t>
+            </a:r>
+          </a:p>
+        </p:txBody>
+      </p:sp>
+      <p:sp>
+        <p:nvSpPr>
+          <p:cNvPr id="16" name="Rounded Rectangle 15"/>
+          <p:cNvSpPr/>
+          <p:nvPr/>
+        </p:nvSpPr>
+        <p:spPr>
+          <a:xfrm>
+            <a:off x="8161120" y="1908800"/>
+            <a:ext cx="1000000" cy="560000"/>
+          </a:xfrm>
+          <a:prstGeom prst="roundRect">
+            <a:avLst>
+              <a:gd name="adj" fmla="val 8000"/>
+            </a:avLst>
+          </a:prstGeom>
+          <a:solidFill>
+            <a:srgbClr val="E3F0EF"/>
+          </a:solidFill>
+          <a:ln>
+            <a:noFill/>
+          </a:ln>
+          <a:effectLst/>
+        </p:spPr>
+        <p:style>
+          <a:lnRef idx="1">
+            <a:schemeClr val="accent1"/>
+          </a:lnRef>
+          <a:fillRef idx="3">
+            <a:schemeClr val="accent1"/>
+          </a:fillRef>
+          <a:effectRef idx="2">
+            <a:schemeClr val="accent1"/>
+          </a:effectRef>
+          <a:fontRef idx="minor">
+            <a:schemeClr val="lt1"/>
+          </a:fontRef>
+        </p:style>
+        <p:txBody>
+          <a:bodyPr rtlCol="0" anchor="ctr"/>
+          <a:lstStyle/>
+          <a:p>
+            <a:pPr algn="ctr"/>
+            <a:r>
+              <a:rPr sz="1500" b="1">
+                <a:solidFill>
+                  <a:srgbClr val="1B2025"/>
+                </a:solidFill>
+                <a:latin typeface="Avenir Next"/>
+              </a:rPr>
+              <a:t>layer 2</a:t>
+            </a:r>
+          </a:p>
+        </p:txBody>
+      </p:sp>
+      <p:sp>
+        <p:nvSpPr>
+          <p:cNvPr id="17" name="TextBox 16"/>
+          <p:cNvSpPr txBox="1"/>
+          <p:nvPr/>
+        </p:nvSpPr>
+        <p:spPr>
+          <a:xfrm>
+            <a:off x="9161120" y="1968800"/>
+            <a:ext cx="903120" cy="440000"/>
+          </a:xfrm>
+          <a:prstGeom prst="rect">
+            <a:avLst/>
+          </a:prstGeom>
+          <a:noFill/>
+        </p:spPr>
+        <p:txBody>
+          <a:bodyPr wrap="square" lIns="45720" rIns="45720" tIns="27432" bIns="27432" anchor="ctr">
+            <a:spAutoFit/>
+          </a:bodyPr>
+          <a:lstStyle/>
+          <a:p>
+            <a:pPr algn="ctr">
+              <a:spcAft>
+                <a:spcPts val="400"/>
+              </a:spcAft>
+            </a:pPr>
+            <a:r>
+              <a:rPr sz="1500" b="1">
+                <a:solidFill>
+                  <a:srgbClr val="0E7C7B"/>
+                </a:solidFill>
+                <a:latin typeface="Menlo"/>
+              </a:rPr>
+              <a:t>× 0.5</a:t>
+            </a:r>
+          </a:p>
+        </p:txBody>
+      </p:sp>
+      <p:sp>
+        <p:nvSpPr>
+          <p:cNvPr id="18" name="Rounded Rectangle 17"/>
+          <p:cNvSpPr/>
+          <p:nvPr/>
+        </p:nvSpPr>
+        <p:spPr>
+          <a:xfrm>
+            <a:off x="10064240" y="1908800"/>
+            <a:ext cx="1000000" cy="560000"/>
+          </a:xfrm>
+          <a:prstGeom prst="roundRect">
+            <a:avLst>
+              <a:gd name="adj" fmla="val 8000"/>
+            </a:avLst>
+          </a:prstGeom>
+          <a:solidFill>
+            <a:srgbClr val="FBF1DC"/>
+          </a:solidFill>
+          <a:ln>
+            <a:noFill/>
+          </a:ln>
+          <a:effectLst/>
+        </p:spPr>
+        <p:style>
+          <a:lnRef idx="1">
+            <a:schemeClr val="accent1"/>
+          </a:lnRef>
+          <a:fillRef idx="3">
+            <a:schemeClr val="accent1"/>
+          </a:fillRef>
+          <a:effectRef idx="2">
+            <a:schemeClr val="accent1"/>
+          </a:effectRef>
+          <a:fontRef idx="minor">
+            <a:schemeClr val="lt1"/>
+          </a:fontRef>
+        </p:style>
+        <p:txBody>
+          <a:bodyPr rtlCol="0" anchor="ctr"/>
+          <a:lstStyle/>
+          <a:p>
+            <a:pPr algn="ctr"/>
+            <a:r>
+              <a:rPr sz="1500" b="1">
+                <a:solidFill>
+                  <a:srgbClr val="1B2025"/>
+                </a:solidFill>
+                <a:latin typeface="Avenir Next"/>
+              </a:rPr>
+              <a:t>layer 1</a:t>
+            </a:r>
+          </a:p>
+        </p:txBody>
+      </p:sp>
+      <p:sp>
+        <p:nvSpPr>
+          <p:cNvPr id="19" name="TextBox 18"/>
+          <p:cNvSpPr txBox="1"/>
+          <p:nvPr/>
+        </p:nvSpPr>
+        <p:spPr>
+          <a:xfrm>
+            <a:off x="9612680" y="2488800"/>
+            <a:ext cx="1903120" cy="330000"/>
+          </a:xfrm>
+          <a:prstGeom prst="rect">
+            <a:avLst/>
+          </a:prstGeom>
+          <a:noFill/>
+        </p:spPr>
+        <p:txBody>
+          <a:bodyPr wrap="square" lIns="45720" rIns="45720" tIns="27432" bIns="27432" anchor="t">
+            <a:spAutoFit/>
+          </a:bodyPr>
+          <a:lstStyle/>
+          <a:p>
+            <a:pPr algn="ctr">
+              <a:spcAft>
+                <a:spcPts val="400"/>
+              </a:spcAft>
+            </a:pPr>
+            <a:r>
+              <a:rPr sz="1400" b="1">
+                <a:solidFill>
+                  <a:srgbClr val="E09E2F"/>
+                </a:solidFill>
+                <a:latin typeface="Avenir Next"/>
+              </a:rPr>
+              <a:t>gradient ?</a:t>
+            </a:r>
+          </a:p>
+        </p:txBody>
+      </p:sp>
+      <p:sp>
+        <p:nvSpPr>
+          <p:cNvPr id="20" name="TextBox 19"/>
+          <p:cNvSpPr txBox="1"/>
+          <p:nvPr/>
+        </p:nvSpPr>
+        <p:spPr>
+          <a:xfrm>
+            <a:off x="548640" y="2888800"/>
+            <a:ext cx="10515600" cy="1900000"/>
+          </a:xfrm>
+          <a:prstGeom prst="rect">
+            <a:avLst/>
+          </a:prstGeom>
+          <a:noFill/>
+        </p:spPr>
+        <p:txBody>
+          <a:bodyPr wrap="square" lIns="45720" rIns="45720" tIns="27432" bIns="27432" anchor="t">
+            <a:spAutoFit/>
+          </a:bodyPr>
+          <a:lstStyle/>
+          <a:p>
+            <a:pPr algn="l">
+              <a:spcAft>
+                <a:spcPts val="600"/>
+              </a:spcAft>
+            </a:pPr>
+            <a:r>
+              <a:rPr sz="1600" b="0">
+                <a:solidFill>
+                  <a:srgbClr val="1B2025"/>
+                </a:solidFill>
+                <a:latin typeface="Avenir Next"/>
+              </a:rPr>
+              <a:t>A gradient is the PRODUCT of the local slopes along the path back to a weight (Lecture 2). Here it passes back through 5 layers, each multiplying it by a slope of 0.5.</a:t>
+            </a:r>
+          </a:p>
+          <a:p>
+            <a:pPr algn="l">
+              <a:spcAft>
+                <a:spcPts val="600"/>
+              </a:spcAft>
+            </a:pPr>
+            <a:r>
+              <a:rPr sz="1600" b="1">
+                <a:solidFill>
+                  <a:srgbClr val="0E7C7B"/>
+                </a:solidFill>
+                <a:latin typeface="Avenir Next"/>
+              </a:rPr>
+              <a:t>(a)  </a:t>
+            </a:r>
+            <a:r>
+              <a:rPr sz="1600" b="0">
+                <a:solidFill>
+                  <a:srgbClr val="1B2025"/>
+                </a:solidFill>
+                <a:latin typeface="Avenir Next"/>
+              </a:rPr>
+              <a:t>What gradient reaches the first layer?   1.0 × 0.5⁵ =</a:t>
+            </a:r>
+            <a:r>
+              <a:rPr sz="1600" b="1">
+                <a:solidFill>
+                  <a:srgbClr val="0E7C7B"/>
+                </a:solidFill>
+                <a:latin typeface="Avenir Next"/>
+              </a:rPr>
+              <a:t>  ________</a:t>
+            </a:r>
+          </a:p>
+          <a:p>
+            <a:pPr algn="l">
+              <a:spcAft>
+                <a:spcPts val="600"/>
+              </a:spcAft>
+            </a:pPr>
+            <a:r>
+              <a:rPr sz="1600" b="1">
+                <a:solidFill>
+                  <a:srgbClr val="0E7C7B"/>
+                </a:solidFill>
+                <a:latin typeface="Avenir Next"/>
+              </a:rPr>
+              <a:t>(b)  </a:t>
+            </a:r>
+            <a:r>
+              <a:rPr sz="1600" b="0">
+                <a:solidFill>
+                  <a:srgbClr val="1B2025"/>
+                </a:solidFill>
+                <a:latin typeface="Avenir Next"/>
+              </a:rPr>
+              <a:t>Is this vanishing or exploding?</a:t>
+            </a:r>
+            <a:r>
+              <a:rPr sz="1600" b="1">
+                <a:solidFill>
+                  <a:srgbClr val="0E7C7B"/>
+                </a:solidFill>
+                <a:latin typeface="Avenir Next"/>
+              </a:rPr>
+              <a:t>  ________</a:t>
+            </a:r>
+          </a:p>
+          <a:p>
+            <a:pPr algn="l">
+              <a:spcAft>
+                <a:spcPts val="600"/>
+              </a:spcAft>
+            </a:pPr>
+            <a:r>
+              <a:rPr sz="1600" b="1">
+                <a:solidFill>
+                  <a:srgbClr val="0E7C7B"/>
+                </a:solidFill>
+                <a:latin typeface="Avenir Next"/>
+              </a:rPr>
+              <a:t>(c)  </a:t>
+            </a:r>
+            <a:r>
+              <a:rPr sz="1600" b="0">
+                <a:solidFill>
+                  <a:srgbClr val="1B2025"/>
+                </a:solidFill>
+                <a:latin typeface="Avenir Next"/>
+              </a:rPr>
+              <a:t>In one line: what does that mean for how the earliest layers learn?</a:t>
             </a:r>
           </a:p>
         </p:txBody>
@@ -6927,7 +7516,7 @@
                 </a:solidFill>
                 <a:latin typeface="Menlo"/>
               </a:rPr>
-              <a:t>PART 2 · TUNING · BATCH SIZE · THE TRADE-OFF (I-DO)</a:t>
+              <a:t>PART 2 · TUNING · THE HYPERPARAMETERS</a:t>
             </a:r>
           </a:p>
         </p:txBody>
@@ -6941,7 +7530,7 @@
         <p:spPr>
           <a:xfrm>
             <a:off x="548640" y="731520"/>
-            <a:ext cx="11064240" cy="1005840"/>
+            <a:ext cx="11064240" cy="1127760"/>
           </a:xfrm>
           <a:prstGeom prst="rect">
             <a:avLst/>
@@ -6961,35 +7550,159 @@
                 </a:solidFill>
                 <a:latin typeface="Avenir Next"/>
               </a:rPr>
-              <a:t>Batch size shapes which valley you land in</a:t>
-            </a:r>
-          </a:p>
-        </p:txBody>
-      </p:sp>
-      <p:pic>
-        <p:nvPicPr>
-          <p:cNvPr id="5" name="Picture 4" descr="fig_batch_tradeoff.png"/>
-          <p:cNvPicPr>
-            <a:picLocks noChangeAspect="1"/>
-          </p:cNvPicPr>
-          <p:nvPr/>
-        </p:nvPicPr>
-        <p:blipFill>
-          <a:blip r:embed="rId3"/>
-          <a:stretch>
-            <a:fillRect/>
-          </a:stretch>
-        </p:blipFill>
-        <p:spPr>
-          <a:xfrm>
-            <a:off x="2169552" y="1828800"/>
-            <a:ext cx="7822415" cy="3383280"/>
-          </a:xfrm>
-          <a:prstGeom prst="rect">
-            <a:avLst/>
-          </a:prstGeom>
-        </p:spPr>
-      </p:pic>
+              <a:t>The knobs you set — tune the learning rate first</a:t>
+            </a:r>
+          </a:p>
+        </p:txBody>
+      </p:sp>
+      <p:sp>
+        <p:nvSpPr>
+          <p:cNvPr id="5" name="TextBox 4"/>
+          <p:cNvSpPr txBox="1"/>
+          <p:nvPr/>
+        </p:nvSpPr>
+        <p:spPr>
+          <a:xfrm>
+            <a:off x="548640" y="1920240"/>
+            <a:ext cx="10789920" cy="3794760"/>
+          </a:xfrm>
+          <a:prstGeom prst="rect">
+            <a:avLst/>
+          </a:prstGeom>
+          <a:noFill/>
+        </p:spPr>
+        <p:txBody>
+          <a:bodyPr wrap="square" anchor="t">
+            <a:spAutoFit/>
+          </a:bodyPr>
+          <a:lstStyle/>
+          <a:p>
+            <a:pPr>
+              <a:spcAft>
+                <a:spcPts val="1800"/>
+              </a:spcAft>
+            </a:pPr>
+            <a:r>
+              <a:rPr sz="2100" b="1" i="0" dirty="0">
+                <a:solidFill>
+                  <a:srgbClr val="0E7C7B"/>
+                </a:solidFill>
+                <a:latin typeface="Avenir Next"/>
+              </a:rPr>
+              <a:t>•  </a:t>
+            </a:r>
+            <a:r>
+              <a:rPr sz="2100" b="0" i="0" dirty="0">
+                <a:solidFill>
+                  <a:srgbClr val="1B2025"/>
+                </a:solidFill>
+                <a:latin typeface="Avenir Next"/>
+              </a:rPr>
+              <a:t>Hyperparameters = settings you choose BEFORE training (the weights are what training learns)</a:t>
+            </a:r>
+          </a:p>
+          <a:p>
+            <a:pPr>
+              <a:spcAft>
+                <a:spcPts val="1800"/>
+              </a:spcAft>
+            </a:pPr>
+            <a:r>
+              <a:rPr sz="2100" b="1" i="0" dirty="0">
+                <a:solidFill>
+                  <a:srgbClr val="0E7C7B"/>
+                </a:solidFill>
+                <a:latin typeface="Avenir Next"/>
+              </a:rPr>
+              <a:t>•  </a:t>
+            </a:r>
+            <a:r>
+              <a:rPr sz="2100" b="0" i="0" dirty="0">
+                <a:solidFill>
+                  <a:srgbClr val="1B2025"/>
+                </a:solidFill>
+                <a:latin typeface="Avenir Next"/>
+              </a:rPr>
+              <a:t>There are a huge number: depth · width · activation · optimizer · dropout · weight decay · schedule · batch size · epochs · …</a:t>
+            </a:r>
+          </a:p>
+          <a:p>
+            <a:pPr>
+              <a:spcAft>
+                <a:spcPts val="1800"/>
+              </a:spcAft>
+            </a:pPr>
+            <a:r>
+              <a:rPr sz="2100" b="1" i="0" dirty="0">
+                <a:solidFill>
+                  <a:srgbClr val="0E7C7B"/>
+                </a:solidFill>
+                <a:latin typeface="Avenir Next"/>
+              </a:rPr>
+              <a:t>•  </a:t>
+            </a:r>
+            <a:r>
+              <a:rPr sz="2100" b="0" i="0" dirty="0">
+                <a:solidFill>
+                  <a:srgbClr val="1B2025"/>
+                </a:solidFill>
+                <a:latin typeface="Avenir Next"/>
+              </a:rPr>
+              <a:t>1 · Learning rate — by far the most impactful (Lecture 2's three bowls)</a:t>
+            </a:r>
+          </a:p>
+          <a:p>
+            <a:pPr>
+              <a:spcAft>
+                <a:spcPts val="1800"/>
+              </a:spcAft>
+            </a:pPr>
+            <a:r>
+              <a:rPr sz="2100" b="1" i="0" dirty="0">
+                <a:solidFill>
+                  <a:srgbClr val="0E7C7B"/>
+                </a:solidFill>
+                <a:latin typeface="Avenir Next"/>
+              </a:rPr>
+              <a:t>•  </a:t>
+            </a:r>
+            <a:r>
+              <a:rPr sz="2100" b="0" i="0" dirty="0">
+                <a:solidFill>
+                  <a:srgbClr val="1B2025"/>
+                </a:solidFill>
+                <a:latin typeface="Avenir Next"/>
+              </a:rPr>
+              <a:t>2 · Batch size — memory and the trade-off, next two slides</a:t>
+            </a:r>
+          </a:p>
+          <a:p>
+            <a:pPr>
+              <a:spcAft>
+                <a:spcPts val="1800"/>
+              </a:spcAft>
+            </a:pPr>
+            <a:r>
+              <a:rPr sz="2100" b="1" i="0" dirty="0">
+                <a:solidFill>
+                  <a:srgbClr val="0E7C7B"/>
+                </a:solidFill>
+                <a:latin typeface="Avenir Next"/>
+              </a:rPr>
+              <a:t>•  </a:t>
+            </a:r>
+            <a:r>
+              <a:rPr sz="2100" b="0" i="0" dirty="0">
+                <a:solidFill>
+                  <a:srgbClr val="1B2025"/>
+                </a:solidFill>
+                <a:latin typeface="Avenir Next"/>
+              </a:rPr>
+              <a:t>3 · Model size / epochs — capacity and how long</a:t>
+            </a:r>
+          </a:p>
+        </p:txBody>
+      </p:sp>
       <p:sp>
         <p:nvSpPr>
           <p:cNvPr id="6" name="Rectangle 5"/>
@@ -6998,8 +7711,8 @@
         </p:nvSpPr>
         <p:spPr>
           <a:xfrm>
-            <a:off x="548640" y="5303520"/>
-            <a:ext cx="10515600" cy="1182624"/>
+            <a:off x="548640" y="5843016"/>
+            <a:ext cx="10515600" cy="923544"/>
           </a:xfrm>
           <a:prstGeom prst="rect">
             <a:avLst/>
@@ -7040,7 +7753,7 @@
                 </a:solidFill>
                 <a:latin typeface="Avenir Next"/>
               </a:rPr>
-              <a:t>Same loss plane, two batch sizes. SMALL batch: noisy gradient → many small, jittery steps into a wide FLAT basin that generalizes. LARGE batch: clean gradient → few big, confident steps into a narrow SHARP basin that generalizes worse. A bigger batch buys a cleaner gradient and better GPU use — but there is a too-big cost.</a:t>
+              <a:t>Get the learning rate right and half your problems disappear; everything else can start at its library default. Order of attack: learning rate → batch size → model size / epochs.</a:t>
             </a:r>
           </a:p>
         </p:txBody>
@@ -7144,7 +7857,7 @@
                 </a:solidFill>
                 <a:latin typeface="Menlo"/>
               </a:rPr>
-              <a:t>PART 2 · TUNING · YOUR TURN (YOU-DO = Q3)</a:t>
+              <a:t>PART 2 · TUNING · BATCH SIZE · THE TRADE-OFF (I-DO)</a:t>
             </a:r>
           </a:p>
         </p:txBody>
@@ -7178,14 +7891,14 @@
                 </a:solidFill>
                 <a:latin typeface="Avenir Next"/>
               </a:rPr>
-              <a:t>Two runs went wrong — diagnose the batch size</a:t>
+              <a:t>Batch size shapes which valley you land in</a:t>
             </a:r>
           </a:p>
         </p:txBody>
       </p:sp>
       <p:pic>
         <p:nvPicPr>
-          <p:cNvPr id="5" name="Picture 4" descr="fig_batch_youdo.png"/>
+          <p:cNvPr id="5" name="Picture 4" descr="fig_batch_tradeoff.png"/>
           <p:cNvPicPr>
             <a:picLocks noChangeAspect="1"/>
           </p:cNvPicPr>
@@ -7199,8 +7912,8 @@
         </p:blipFill>
         <p:spPr>
           <a:xfrm>
-            <a:off x="1699128" y="1828800"/>
-            <a:ext cx="8763263" cy="3617976"/>
+            <a:off x="2169552" y="1828800"/>
+            <a:ext cx="7822415" cy="3383280"/>
           </a:xfrm>
           <a:prstGeom prst="rect">
             <a:avLst/>
@@ -7215,7 +7928,7 @@
         </p:nvSpPr>
         <p:spPr>
           <a:xfrm>
-            <a:off x="548640" y="5538216"/>
+            <a:off x="548640" y="5303520"/>
             <a:ext cx="10515600" cy="1182624"/>
           </a:xfrm>
           <a:prstGeom prst="rect">
@@ -7226,7 +7939,7 @@
           </a:solidFill>
           <a:ln w="12700">
             <a:solidFill>
-              <a:srgbClr val="E09E2F"/>
+              <a:srgbClr val="3D444C"/>
             </a:solidFill>
           </a:ln>
           <a:effectLst/>
@@ -7251,22 +7964,13 @@
           <a:p>
             <a:pPr algn="ctr"/>
             <a:r>
-              <a:rPr sz="1200" b="1" i="0">
-                <a:solidFill>
-                  <a:srgbClr val="E09E2F"/>
-                </a:solidFill>
-                <a:latin typeface="Menlo"/>
-              </a:rPr>
-              <a:t>CHECKPOINT · </a:t>
-            </a:r>
-            <a:r>
               <a:rPr sz="1700" b="0" i="0">
                 <a:solidFill>
                   <a:srgbClr val="3D444C"/>
                 </a:solidFill>
                 <a:latin typeface="Avenir Next"/>
               </a:rPr>
-              <a:t>Your turn → Quiz 4, Q3. A colleague retrained this classifier and hit two problems: (a) batch 1024 → 'CUDA out of memory' before epoch 1; (b) batch 512 → smooth curve, but it plateaus HIGHER than batch-32 did (the picture). For each, say what it reveals about the batch and one change. Worked answer in the notes.</a:t>
+              <a:t>Same loss plane, two batch sizes. SMALL batch: noisy gradient → many small, jittery steps into a wide FLAT basin that generalizes. LARGE batch: clean gradient → few big, confident steps into a narrow SHARP basin that generalizes worse. A bigger batch buys a cleaner gradient and better GPU use — but there is a too-big cost.</a:t>
             </a:r>
           </a:p>
         </p:txBody>
@@ -7370,7 +8074,7 @@
                 </a:solidFill>
                 <a:latin typeface="Menlo"/>
               </a:rPr>
-              <a:t>PART 2 · TUNING · SEARCHING COMBINATIONS</a:t>
+              <a:t>PART 2 · TUNING · YOUR TURN (YOU-DO = Q3)</a:t>
             </a:r>
           </a:p>
         </p:txBody>
@@ -7404,14 +8108,14 @@
                 </a:solidFill>
                 <a:latin typeface="Avenir Next"/>
               </a:rPr>
-              <a:t>Grid vs. random search: random usually wins</a:t>
+              <a:t>Two runs went wrong — diagnose the batch size</a:t>
             </a:r>
           </a:p>
         </p:txBody>
       </p:sp>
       <p:pic>
         <p:nvPicPr>
-          <p:cNvPr id="5" name="Picture 4" descr="fig_search.png"/>
+          <p:cNvPr id="5" name="Picture 4" descr="fig_batch_youdo.png"/>
           <p:cNvPicPr>
             <a:picLocks noChangeAspect="1"/>
           </p:cNvPicPr>
@@ -7425,8 +8129,8 @@
         </p:blipFill>
         <p:spPr>
           <a:xfrm>
-            <a:off x="1619227" y="1828800"/>
-            <a:ext cx="8923066" cy="3358897"/>
+            <a:off x="1699128" y="1828800"/>
+            <a:ext cx="8763263" cy="3617976"/>
           </a:xfrm>
           <a:prstGeom prst="rect">
             <a:avLst/>
@@ -7441,8 +8145,8 @@
         </p:nvSpPr>
         <p:spPr>
           <a:xfrm>
-            <a:off x="548640" y="5279137"/>
-            <a:ext cx="10515600" cy="1441703"/>
+            <a:off x="548640" y="5538216"/>
+            <a:ext cx="10515600" cy="1182624"/>
           </a:xfrm>
           <a:prstGeom prst="rect">
             <a:avLst/>
@@ -7452,7 +8156,7 @@
           </a:solidFill>
           <a:ln w="12700">
             <a:solidFill>
-              <a:srgbClr val="3D444C"/>
+              <a:srgbClr val="E09E2F"/>
             </a:solidFill>
           </a:ln>
           <a:effectLst/>
@@ -7477,13 +8181,22 @@
           <a:p>
             <a:pPr algn="ctr"/>
             <a:r>
+              <a:rPr sz="1200" b="1" i="0">
+                <a:solidFill>
+                  <a:srgbClr val="E09E2F"/>
+                </a:solidFill>
+                <a:latin typeface="Menlo"/>
+              </a:rPr>
+              <a:t>CHECKPOINT · </a:t>
+            </a:r>
+            <a:r>
               <a:rPr sz="1700" b="0" i="0">
                 <a:solidFill>
                   <a:srgbClr val="3D444C"/>
                 </a:solidFill>
                 <a:latin typeface="Avenir Next"/>
               </a:rPr>
-              <a:t>Searching learning rate × batch size for a DRIAMS spectra classifier: when one knob (the learning rate) matters far more than others, random search samples many more values of it for the same budget — so it beats a rigid grid. Smarter still: Bayesian optimization (Optuna, Ray Tune) learns from your past trials and spends its budget where a good score looks most likely.</a:t>
+              <a:t>Your turn → Quiz 4, Q3. A colleague retrained this classifier and hit two problems: (a) batch 1024 → 'CUDA out of memory' before epoch 1; (b) batch 512 → smooth curve, but it plateaus HIGHER than batch-32 did (the picture). For each, say what it reveals about the batch and one change. Worked answer in the notes.</a:t>
             </a:r>
           </a:p>
         </p:txBody>
@@ -7587,7 +8300,7 @@
                 </a:solidFill>
                 <a:latin typeface="Menlo"/>
               </a:rPr>
-              <a:t>LECTURE 4 · PART 3 OF 3</a:t>
+              <a:t>PART 2 · TUNING · SEARCHING COMBINATIONS</a:t>
             </a:r>
           </a:p>
         </p:txBody>
@@ -7600,8 +8313,8 @@
         </p:nvSpPr>
         <p:spPr>
           <a:xfrm>
-            <a:off x="548640" y="2194560"/>
-            <a:ext cx="11064240" cy="2011680"/>
+            <a:off x="548640" y="731520"/>
+            <a:ext cx="11064240" cy="1005840"/>
           </a:xfrm>
           <a:prstGeom prst="rect">
             <a:avLst/>
@@ -7609,58 +8322,68 @@
           <a:noFill/>
         </p:spPr>
         <p:txBody>
-          <a:bodyPr wrap="square" anchor="ctr">
+          <a:bodyPr wrap="square" anchor="t">
             <a:spAutoFit/>
           </a:bodyPr>
           <a:lstStyle/>
           <a:p>
             <a:r>
-              <a:rPr sz="4400" b="1" i="0">
+              <a:rPr sz="3400" b="1" i="0">
                 <a:solidFill>
                   <a:srgbClr val="1B2025"/>
                 </a:solidFill>
                 <a:latin typeface="Avenir Next"/>
               </a:rPr>
-              <a:t>Overfitting vs. underfitting</a:t>
-            </a:r>
-          </a:p>
-          <a:p>
-            <a:pPr>
-              <a:spcBef>
-                <a:spcPts val="1600"/>
-              </a:spcBef>
-            </a:pPr>
-            <a:r>
-              <a:rPr sz="2200" b="0" i="0">
-                <a:solidFill>
-                  <a:srgbClr val="0E7C7B"/>
-                </a:solidFill>
-                <a:latin typeface="Avenir Next"/>
-              </a:rPr>
-              <a:t>reading train-vs-validation curves — and four ways to fix a leak</a:t>
-            </a:r>
-          </a:p>
-        </p:txBody>
-      </p:sp>
-      <p:sp>
-        <p:nvSpPr>
-          <p:cNvPr id="5" name="Rectangle 4"/>
+              <a:t>Grid vs. random search: random usually wins</a:t>
+            </a:r>
+          </a:p>
+        </p:txBody>
+      </p:sp>
+      <p:pic>
+        <p:nvPicPr>
+          <p:cNvPr id="5" name="Picture 4" descr="fig_search.png"/>
+          <p:cNvPicPr>
+            <a:picLocks noChangeAspect="1"/>
+          </p:cNvPicPr>
+          <p:nvPr/>
+        </p:nvPicPr>
+        <p:blipFill>
+          <a:blip r:embed="rId3"/>
+          <a:stretch>
+            <a:fillRect/>
+          </a:stretch>
+        </p:blipFill>
+        <p:spPr>
+          <a:xfrm>
+            <a:off x="1619227" y="1828800"/>
+            <a:ext cx="8923066" cy="3358897"/>
+          </a:xfrm>
+          <a:prstGeom prst="rect">
+            <a:avLst/>
+          </a:prstGeom>
+        </p:spPr>
+      </p:pic>
+      <p:sp>
+        <p:nvSpPr>
+          <p:cNvPr id="6" name="Rectangle 5"/>
           <p:cNvSpPr/>
           <p:nvPr/>
         </p:nvSpPr>
         <p:spPr>
           <a:xfrm>
-            <a:off x="548640" y="2057400"/>
-            <a:ext cx="1280160" cy="54864"/>
+            <a:off x="548640" y="5279137"/>
+            <a:ext cx="10515600" cy="1441703"/>
           </a:xfrm>
           <a:prstGeom prst="rect">
             <a:avLst/>
           </a:prstGeom>
           <a:solidFill>
-            <a:srgbClr val="E09E2F"/>
+            <a:srgbClr val="F1F1EC"/>
           </a:solidFill>
-          <a:ln>
-            <a:noFill/>
+          <a:ln w="12700">
+            <a:solidFill>
+              <a:srgbClr val="3D444C"/>
+            </a:solidFill>
           </a:ln>
           <a:effectLst/>
         </p:spPr>
@@ -7679,11 +8402,19 @@
           </a:fontRef>
         </p:style>
         <p:txBody>
-          <a:bodyPr rtlCol="0" anchor="ctr"/>
+          <a:bodyPr wrap="square" lIns="182880" rIns="182880" rtlCol="0" anchor="ctr"/>
           <a:lstStyle/>
           <a:p>
             <a:pPr algn="ctr"/>
-            <a:endParaRPr/>
+            <a:r>
+              <a:rPr sz="1700" b="0" i="0">
+                <a:solidFill>
+                  <a:srgbClr val="3D444C"/>
+                </a:solidFill>
+                <a:latin typeface="Avenir Next"/>
+              </a:rPr>
+              <a:t>Searching learning rate × batch size for a DRIAMS spectra classifier: when one knob (the learning rate) matters far more than others, random search samples many more values of it for the same budget — so it beats a rigid grid. Smarter still: Bayesian optimization (Optuna, Ray Tune) learns from your past trials and spends its budget where a good score looks most likely.</a:t>
+            </a:r>
           </a:p>
         </p:txBody>
       </p:sp>
@@ -7786,7 +8517,7 @@
                 </a:solidFill>
                 <a:latin typeface="Menlo"/>
               </a:rPr>
-              <a:t>PART 3 · OVERFITTING · THE PICTURE EVERYONE MEANS</a:t>
+              <a:t>LECTURE 4 · PART 3 OF 3</a:t>
             </a:r>
           </a:p>
         </p:txBody>
@@ -7799,8 +8530,8 @@
         </p:nvSpPr>
         <p:spPr>
           <a:xfrm>
-            <a:off x="548640" y="731520"/>
-            <a:ext cx="11064240" cy="1005840"/>
+            <a:off x="548640" y="2194560"/>
+            <a:ext cx="11064240" cy="2011680"/>
           </a:xfrm>
           <a:prstGeom prst="rect">
             <a:avLst/>
@@ -7808,68 +8539,58 @@
           <a:noFill/>
         </p:spPr>
         <p:txBody>
-          <a:bodyPr wrap="square" anchor="t">
+          <a:bodyPr wrap="square" anchor="ctr">
             <a:spAutoFit/>
           </a:bodyPr>
           <a:lstStyle/>
           <a:p>
             <a:r>
-              <a:rPr sz="3400" b="1" i="0">
+              <a:rPr sz="4400" b="1" i="0">
                 <a:solidFill>
                   <a:srgbClr val="1B2025"/>
                 </a:solidFill>
                 <a:latin typeface="Avenir Next"/>
               </a:rPr>
-              <a:t>Fit the trend, not the noise</a:t>
-            </a:r>
-          </a:p>
-        </p:txBody>
-      </p:sp>
-      <p:pic>
-        <p:nvPicPr>
-          <p:cNvPr id="5" name="Picture 4" descr="fig_fit_trio.png"/>
-          <p:cNvPicPr>
-            <a:picLocks noChangeAspect="1"/>
-          </p:cNvPicPr>
-          <p:nvPr/>
-        </p:nvPicPr>
-        <p:blipFill>
-          <a:blip r:embed="rId3"/>
-          <a:stretch>
-            <a:fillRect/>
-          </a:stretch>
-        </p:blipFill>
-        <p:spPr>
-          <a:xfrm>
-            <a:off x="1788760" y="1828800"/>
-            <a:ext cx="8584000" cy="3017520"/>
-          </a:xfrm>
-          <a:prstGeom prst="rect">
-            <a:avLst/>
-          </a:prstGeom>
-        </p:spPr>
-      </p:pic>
-      <p:sp>
-        <p:nvSpPr>
-          <p:cNvPr id="6" name="Rectangle 5"/>
+              <a:t>Overfitting vs. underfitting</a:t>
+            </a:r>
+          </a:p>
+          <a:p>
+            <a:pPr>
+              <a:spcBef>
+                <a:spcPts val="1600"/>
+              </a:spcBef>
+            </a:pPr>
+            <a:r>
+              <a:rPr sz="2200" b="0" i="0">
+                <a:solidFill>
+                  <a:srgbClr val="0E7C7B"/>
+                </a:solidFill>
+                <a:latin typeface="Avenir Next"/>
+              </a:rPr>
+              <a:t>reading train-vs-validation curves — and four ways to fix a leak</a:t>
+            </a:r>
+          </a:p>
+        </p:txBody>
+      </p:sp>
+      <p:sp>
+        <p:nvSpPr>
+          <p:cNvPr id="5" name="Rectangle 4"/>
           <p:cNvSpPr/>
           <p:nvPr/>
         </p:nvSpPr>
         <p:spPr>
           <a:xfrm>
-            <a:off x="548640" y="4937760"/>
-            <a:ext cx="10515600" cy="1182624"/>
+            <a:off x="548640" y="2057400"/>
+            <a:ext cx="1280160" cy="54864"/>
           </a:xfrm>
           <a:prstGeom prst="rect">
             <a:avLst/>
           </a:prstGeom>
           <a:solidFill>
-            <a:srgbClr val="F1F1EC"/>
+            <a:srgbClr val="E09E2F"/>
           </a:solidFill>
-          <a:ln w="12700">
-            <a:solidFill>
-              <a:srgbClr val="3D444C"/>
-            </a:solidFill>
+          <a:ln>
+            <a:noFill/>
           </a:ln>
           <a:effectLst/>
         </p:spPr>
@@ -7888,19 +8609,11 @@
           </a:fontRef>
         </p:style>
         <p:txBody>
-          <a:bodyPr wrap="square" lIns="182880" rIns="182880" rtlCol="0" anchor="ctr"/>
+          <a:bodyPr rtlCol="0" anchor="ctr"/>
           <a:lstStyle/>
           <a:p>
             <a:pPr algn="ctr"/>
-            <a:r>
-              <a:rPr sz="1700" b="0" i="0">
-                <a:solidFill>
-                  <a:srgbClr val="3D444C"/>
-                </a:solidFill>
-                <a:latin typeface="Avenir Next"/>
-              </a:rPr>
-              <a:t>Same seven noisy points, three models. Underfitting: a line too simple to catch the trend. Just right: a smooth curve that follows the trend and ignores the wiggle. Overfitting: a curve contorted through every point — 'perfect' on these dots, useless on the NEXT one. The goal is the trend, not a perfect score on the training dots.</a:t>
-            </a:r>
+            <a:endParaRPr/>
           </a:p>
         </p:txBody>
       </p:sp>
@@ -7931,6 +8644,51 @@
       </p:grpSpPr>
       <p:sp>
         <p:nvSpPr>
+          <p:cNvPr id="2" name="Rectangle 1"/>
+          <p:cNvSpPr/>
+          <p:nvPr/>
+        </p:nvSpPr>
+        <p:spPr>
+          <a:xfrm>
+            <a:off x="0" y="0"/>
+            <a:ext cx="12191695" cy="6858000"/>
+          </a:xfrm>
+          <a:prstGeom prst="rect">
+            <a:avLst/>
+          </a:prstGeom>
+          <a:solidFill>
+            <a:srgbClr val="FBFBF8"/>
+          </a:solidFill>
+          <a:ln>
+            <a:noFill/>
+          </a:ln>
+          <a:effectLst/>
+        </p:spPr>
+        <p:style>
+          <a:lnRef idx="1">
+            <a:schemeClr val="accent1"/>
+          </a:lnRef>
+          <a:fillRef idx="3">
+            <a:schemeClr val="accent1"/>
+          </a:fillRef>
+          <a:effectRef idx="2">
+            <a:schemeClr val="accent1"/>
+          </a:effectRef>
+          <a:fontRef idx="minor">
+            <a:schemeClr val="lt1"/>
+          </a:fontRef>
+        </p:style>
+        <p:txBody>
+          <a:bodyPr rtlCol="0" anchor="ctr"/>
+          <a:lstStyle/>
+          <a:p>
+            <a:pPr algn="ctr"/>
+            <a:endParaRPr/>
+          </a:p>
+        </p:txBody>
+      </p:sp>
+      <p:sp>
+        <p:nvSpPr>
           <p:cNvPr id="3" name="TextBox 2"/>
           <p:cNvSpPr txBox="1"/>
           <p:nvPr/>
@@ -7958,7 +8716,7 @@
                 </a:solidFill>
                 <a:latin typeface="Menlo"/>
               </a:rPr>
-              <a:t>PART 3 · OVERFITTING · READ THE TWO CURVES (I-DO)</a:t>
+              <a:t>PART 3 · OVERFITTING · THE PICTURE EVERYONE MEANS</a:t>
             </a:r>
           </a:p>
         </p:txBody>
@@ -7986,20 +8744,20 @@
           <a:lstStyle/>
           <a:p>
             <a:r>
-              <a:rPr sz="3400" b="1" i="0" dirty="0">
+              <a:rPr sz="3400" b="1" i="0">
                 <a:solidFill>
                   <a:srgbClr val="1B2025"/>
                 </a:solidFill>
                 <a:latin typeface="Avenir Next"/>
               </a:rPr>
-              <a:t>Watch training and validation loss together</a:t>
+              <a:t>Fit the trend, not the noise</a:t>
             </a:r>
           </a:p>
         </p:txBody>
       </p:sp>
       <p:pic>
         <p:nvPicPr>
-          <p:cNvPr id="5" name="Picture 4" descr="fig_trainval_ido.png"/>
+          <p:cNvPr id="5" name="Picture 4" descr="fig_fit_trio.png"/>
           <p:cNvPicPr>
             <a:picLocks noChangeAspect="1"/>
           </p:cNvPicPr>
@@ -8013,8 +8771,8 @@
         </p:blipFill>
         <p:spPr>
           <a:xfrm>
-            <a:off x="1793609" y="2337816"/>
-            <a:ext cx="8482862" cy="3017520"/>
+            <a:off x="1788760" y="1828800"/>
+            <a:ext cx="8584000" cy="3017520"/>
           </a:xfrm>
           <a:prstGeom prst="rect">
             <a:avLst/>
@@ -8029,7 +8787,7 @@
         </p:nvSpPr>
         <p:spPr>
           <a:xfrm>
-            <a:off x="548640" y="5355336"/>
+            <a:off x="548640" y="4937760"/>
             <a:ext cx="10515600" cy="1182624"/>
           </a:xfrm>
           <a:prstGeom prst="rect">
@@ -8071,42 +8829,7 @@
                 </a:solidFill>
                 <a:latin typeface="Avenir Next"/>
               </a:rPr>
-              <a:t>Always plot BOTH: training loss (solid) on data the model learns from, validation loss (dashed) on held-out data it never trains on. Underfitting: both stay HIGH. Just right: both LOW, small gap. Overfitting: training keeps dropping while validation turns back UP. The GAP between them is the tell.</a:t>
-            </a:r>
-          </a:p>
-        </p:txBody>
-      </p:sp>
-      <p:sp>
-        <p:nvSpPr>
-          <p:cNvPr id="7" name="TextBox 6">
-            <a:extLst>
-              <a:ext uri="{FF2B5EF4-FFF2-40B4-BE49-F238E27FC236}">
-                <a16:creationId xmlns:a16="http://schemas.microsoft.com/office/drawing/2014/main" id="{B099972D-57FD-F9AD-F913-8476D04D95DB}"/>
-              </a:ext>
-            </a:extLst>
-          </p:cNvPr>
-          <p:cNvSpPr txBox="1"/>
-          <p:nvPr/>
-        </p:nvSpPr>
-        <p:spPr>
-          <a:xfrm>
-            <a:off x="579120" y="1737360"/>
-            <a:ext cx="4017446" cy="400110"/>
-          </a:xfrm>
-          <a:prstGeom prst="rect">
-            <a:avLst/>
-          </a:prstGeom>
-          <a:noFill/>
-        </p:spPr>
-        <p:txBody>
-          <a:bodyPr wrap="none" rtlCol="0">
-            <a:spAutoFit/>
-          </a:bodyPr>
-          <a:lstStyle/>
-          <a:p>
-            <a:r>
-              <a:rPr lang="en-US" sz="2000" dirty="0"/>
-              <a:t>Use a held-out validation dataset</a:t>
+              <a:t>Same seven noisy points, three models. Underfitting: a line too simple to catch the trend. Just right: a smooth curve that follows the trend and ignores the wiggle. Overfitting: a curve contorted through every point — 'perfect' on these dots, useless on the NEXT one. The goal is the trend, not a perfect score on the training dots.</a:t>
             </a:r>
           </a:p>
         </p:txBody>
@@ -8138,51 +8861,6 @@
       </p:grpSpPr>
       <p:sp>
         <p:nvSpPr>
-          <p:cNvPr id="2" name="Rectangle 1"/>
-          <p:cNvSpPr/>
-          <p:nvPr/>
-        </p:nvSpPr>
-        <p:spPr>
-          <a:xfrm>
-            <a:off x="0" y="0"/>
-            <a:ext cx="12191695" cy="6858000"/>
-          </a:xfrm>
-          <a:prstGeom prst="rect">
-            <a:avLst/>
-          </a:prstGeom>
-          <a:solidFill>
-            <a:srgbClr val="FBFBF8"/>
-          </a:solidFill>
-          <a:ln>
-            <a:noFill/>
-          </a:ln>
-          <a:effectLst/>
-        </p:spPr>
-        <p:style>
-          <a:lnRef idx="1">
-            <a:schemeClr val="accent1"/>
-          </a:lnRef>
-          <a:fillRef idx="3">
-            <a:schemeClr val="accent1"/>
-          </a:fillRef>
-          <a:effectRef idx="2">
-            <a:schemeClr val="accent1"/>
-          </a:effectRef>
-          <a:fontRef idx="minor">
-            <a:schemeClr val="lt1"/>
-          </a:fontRef>
-        </p:style>
-        <p:txBody>
-          <a:bodyPr rtlCol="0" anchor="ctr"/>
-          <a:lstStyle/>
-          <a:p>
-            <a:pPr algn="ctr"/>
-            <a:endParaRPr/>
-          </a:p>
-        </p:txBody>
-      </p:sp>
-      <p:sp>
-        <p:nvSpPr>
           <p:cNvPr id="3" name="TextBox 2"/>
           <p:cNvSpPr txBox="1"/>
           <p:nvPr/>
@@ -8210,7 +8888,7 @@
                 </a:solidFill>
                 <a:latin typeface="Menlo"/>
               </a:rPr>
-              <a:t>PART 3 · OVERFITTING · YOUR TURN (YOU-DO = Q2)</a:t>
+              <a:t>PART 3 · OVERFITTING · READ THE TWO CURVES (I-DO)</a:t>
             </a:r>
           </a:p>
         </p:txBody>
@@ -8238,20 +8916,20 @@
           <a:lstStyle/>
           <a:p>
             <a:r>
-              <a:rPr sz="3400" b="1" i="0">
+              <a:rPr sz="3400" b="1" i="0" dirty="0">
                 <a:solidFill>
                   <a:srgbClr val="1B2025"/>
                 </a:solidFill>
                 <a:latin typeface="Avenir Next"/>
               </a:rPr>
-              <a:t>Diagnose four curve pairs — and name the fix</a:t>
+              <a:t>Watch training and validation loss together</a:t>
             </a:r>
           </a:p>
         </p:txBody>
       </p:sp>
       <p:pic>
         <p:nvPicPr>
-          <p:cNvPr id="5" name="Picture 4" descr="fig_trainval_youdo.png"/>
+          <p:cNvPr id="5" name="Picture 4" descr="fig_trainval_ido.png"/>
           <p:cNvPicPr>
             <a:picLocks noChangeAspect="1"/>
           </p:cNvPicPr>
@@ -8265,8 +8943,8 @@
         </p:blipFill>
         <p:spPr>
           <a:xfrm>
-            <a:off x="1604676" y="1828800"/>
-            <a:ext cx="8952167" cy="2743200"/>
+            <a:off x="1793609" y="2337816"/>
+            <a:ext cx="8482862" cy="3017520"/>
           </a:xfrm>
           <a:prstGeom prst="rect">
             <a:avLst/>
@@ -8281,8 +8959,8 @@
         </p:nvSpPr>
         <p:spPr>
           <a:xfrm>
-            <a:off x="548640" y="4663440"/>
-            <a:ext cx="10515600" cy="923544"/>
+            <a:off x="548640" y="5355336"/>
+            <a:ext cx="10515600" cy="1182624"/>
           </a:xfrm>
           <a:prstGeom prst="rect">
             <a:avLst/>
@@ -8292,7 +8970,7 @@
           </a:solidFill>
           <a:ln w="12700">
             <a:solidFill>
-              <a:srgbClr val="E09E2F"/>
+              <a:srgbClr val="3D444C"/>
             </a:solidFill>
           </a:ln>
           <a:effectLst/>
@@ -8317,36 +8995,33 @@
           <a:p>
             <a:pPr algn="ctr"/>
             <a:r>
-              <a:rPr sz="1200" b="1" i="0">
-                <a:solidFill>
-                  <a:srgbClr val="E09E2F"/>
-                </a:solidFill>
-                <a:latin typeface="Menlo"/>
-              </a:rPr>
-              <a:t>CHECKPOINT · </a:t>
-            </a:r>
-            <a:r>
               <a:rPr sz="1700" b="0" i="0">
                 <a:solidFill>
                   <a:srgbClr val="3D444C"/>
                 </a:solidFill>
                 <a:latin typeface="Avenir Next"/>
               </a:rPr>
-              <a:t>Your turn → Quiz 4, Q2. For each pair write the diagnosis and one fix (word banks on the sheet). Watch out: (d) is NOT an overfitting problem. 2–3 minutes — worked answer in the notes.</a:t>
-            </a:r>
-          </a:p>
-        </p:txBody>
-      </p:sp>
-      <p:sp>
-        <p:nvSpPr>
-          <p:cNvPr id="7" name="TextBox 6"/>
+              <a:t>Always plot BOTH: training loss (solid) on data the model learns from, validation loss (dashed) on held-out data it never trains on. Underfitting: both stay HIGH. Just right: both LOW, small gap. Overfitting: training keeps dropping while validation turns back UP. The GAP between them is the tell.</a:t>
+            </a:r>
+          </a:p>
+        </p:txBody>
+      </p:sp>
+      <p:sp>
+        <p:nvSpPr>
+          <p:cNvPr id="7" name="TextBox 6">
+            <a:extLst>
+              <a:ext uri="{FF2B5EF4-FFF2-40B4-BE49-F238E27FC236}">
+                <a16:creationId xmlns:a16="http://schemas.microsoft.com/office/drawing/2014/main" id="{B099972D-57FD-F9AD-F913-8476D04D95DB}"/>
+              </a:ext>
+            </a:extLst>
+          </p:cNvPr>
           <p:cNvSpPr txBox="1"/>
           <p:nvPr/>
         </p:nvSpPr>
         <p:spPr>
           <a:xfrm>
-            <a:off x="548640" y="5678424"/>
-            <a:ext cx="10515600" cy="820000"/>
+            <a:off x="579120" y="1737360"/>
+            <a:ext cx="4017446" cy="400110"/>
           </a:xfrm>
           <a:prstGeom prst="rect">
             <a:avLst/>
@@ -8354,58 +9029,14 @@
           <a:noFill/>
         </p:spPr>
         <p:txBody>
-          <a:bodyPr wrap="square" lIns="45720" rIns="45720" tIns="27432" bIns="27432" anchor="t">
+          <a:bodyPr wrap="none" rtlCol="0">
             <a:spAutoFit/>
           </a:bodyPr>
           <a:lstStyle/>
           <a:p>
-            <a:pPr algn="l">
-              <a:spcAft>
-                <a:spcPts val="200"/>
-              </a:spcAft>
-            </a:pPr>
-            <a:r>
-              <a:rPr sz="1200" b="1">
-                <a:solidFill>
-                  <a:srgbClr val="0E7C7B"/>
-                </a:solidFill>
-                <a:latin typeface="Avenir Next"/>
-              </a:rPr>
-              <a:t>Diagnosis bank:</a:t>
-            </a:r>
-            <a:r>
-              <a:rPr sz="1200" b="0">
-                <a:solidFill>
-                  <a:srgbClr val="3D444C"/>
-                </a:solidFill>
-                <a:latin typeface="Avenir Next"/>
-              </a:rPr>
-              <a:t>  underfitting  ·  just right  ·  overfitting  ·  learning rate far too high (diverging)</a:t>
-            </a:r>
-          </a:p>
-          <a:p>
-            <a:pPr algn="l">
-              <a:spcAft>
-                <a:spcPts val="200"/>
-              </a:spcAft>
-            </a:pPr>
-            <a:r>
-              <a:rPr sz="1200" b="1">
-                <a:solidFill>
-                  <a:srgbClr val="0E7C7B"/>
-                </a:solidFill>
-                <a:latin typeface="Avenir Next"/>
-              </a:rPr>
-              <a:t>Fix bank:</a:t>
-            </a:r>
-            <a:r>
-              <a:rPr sz="1200" b="0">
-                <a:solidFill>
-                  <a:srgbClr val="3D444C"/>
-                </a:solidFill>
-                <a:latin typeface="Avenir Next"/>
-              </a:rPr>
-              <a:t>  make the model bigger / train longer  ·  keep it (ship it)  ·  regularize (dropout / weight decay / early stopping / more data)  ·  lower the learning rate</a:t>
+            <a:r>
+              <a:rPr lang="en-US" sz="2000" dirty="0"/>
+              <a:t>Use a held-out validation dataset</a:t>
             </a:r>
           </a:p>
         </p:txBody>
@@ -8509,7 +9140,7 @@
                 </a:solidFill>
                 <a:latin typeface="Menlo"/>
               </a:rPr>
-              <a:t>PART 3 · OVERFITTING · WHAT IT MEANS IN YOUR LAB</a:t>
+              <a:t>PART 3 · OVERFITTING · YOUR TURN (YOU-DO = Q2)</a:t>
             </a:r>
           </a:p>
         </p:txBody>
@@ -8523,7 +9154,7 @@
         <p:spPr>
           <a:xfrm>
             <a:off x="548640" y="731520"/>
-            <a:ext cx="11064240" cy="1127760"/>
+            <a:ext cx="11064240" cy="1005840"/>
           </a:xfrm>
           <a:prstGeom prst="rect">
             <a:avLst/>
@@ -8543,14 +9174,14 @@
                 </a:solidFill>
                 <a:latin typeface="Avenir Next"/>
               </a:rPr>
-              <a:t>Memorizing one instrument's quirks vs. learning the chemistry</a:t>
+              <a:t>Diagnose four curve pairs — and name the fix</a:t>
             </a:r>
           </a:p>
         </p:txBody>
       </p:sp>
       <p:pic>
         <p:nvPicPr>
-          <p:cNvPr id="5" name="Picture 4" descr="maldi_tof_real.png"/>
+          <p:cNvPr id="5" name="Picture 4" descr="fig_trainval_youdo.png"/>
           <p:cNvPicPr>
             <a:picLocks noChangeAspect="1"/>
           </p:cNvPicPr>
@@ -8564,8 +9195,8 @@
         </p:blipFill>
         <p:spPr>
           <a:xfrm>
-            <a:off x="548640" y="1965960"/>
-            <a:ext cx="5394960" cy="1285798"/>
+            <a:off x="1604676" y="1828800"/>
+            <a:ext cx="8952167" cy="2743200"/>
           </a:xfrm>
           <a:prstGeom prst="rect">
             <a:avLst/>
@@ -8574,104 +9205,14 @@
       </p:pic>
       <p:sp>
         <p:nvSpPr>
-          <p:cNvPr id="6" name="TextBox 5"/>
-          <p:cNvSpPr txBox="1"/>
-          <p:nvPr/>
-        </p:nvSpPr>
-        <p:spPr>
-          <a:xfrm>
-            <a:off x="548640" y="3306622"/>
-            <a:ext cx="5394960" cy="411480"/>
-          </a:xfrm>
-          <a:prstGeom prst="rect">
-            <a:avLst/>
-          </a:prstGeom>
-          <a:noFill/>
-        </p:spPr>
-        <p:txBody>
-          <a:bodyPr wrap="square" anchor="t">
-            <a:spAutoFit/>
-          </a:bodyPr>
-          <a:lstStyle/>
-          <a:p>
-            <a:pPr algn="ctr"/>
-            <a:r>
-              <a:rPr sz="1200" b="0" i="1">
-                <a:solidFill>
-                  <a:srgbClr val="8A9099"/>
-                </a:solidFill>
-                <a:latin typeface="Avenir Next"/>
-              </a:rPr>
-              <a:t>real MALDI-TOF spectra · Martisius et al. 2020, Wikimedia Commons, CC BY 4.0</a:t>
-            </a:r>
-          </a:p>
-        </p:txBody>
-      </p:sp>
-      <p:sp>
-        <p:nvSpPr>
-          <p:cNvPr id="7" name="TextBox 6"/>
-          <p:cNvSpPr txBox="1"/>
-          <p:nvPr/>
-        </p:nvSpPr>
-        <p:spPr>
-          <a:xfrm>
-            <a:off x="6309360" y="2011680"/>
-            <a:ext cx="5394960" cy="3657600"/>
-          </a:xfrm>
-          <a:prstGeom prst="rect">
-            <a:avLst/>
-          </a:prstGeom>
-          <a:noFill/>
-        </p:spPr>
-        <p:txBody>
-          <a:bodyPr wrap="square" anchor="t">
-            <a:spAutoFit/>
-          </a:bodyPr>
-          <a:lstStyle/>
-          <a:p>
-            <a:pPr>
-              <a:spcAft>
-                <a:spcPts val="1200"/>
-              </a:spcAft>
-            </a:pPr>
-            <a:r>
-              <a:rPr sz="2100" b="0" i="0">
-                <a:solidFill>
-                  <a:srgbClr val="1B2025"/>
-                </a:solidFill>
-                <a:latin typeface="Avenir Next"/>
-              </a:rPr>
-              <a:t>An overfit spectra classifier can learn the baseline wobble and detector noise of your ONE instrument — hitting 99% in-house.</a:t>
-            </a:r>
-          </a:p>
-          <a:p>
-            <a:pPr>
-              <a:spcAft>
-                <a:spcPts val="1200"/>
-              </a:spcAft>
-            </a:pPr>
-            <a:r>
-              <a:rPr sz="2100" b="0" i="0">
-                <a:solidFill>
-                  <a:srgbClr val="1B2025"/>
-                </a:solidFill>
-                <a:latin typeface="Avenir Next"/>
-              </a:rPr>
-              <a:t>Move it to a second instrument, site, or reagent lot and it collapses: it memorized the machine, not the biology.</a:t>
-            </a:r>
-          </a:p>
-        </p:txBody>
-      </p:sp>
-      <p:sp>
-        <p:nvSpPr>
-          <p:cNvPr id="8" name="Rectangle 7"/>
+          <p:cNvPr id="6" name="Rectangle 5"/>
           <p:cNvSpPr/>
           <p:nvPr/>
         </p:nvSpPr>
         <p:spPr>
           <a:xfrm>
-            <a:off x="6309360" y="5324857"/>
-            <a:ext cx="5394960" cy="1441703"/>
+            <a:off x="548640" y="4663440"/>
+            <a:ext cx="10515600" cy="923544"/>
           </a:xfrm>
           <a:prstGeom prst="rect">
             <a:avLst/>
@@ -8712,7 +9253,7 @@
                 </a:solidFill>
                 <a:latin typeface="Menlo"/>
               </a:rPr>
-              <a:t>PAIR · </a:t>
+              <a:t>CHECKPOINT · </a:t>
             </a:r>
             <a:r>
               <a:rPr sz="1700" b="0" i="0">
@@ -8721,7 +9262,80 @@
                 </a:solidFill>
                 <a:latin typeface="Avenir Next"/>
               </a:rPr>
-              <a:t>💬 Quick show of hands (30 sec): your model scores 99% on training data but only 70% on new samples — under- or over-fitting? Shout out the FIRST fix you'd reach for.</a:t>
+              <a:t>Your turn → Quiz 4, Q2. For each pair write the diagnosis and one fix (word banks on the sheet). Watch out: (d) is NOT an overfitting problem. 2–3 minutes — worked answer in the notes.</a:t>
+            </a:r>
+          </a:p>
+        </p:txBody>
+      </p:sp>
+      <p:sp>
+        <p:nvSpPr>
+          <p:cNvPr id="7" name="TextBox 6"/>
+          <p:cNvSpPr txBox="1"/>
+          <p:nvPr/>
+        </p:nvSpPr>
+        <p:spPr>
+          <a:xfrm>
+            <a:off x="548640" y="5678424"/>
+            <a:ext cx="10515600" cy="820000"/>
+          </a:xfrm>
+          <a:prstGeom prst="rect">
+            <a:avLst/>
+          </a:prstGeom>
+          <a:noFill/>
+        </p:spPr>
+        <p:txBody>
+          <a:bodyPr wrap="square" lIns="45720" rIns="45720" tIns="27432" bIns="27432" anchor="t">
+            <a:spAutoFit/>
+          </a:bodyPr>
+          <a:lstStyle/>
+          <a:p>
+            <a:pPr algn="l">
+              <a:spcAft>
+                <a:spcPts val="200"/>
+              </a:spcAft>
+            </a:pPr>
+            <a:r>
+              <a:rPr sz="1200" b="1">
+                <a:solidFill>
+                  <a:srgbClr val="0E7C7B"/>
+                </a:solidFill>
+                <a:latin typeface="Avenir Next"/>
+              </a:rPr>
+              <a:t>Diagnosis bank:</a:t>
+            </a:r>
+            <a:r>
+              <a:rPr sz="1200" b="0">
+                <a:solidFill>
+                  <a:srgbClr val="3D444C"/>
+                </a:solidFill>
+                <a:latin typeface="Avenir Next"/>
+              </a:rPr>
+              <a:t>  underfitting  ·  just right  ·  overfitting  ·  learning rate far too high (diverging)</a:t>
+            </a:r>
+          </a:p>
+          <a:p>
+            <a:pPr algn="l">
+              <a:spcAft>
+                <a:spcPts val="200"/>
+              </a:spcAft>
+            </a:pPr>
+            <a:r>
+              <a:rPr sz="1200" b="1">
+                <a:solidFill>
+                  <a:srgbClr val="0E7C7B"/>
+                </a:solidFill>
+                <a:latin typeface="Avenir Next"/>
+              </a:rPr>
+              <a:t>Fix bank:</a:t>
+            </a:r>
+            <a:r>
+              <a:rPr sz="1200" b="0">
+                <a:solidFill>
+                  <a:srgbClr val="3D444C"/>
+                </a:solidFill>
+                <a:latin typeface="Avenir Next"/>
+              </a:rPr>
+              <a:t>  make the model bigger / train longer  ·  keep it (ship it)  ·  regularize (dropout / weight decay / early stopping / more data)  ·  lower the learning rate</a:t>
             </a:r>
           </a:p>
         </p:txBody>
@@ -8825,7 +9439,7 @@
                 </a:solidFill>
                 <a:latin typeface="Menlo"/>
               </a:rPr>
-              <a:t>PART 3 · OVERFITTING · FIXES 1 &amp; 2</a:t>
+              <a:t>PART 3 · OVERFITTING · WHAT IT MEANS IN YOUR LAB</a:t>
             </a:r>
           </a:p>
         </p:txBody>
@@ -8839,7 +9453,7 @@
         <p:spPr>
           <a:xfrm>
             <a:off x="548640" y="731520"/>
-            <a:ext cx="11064240" cy="1005840"/>
+            <a:ext cx="11064240" cy="1127760"/>
           </a:xfrm>
           <a:prstGeom prst="rect">
             <a:avLst/>
@@ -8859,14 +9473,14 @@
                 </a:solidFill>
                 <a:latin typeface="Avenir Next"/>
               </a:rPr>
-              <a:t>More data · and early stopping</a:t>
+              <a:t>Memorizing one instrument's quirks vs. learning the chemistry</a:t>
             </a:r>
           </a:p>
         </p:txBody>
       </p:sp>
       <p:pic>
         <p:nvPicPr>
-          <p:cNvPr id="5" name="Picture 4" descr="fig_early_stopping.png"/>
+          <p:cNvPr id="5" name="Picture 4" descr="maldi_tof_real.png"/>
           <p:cNvPicPr>
             <a:picLocks noChangeAspect="1"/>
           </p:cNvPicPr>
@@ -8880,8 +9494,8 @@
         </p:blipFill>
         <p:spPr>
           <a:xfrm>
-            <a:off x="2300599" y="1828800"/>
-            <a:ext cx="7560322" cy="3617976"/>
+            <a:off x="548640" y="1965960"/>
+            <a:ext cx="5394960" cy="1285798"/>
           </a:xfrm>
           <a:prstGeom prst="rect">
             <a:avLst/>
@@ -8890,14 +9504,104 @@
       </p:pic>
       <p:sp>
         <p:nvSpPr>
-          <p:cNvPr id="6" name="Rectangle 5"/>
+          <p:cNvPr id="6" name="TextBox 5"/>
+          <p:cNvSpPr txBox="1"/>
+          <p:nvPr/>
+        </p:nvSpPr>
+        <p:spPr>
+          <a:xfrm>
+            <a:off x="548640" y="3306622"/>
+            <a:ext cx="5394960" cy="411480"/>
+          </a:xfrm>
+          <a:prstGeom prst="rect">
+            <a:avLst/>
+          </a:prstGeom>
+          <a:noFill/>
+        </p:spPr>
+        <p:txBody>
+          <a:bodyPr wrap="square" anchor="t">
+            <a:spAutoFit/>
+          </a:bodyPr>
+          <a:lstStyle/>
+          <a:p>
+            <a:pPr algn="ctr"/>
+            <a:r>
+              <a:rPr sz="1200" b="0" i="1">
+                <a:solidFill>
+                  <a:srgbClr val="8A9099"/>
+                </a:solidFill>
+                <a:latin typeface="Avenir Next"/>
+              </a:rPr>
+              <a:t>real MALDI-TOF spectra · Martisius et al. 2020, Wikimedia Commons, CC BY 4.0</a:t>
+            </a:r>
+          </a:p>
+        </p:txBody>
+      </p:sp>
+      <p:sp>
+        <p:nvSpPr>
+          <p:cNvPr id="7" name="TextBox 6"/>
+          <p:cNvSpPr txBox="1"/>
+          <p:nvPr/>
+        </p:nvSpPr>
+        <p:spPr>
+          <a:xfrm>
+            <a:off x="6309360" y="2011680"/>
+            <a:ext cx="5394960" cy="3657600"/>
+          </a:xfrm>
+          <a:prstGeom prst="rect">
+            <a:avLst/>
+          </a:prstGeom>
+          <a:noFill/>
+        </p:spPr>
+        <p:txBody>
+          <a:bodyPr wrap="square" anchor="t">
+            <a:spAutoFit/>
+          </a:bodyPr>
+          <a:lstStyle/>
+          <a:p>
+            <a:pPr>
+              <a:spcAft>
+                <a:spcPts val="1200"/>
+              </a:spcAft>
+            </a:pPr>
+            <a:r>
+              <a:rPr sz="2100" b="0" i="0">
+                <a:solidFill>
+                  <a:srgbClr val="1B2025"/>
+                </a:solidFill>
+                <a:latin typeface="Avenir Next"/>
+              </a:rPr>
+              <a:t>An overfit spectra classifier can learn the baseline wobble and detector noise of your ONE instrument — hitting 99% in-house.</a:t>
+            </a:r>
+          </a:p>
+          <a:p>
+            <a:pPr>
+              <a:spcAft>
+                <a:spcPts val="1200"/>
+              </a:spcAft>
+            </a:pPr>
+            <a:r>
+              <a:rPr sz="2100" b="0" i="0">
+                <a:solidFill>
+                  <a:srgbClr val="1B2025"/>
+                </a:solidFill>
+                <a:latin typeface="Avenir Next"/>
+              </a:rPr>
+              <a:t>Move it to a second instrument, site, or reagent lot and it collapses: it memorized the machine, not the biology.</a:t>
+            </a:r>
+          </a:p>
+        </p:txBody>
+      </p:sp>
+      <p:sp>
+        <p:nvSpPr>
+          <p:cNvPr id="8" name="Rectangle 7"/>
           <p:cNvSpPr/>
           <p:nvPr/>
         </p:nvSpPr>
         <p:spPr>
           <a:xfrm>
-            <a:off x="548640" y="5538216"/>
-            <a:ext cx="10515600" cy="1182624"/>
+            <a:off x="6309360" y="5324857"/>
+            <a:ext cx="5394960" cy="1441703"/>
           </a:xfrm>
           <a:prstGeom prst="rect">
             <a:avLst/>
@@ -8907,7 +9611,7 @@
           </a:solidFill>
           <a:ln w="12700">
             <a:solidFill>
-              <a:srgbClr val="3D444C"/>
+              <a:srgbClr val="E09E2F"/>
             </a:solidFill>
           </a:ln>
           <a:effectLst/>
@@ -8932,13 +9636,22 @@
           <a:p>
             <a:pPr algn="ctr"/>
             <a:r>
+              <a:rPr sz="1200" b="1" i="0">
+                <a:solidFill>
+                  <a:srgbClr val="E09E2F"/>
+                </a:solidFill>
+                <a:latin typeface="Menlo"/>
+              </a:rPr>
+              <a:t>PAIR · </a:t>
+            </a:r>
+            <a:r>
               <a:rPr sz="1700" b="0" i="0">
                 <a:solidFill>
                   <a:srgbClr val="3D444C"/>
                 </a:solidFill>
                 <a:latin typeface="Avenir Next"/>
               </a:rPr>
-              <a:t>More (and more VARIED) data is the strongest fix — harder to memorize, easier to find the real pattern; spectra from several instruments beats many from one. Early stopping: watch validation loss and keep the model from its lowest point, before it turns back up. Free, and always worth doing.</a:t>
+              <a:t>💬 Quick show of hands (30 sec): your model scores 99% on training data but only 70% on new samples — under- or over-fitting? Shout out the FIRST fix you'd reach for.</a:t>
             </a:r>
           </a:p>
         </p:txBody>
@@ -9241,7 +9954,7 @@
                 </a:solidFill>
                 <a:latin typeface="Menlo"/>
               </a:rPr>
-              <a:t>PART 3 · OVERFITTING · FIX 3 · REGULARIZATION</a:t>
+              <a:t>PART 3 · OVERFITTING · FIXES 1 &amp; 2</a:t>
             </a:r>
           </a:p>
         </p:txBody>
@@ -9255,7 +9968,7 @@
         <p:spPr>
           <a:xfrm>
             <a:off x="548640" y="731520"/>
-            <a:ext cx="11064240" cy="1127760"/>
+            <a:ext cx="11064240" cy="1005840"/>
           </a:xfrm>
           <a:prstGeom prst="rect">
             <a:avLst/>
@@ -9275,14 +9988,14 @@
                 </a:solidFill>
                 <a:latin typeface="Avenir Next"/>
               </a:rPr>
-              <a:t>Dropout: randomly switch off neurons each step</a:t>
+              <a:t>More data · and early stopping</a:t>
             </a:r>
           </a:p>
         </p:txBody>
       </p:sp>
       <p:pic>
         <p:nvPicPr>
-          <p:cNvPr id="5" name="Picture 4" descr="fig_dropout.png"/>
+          <p:cNvPr id="5" name="Picture 4" descr="fig_early_stopping.png"/>
           <p:cNvPicPr>
             <a:picLocks noChangeAspect="1"/>
           </p:cNvPicPr>
@@ -9296,8 +10009,8 @@
         </p:blipFill>
         <p:spPr>
           <a:xfrm>
-            <a:off x="1189319" y="1828800"/>
-            <a:ext cx="9782882" cy="3200400"/>
+            <a:off x="2300599" y="1828800"/>
+            <a:ext cx="7560322" cy="3617976"/>
           </a:xfrm>
           <a:prstGeom prst="rect">
             <a:avLst/>
@@ -9312,7 +10025,7 @@
         </p:nvSpPr>
         <p:spPr>
           <a:xfrm>
-            <a:off x="548640" y="5120640"/>
+            <a:off x="548640" y="5538216"/>
             <a:ext cx="10515600" cy="1182624"/>
           </a:xfrm>
           <a:prstGeom prst="rect">
@@ -9354,7 +10067,7 @@
                 </a:solidFill>
                 <a:latin typeface="Avenir Next"/>
               </a:rPr>
-              <a:t>On every training step, dropout zeroes a random ~half of the hidden neurons — and a DIFFERENT set each step. The net can't lean on any one neuron, so it builds redundant, robust features (like a committee that votes). At test time all neurons are back on. One line in PyTorch: nn.Dropout(0.5).</a:t>
+              <a:t>More (and more VARIED) data is the strongest fix — harder to memorize, easier to find the real pattern; spectra from several instruments beats many from one. Early stopping: watch validation loss and keep the model from its lowest point, before it turns back up. Free, and always worth doing.</a:t>
             </a:r>
           </a:p>
         </p:txBody>
@@ -9458,7 +10171,7 @@
                 </a:solidFill>
                 <a:latin typeface="Menlo"/>
               </a:rPr>
-              <a:t>PART 3 · OVERFITTING · FIX 4 · REGULARIZATION</a:t>
+              <a:t>PART 3 · OVERFITTING · FIX 3 · REGULARIZATION</a:t>
             </a:r>
           </a:p>
         </p:txBody>
@@ -9472,7 +10185,7 @@
         <p:spPr>
           <a:xfrm>
             <a:off x="548640" y="731520"/>
-            <a:ext cx="11064240" cy="1005840"/>
+            <a:ext cx="11064240" cy="1127760"/>
           </a:xfrm>
           <a:prstGeom prst="rect">
             <a:avLst/>
@@ -9492,14 +10205,14 @@
                 </a:solidFill>
                 <a:latin typeface="Avenir Next"/>
               </a:rPr>
-              <a:t>L2 regularization = weight decay</a:t>
+              <a:t>Dropout: randomly switch off neurons each step</a:t>
             </a:r>
           </a:p>
         </p:txBody>
       </p:sp>
       <p:pic>
         <p:nvPicPr>
-          <p:cNvPr id="5" name="Picture 4" descr="fig_weight_decay.png"/>
+          <p:cNvPr id="5" name="Picture 4" descr="fig_dropout.png"/>
           <p:cNvPicPr>
             <a:picLocks noChangeAspect="1"/>
           </p:cNvPicPr>
@@ -9513,8 +10226,8 @@
         </p:blipFill>
         <p:spPr>
           <a:xfrm>
-            <a:off x="1384156" y="1828800"/>
-            <a:ext cx="9393207" cy="3200400"/>
+            <a:off x="1189319" y="1828800"/>
+            <a:ext cx="9782882" cy="3200400"/>
           </a:xfrm>
           <a:prstGeom prst="rect">
             <a:avLst/>
@@ -9530,17 +10243,17 @@
         <p:spPr>
           <a:xfrm>
             <a:off x="548640" y="5120640"/>
-            <a:ext cx="10515600" cy="1441703"/>
+            <a:ext cx="10515600" cy="1182624"/>
           </a:xfrm>
           <a:prstGeom prst="rect">
             <a:avLst/>
           </a:prstGeom>
           <a:solidFill>
-            <a:srgbClr val="E3F0EF"/>
+            <a:srgbClr val="F1F1EC"/>
           </a:solidFill>
           <a:ln w="12700">
             <a:solidFill>
-              <a:srgbClr val="0E7C7B"/>
+              <a:srgbClr val="3D444C"/>
             </a:solidFill>
           </a:ln>
           <a:effectLst/>
@@ -9565,13 +10278,13 @@
           <a:p>
             <a:pPr algn="ctr"/>
             <a:r>
-              <a:rPr sz="1700" b="0" i="0" dirty="0">
+              <a:rPr sz="1700" b="0" i="0">
                 <a:solidFill>
                   <a:srgbClr val="3D444C"/>
                 </a:solidFill>
                 <a:latin typeface="Avenir Next"/>
               </a:rPr>
-              <a:t>Big weights let the curve bend sharply enough to thread every noisy point — the output becomes the noise. Add λ·Σw² to the loss so every step also nudges weights toward 0 ('weight decay'): the curve can only track the trend. A spectra net then spreads reliance across many m/z channels instead of pinning one huge weight on a fluke.</a:t>
+              <a:t>On every training step, dropout zeroes a random ~half of the hidden neurons — and a DIFFERENT set each step. The net can't lean on any one neuron, so it builds redundant, robust features (like a committee that votes). At test time all neurons are back on. One line in PyTorch: nn.Dropout(0.5).</a:t>
             </a:r>
           </a:p>
         </p:txBody>
@@ -9655,7 +10368,7 @@
         <p:spPr>
           <a:xfrm>
             <a:off x="548640" y="320040"/>
-            <a:ext cx="10972800" cy="292388"/>
+            <a:ext cx="10972800" cy="365760"/>
           </a:xfrm>
           <a:prstGeom prst="rect">
             <a:avLst/>
@@ -9669,31 +10382,13 @@
           <a:lstStyle/>
           <a:p>
             <a:r>
-              <a:rPr sz="1300" b="1" i="0" dirty="0">
+              <a:rPr sz="1300" b="1" i="0">
                 <a:solidFill>
                   <a:srgbClr val="8A9099"/>
                 </a:solidFill>
                 <a:latin typeface="Menlo"/>
               </a:rPr>
-              <a:t>PART 3 · </a:t>
-            </a:r>
-            <a:r>
-              <a:rPr lang="en-US" sz="1300" b="1" i="0" dirty="0">
-                <a:solidFill>
-                  <a:srgbClr val="8A9099"/>
-                </a:solidFill>
-                <a:latin typeface="Menlo"/>
-              </a:rPr>
-              <a:t>FORESHADOW</a:t>
-            </a:r>
-            <a:r>
-              <a:rPr sz="1300" b="1" i="0" dirty="0">
-                <a:solidFill>
-                  <a:srgbClr val="8A9099"/>
-                </a:solidFill>
-                <a:latin typeface="Menlo"/>
-              </a:rPr>
-              <a:t> · A RARE BUT CRITICAL CLASS (PAIR = Q5)</a:t>
+              <a:t>PART 3 · OVERFITTING · FIX 4 · REGULARIZATION</a:t>
             </a:r>
           </a:p>
         </p:txBody>
@@ -9707,7 +10402,7 @@
         <p:spPr>
           <a:xfrm>
             <a:off x="548640" y="731520"/>
-            <a:ext cx="11064240" cy="1127760"/>
+            <a:ext cx="11064240" cy="1005840"/>
           </a:xfrm>
           <a:prstGeom prst="rect">
             <a:avLst/>
@@ -9727,14 +10422,14 @@
                 </a:solidFill>
                 <a:latin typeface="Avenir Next"/>
               </a:rPr>
-              <a:t>When plain accuracy lies: the rare resistant isolate</a:t>
+              <a:t>L2 regularization = weight decay</a:t>
             </a:r>
           </a:p>
         </p:txBody>
       </p:sp>
       <p:pic>
         <p:nvPicPr>
-          <p:cNvPr id="5" name="Picture 4" descr="fig_imbalance.png"/>
+          <p:cNvPr id="5" name="Picture 4" descr="fig_weight_decay.png"/>
           <p:cNvPicPr>
             <a:picLocks noChangeAspect="1"/>
           </p:cNvPicPr>
@@ -9748,8 +10443,8 @@
         </p:blipFill>
         <p:spPr>
           <a:xfrm>
-            <a:off x="2296045" y="1828800"/>
-            <a:ext cx="7569429" cy="3358897"/>
+            <a:off x="1384156" y="1828800"/>
+            <a:ext cx="9393207" cy="3200400"/>
           </a:xfrm>
           <a:prstGeom prst="rect">
             <a:avLst/>
@@ -9764,18 +10459,18 @@
         </p:nvSpPr>
         <p:spPr>
           <a:xfrm>
-            <a:off x="548640" y="5279137"/>
+            <a:off x="548640" y="5120640"/>
             <a:ext cx="10515600" cy="1441703"/>
           </a:xfrm>
           <a:prstGeom prst="rect">
             <a:avLst/>
           </a:prstGeom>
           <a:solidFill>
-            <a:srgbClr val="F1F1EC"/>
+            <a:srgbClr val="E3F0EF"/>
           </a:solidFill>
           <a:ln w="12700">
             <a:solidFill>
-              <a:srgbClr val="E09E2F"/>
+              <a:srgbClr val="0E7C7B"/>
             </a:solidFill>
           </a:ln>
           <a:effectLst/>
@@ -9800,22 +10495,13 @@
           <a:p>
             <a:pPr algn="ctr"/>
             <a:r>
-              <a:rPr sz="1200" b="1" i="0">
-                <a:solidFill>
-                  <a:srgbClr val="E09E2F"/>
-                </a:solidFill>
-                <a:latin typeface="Menlo"/>
-              </a:rPr>
-              <a:t>PAIR · </a:t>
-            </a:r>
-            <a:r>
-              <a:rPr sz="1700" b="0" i="0">
+              <a:rPr sz="1700" b="0" i="0" dirty="0">
                 <a:solidFill>
                   <a:srgbClr val="3D444C"/>
                 </a:solidFill>
                 <a:latin typeface="Avenir Next"/>
               </a:rPr>
-              <a:t>Pair → Quiz 4, Q5. DRIAMS S. aureus + oxacillin: 41 R among 738; a classifier reports 94% accuracy. (a) Why is 94% misleading, and what would you look at instead? (b) You CAN'T collect more R this cycle — of oversample-R / undersample-S / class-weight / lower-threshold, which help, and what can NONE of them fix? Worked answer in the notes.</a:t>
+              <a:t>Big weights let the curve bend sharply enough to thread every noisy point — the output becomes the noise. Add λ·Σw² to the loss so every step also nudges weights toward 0 ('weight decay'): the curve can only track the trend. A spectra net then spreads reliance across many m/z channels instead of pinning one huge weight on a fluke.</a:t>
             </a:r>
           </a:p>
         </p:txBody>
@@ -9899,6 +10585,250 @@
         <p:spPr>
           <a:xfrm>
             <a:off x="548640" y="320040"/>
+            <a:ext cx="10972800" cy="292388"/>
+          </a:xfrm>
+          <a:prstGeom prst="rect">
+            <a:avLst/>
+          </a:prstGeom>
+          <a:noFill/>
+        </p:spPr>
+        <p:txBody>
+          <a:bodyPr wrap="square" anchor="t">
+            <a:spAutoFit/>
+          </a:bodyPr>
+          <a:lstStyle/>
+          <a:p>
+            <a:r>
+              <a:rPr sz="1300" b="1" i="0" dirty="0">
+                <a:solidFill>
+                  <a:srgbClr val="8A9099"/>
+                </a:solidFill>
+                <a:latin typeface="Menlo"/>
+              </a:rPr>
+              <a:t>PART 3 · </a:t>
+            </a:r>
+            <a:r>
+              <a:rPr lang="en-US" sz="1300" b="1" i="0" dirty="0">
+                <a:solidFill>
+                  <a:srgbClr val="8A9099"/>
+                </a:solidFill>
+                <a:latin typeface="Menlo"/>
+              </a:rPr>
+              <a:t>FORESHADOW</a:t>
+            </a:r>
+            <a:r>
+              <a:rPr sz="1300" b="1" i="0" dirty="0">
+                <a:solidFill>
+                  <a:srgbClr val="8A9099"/>
+                </a:solidFill>
+                <a:latin typeface="Menlo"/>
+              </a:rPr>
+              <a:t> · A RARE BUT CRITICAL CLASS (PAIR = Q5)</a:t>
+            </a:r>
+          </a:p>
+        </p:txBody>
+      </p:sp>
+      <p:sp>
+        <p:nvSpPr>
+          <p:cNvPr id="4" name="TextBox 3"/>
+          <p:cNvSpPr txBox="1"/>
+          <p:nvPr/>
+        </p:nvSpPr>
+        <p:spPr>
+          <a:xfrm>
+            <a:off x="548640" y="731520"/>
+            <a:ext cx="11064240" cy="1127760"/>
+          </a:xfrm>
+          <a:prstGeom prst="rect">
+            <a:avLst/>
+          </a:prstGeom>
+          <a:noFill/>
+        </p:spPr>
+        <p:txBody>
+          <a:bodyPr wrap="square" anchor="t">
+            <a:spAutoFit/>
+          </a:bodyPr>
+          <a:lstStyle/>
+          <a:p>
+            <a:r>
+              <a:rPr sz="3400" b="1" i="0">
+                <a:solidFill>
+                  <a:srgbClr val="1B2025"/>
+                </a:solidFill>
+                <a:latin typeface="Avenir Next"/>
+              </a:rPr>
+              <a:t>When plain accuracy lies: the rare resistant isolate</a:t>
+            </a:r>
+          </a:p>
+        </p:txBody>
+      </p:sp>
+      <p:pic>
+        <p:nvPicPr>
+          <p:cNvPr id="5" name="Picture 4" descr="fig_imbalance.png"/>
+          <p:cNvPicPr>
+            <a:picLocks noChangeAspect="1"/>
+          </p:cNvPicPr>
+          <p:nvPr/>
+        </p:nvPicPr>
+        <p:blipFill>
+          <a:blip r:embed="rId3"/>
+          <a:stretch>
+            <a:fillRect/>
+          </a:stretch>
+        </p:blipFill>
+        <p:spPr>
+          <a:xfrm>
+            <a:off x="2296045" y="1828800"/>
+            <a:ext cx="7569429" cy="3358897"/>
+          </a:xfrm>
+          <a:prstGeom prst="rect">
+            <a:avLst/>
+          </a:prstGeom>
+        </p:spPr>
+      </p:pic>
+      <p:sp>
+        <p:nvSpPr>
+          <p:cNvPr id="6" name="Rectangle 5"/>
+          <p:cNvSpPr/>
+          <p:nvPr/>
+        </p:nvSpPr>
+        <p:spPr>
+          <a:xfrm>
+            <a:off x="548640" y="5279137"/>
+            <a:ext cx="10515600" cy="1441703"/>
+          </a:xfrm>
+          <a:prstGeom prst="rect">
+            <a:avLst/>
+          </a:prstGeom>
+          <a:solidFill>
+            <a:srgbClr val="F1F1EC"/>
+          </a:solidFill>
+          <a:ln w="12700">
+            <a:solidFill>
+              <a:srgbClr val="E09E2F"/>
+            </a:solidFill>
+          </a:ln>
+          <a:effectLst/>
+        </p:spPr>
+        <p:style>
+          <a:lnRef idx="1">
+            <a:schemeClr val="accent1"/>
+          </a:lnRef>
+          <a:fillRef idx="3">
+            <a:schemeClr val="accent1"/>
+          </a:fillRef>
+          <a:effectRef idx="2">
+            <a:schemeClr val="accent1"/>
+          </a:effectRef>
+          <a:fontRef idx="minor">
+            <a:schemeClr val="lt1"/>
+          </a:fontRef>
+        </p:style>
+        <p:txBody>
+          <a:bodyPr wrap="square" lIns="182880" rIns="182880" rtlCol="0" anchor="ctr"/>
+          <a:lstStyle/>
+          <a:p>
+            <a:pPr algn="ctr"/>
+            <a:r>
+              <a:rPr sz="1200" b="1" i="0">
+                <a:solidFill>
+                  <a:srgbClr val="E09E2F"/>
+                </a:solidFill>
+                <a:latin typeface="Menlo"/>
+              </a:rPr>
+              <a:t>PAIR · </a:t>
+            </a:r>
+            <a:r>
+              <a:rPr sz="1700" b="0" i="0">
+                <a:solidFill>
+                  <a:srgbClr val="3D444C"/>
+                </a:solidFill>
+                <a:latin typeface="Avenir Next"/>
+              </a:rPr>
+              <a:t>Pair → Quiz 4, Q5. DRIAMS S. aureus + oxacillin: 41 R among 738; a classifier reports 94% accuracy. (a) Why is 94% misleading, and what would you look at instead? (b) You CAN'T collect more R this cycle — of oversample-R / undersample-S / class-weight / lower-threshold, which help, and what can NONE of them fix? Worked answer in the notes.</a:t>
+            </a:r>
+          </a:p>
+        </p:txBody>
+      </p:sp>
+    </p:spTree>
+  </p:cSld>
+  <p:clrMapOvr>
+    <a:masterClrMapping/>
+  </p:clrMapOvr>
+</p:sld>
+</file>
+
+<file path=ppt/slides/slide34.xml><?xml version="1.0" encoding="utf-8"?>
+<p:sld xmlns:a="http://schemas.openxmlformats.org/drawingml/2006/main" xmlns:r="http://schemas.openxmlformats.org/officeDocument/2006/relationships" xmlns:p="http://schemas.openxmlformats.org/presentationml/2006/main">
+  <p:cSld>
+    <p:spTree>
+      <p:nvGrpSpPr>
+        <p:cNvPr id="1" name=""/>
+        <p:cNvGrpSpPr/>
+        <p:nvPr/>
+      </p:nvGrpSpPr>
+      <p:grpSpPr>
+        <a:xfrm>
+          <a:off x="0" y="0"/>
+          <a:ext cx="0" cy="0"/>
+          <a:chOff x="0" y="0"/>
+          <a:chExt cx="0" cy="0"/>
+        </a:xfrm>
+      </p:grpSpPr>
+      <p:sp>
+        <p:nvSpPr>
+          <p:cNvPr id="2" name="Rectangle 1"/>
+          <p:cNvSpPr/>
+          <p:nvPr/>
+        </p:nvSpPr>
+        <p:spPr>
+          <a:xfrm>
+            <a:off x="0" y="0"/>
+            <a:ext cx="12191695" cy="6858000"/>
+          </a:xfrm>
+          <a:prstGeom prst="rect">
+            <a:avLst/>
+          </a:prstGeom>
+          <a:solidFill>
+            <a:srgbClr val="FBFBF8"/>
+          </a:solidFill>
+          <a:ln>
+            <a:noFill/>
+          </a:ln>
+          <a:effectLst/>
+        </p:spPr>
+        <p:style>
+          <a:lnRef idx="1">
+            <a:schemeClr val="accent1"/>
+          </a:lnRef>
+          <a:fillRef idx="3">
+            <a:schemeClr val="accent1"/>
+          </a:fillRef>
+          <a:effectRef idx="2">
+            <a:schemeClr val="accent1"/>
+          </a:effectRef>
+          <a:fontRef idx="minor">
+            <a:schemeClr val="lt1"/>
+          </a:fontRef>
+        </p:style>
+        <p:txBody>
+          <a:bodyPr rtlCol="0" anchor="ctr"/>
+          <a:lstStyle/>
+          <a:p>
+            <a:pPr algn="ctr"/>
+            <a:endParaRPr/>
+          </a:p>
+        </p:txBody>
+      </p:sp>
+      <p:sp>
+        <p:nvSpPr>
+          <p:cNvPr id="3" name="TextBox 2"/>
+          <p:cNvSpPr txBox="1"/>
+          <p:nvPr/>
+        </p:nvSpPr>
+        <p:spPr>
+          <a:xfrm>
+            <a:off x="548640" y="320040"/>
             <a:ext cx="10972800" cy="365760"/>
           </a:xfrm>
           <a:prstGeom prst="rect">
@@ -10132,936 +11062,6 @@
                 <a:latin typeface="Avenir Next"/>
               </a:rPr>
               <a:t>Everything today serves one idea: fit the data + don't memorize it. If you can read a validation curve and name a fix, you can do every item on Quiz 4.</a:t>
-            </a:r>
-          </a:p>
-        </p:txBody>
-      </p:sp>
-    </p:spTree>
-  </p:cSld>
-  <p:clrMapOvr>
-    <a:masterClrMapping/>
-  </p:clrMapOvr>
-</p:sld>
-</file>
-
-<file path=ppt/slides/slide34.xml><?xml version="1.0" encoding="utf-8"?>
-<p:sld xmlns:a="http://schemas.openxmlformats.org/drawingml/2006/main" xmlns:p="http://schemas.openxmlformats.org/presentationml/2006/main" xmlns:r="http://schemas.openxmlformats.org/officeDocument/2006/relationships">
-  <p:cSld>
-    <p:spTree>
-      <p:nvGrpSpPr>
-        <p:cNvPr id="1" name=""/>
-        <p:cNvGrpSpPr/>
-        <p:nvPr/>
-      </p:nvGrpSpPr>
-      <p:grpSpPr/>
-      <p:sp>
-        <p:nvSpPr>
-          <p:cNvPr id="2" name="Rectangle 1"/>
-          <p:cNvSpPr/>
-          <p:nvPr/>
-        </p:nvSpPr>
-        <p:spPr>
-          <a:xfrm>
-            <a:off x="0" y="0"/>
-            <a:ext cx="12191695" cy="6858000"/>
-          </a:xfrm>
-          <a:prstGeom prst="rect">
-            <a:avLst/>
-          </a:prstGeom>
-          <a:solidFill>
-            <a:srgbClr val="FBFBF8"/>
-          </a:solidFill>
-          <a:ln>
-            <a:noFill/>
-          </a:ln>
-          <a:effectLst/>
-        </p:spPr>
-        <p:style>
-          <a:lnRef idx="1">
-            <a:schemeClr val="accent1"/>
-          </a:lnRef>
-          <a:fillRef idx="3">
-            <a:schemeClr val="accent1"/>
-          </a:fillRef>
-          <a:effectRef idx="2">
-            <a:schemeClr val="accent1"/>
-          </a:effectRef>
-          <a:fontRef idx="minor">
-            <a:schemeClr val="lt1"/>
-          </a:fontRef>
-        </p:style>
-        <p:txBody>
-          <a:bodyPr rtlCol="0" anchor="ctr"/>
-          <a:lstStyle/>
-          <a:p>
-            <a:pPr algn="ctr"/>
-            <a:endParaRPr/>
-          </a:p>
-        </p:txBody>
-      </p:sp>
-      <p:sp>
-        <p:nvSpPr>
-          <p:cNvPr id="3" name="TextBox 2"/>
-          <p:cNvSpPr txBox="1"/>
-          <p:nvPr/>
-        </p:nvSpPr>
-        <p:spPr>
-          <a:xfrm>
-            <a:off x="548640" y="320040"/>
-            <a:ext cx="10972800" cy="365760"/>
-          </a:xfrm>
-          <a:prstGeom prst="rect">
-            <a:avLst/>
-          </a:prstGeom>
-          <a:noFill/>
-        </p:spPr>
-        <p:txBody>
-          <a:bodyPr wrap="square" anchor="t">
-            <a:spAutoFit/>
-          </a:bodyPr>
-          <a:lstStyle/>
-          <a:p>
-            <a:r>
-              <a:rPr sz="1300" b="1" i="0">
-                <a:solidFill>
-                  <a:srgbClr val="8A9099"/>
-                </a:solidFill>
-                <a:latin typeface="Menlo"/>
-              </a:rPr>
-              <a:t>PART 2 · TUNING · YOUR TURN (YOU-DO = Q4)</a:t>
-            </a:r>
-          </a:p>
-        </p:txBody>
-      </p:sp>
-      <p:sp>
-        <p:nvSpPr>
-          <p:cNvPr id="4" name="TextBox 3"/>
-          <p:cNvSpPr txBox="1"/>
-          <p:nvPr/>
-        </p:nvSpPr>
-        <p:spPr>
-          <a:xfrm>
-            <a:off x="548640" y="731520"/>
-            <a:ext cx="11064240" cy="1005840"/>
-          </a:xfrm>
-          <a:prstGeom prst="rect">
-            <a:avLst/>
-          </a:prstGeom>
-          <a:noFill/>
-        </p:spPr>
-        <p:txBody>
-          <a:bodyPr wrap="square" anchor="t">
-            <a:spAutoFit/>
-          </a:bodyPr>
-          <a:lstStyle/>
-          <a:p>
-            <a:r>
-              <a:rPr sz="3400" b="1" i="0">
-                <a:solidFill>
-                  <a:srgbClr val="1B2025"/>
-                </a:solidFill>
-                <a:latin typeface="Avenir Next"/>
-              </a:rPr>
-              <a:t>Your turn — what gradient reaches layer 1?</a:t>
-            </a:r>
-          </a:p>
-        </p:txBody>
-      </p:sp>
-      <p:sp>
-        <p:nvSpPr>
-          <p:cNvPr id="6" name="Rectangle 5"/>
-          <p:cNvSpPr/>
-          <p:nvPr/>
-        </p:nvSpPr>
-        <p:spPr>
-          <a:xfrm>
-            <a:off x="548640" y="5538216"/>
-            <a:ext cx="10515600" cy="1182624"/>
-          </a:xfrm>
-          <a:prstGeom prst="rect">
-            <a:avLst/>
-          </a:prstGeom>
-          <a:solidFill>
-            <a:srgbClr val="F1F1EC"/>
-          </a:solidFill>
-          <a:ln w="12700">
-            <a:solidFill>
-              <a:srgbClr val="E09E2F"/>
-            </a:solidFill>
-          </a:ln>
-          <a:effectLst/>
-        </p:spPr>
-        <p:style>
-          <a:lnRef idx="1">
-            <a:schemeClr val="accent1"/>
-          </a:lnRef>
-          <a:fillRef idx="3">
-            <a:schemeClr val="accent1"/>
-          </a:fillRef>
-          <a:effectRef idx="2">
-            <a:schemeClr val="accent1"/>
-          </a:effectRef>
-          <a:fontRef idx="minor">
-            <a:schemeClr val="lt1"/>
-          </a:fontRef>
-        </p:style>
-        <p:txBody>
-          <a:bodyPr wrap="square" lIns="182880" rIns="182880" rtlCol="0" anchor="ctr"/>
-          <a:lstStyle/>
-          <a:p>
-            <a:pPr algn="ctr"/>
-            <a:r>
-              <a:rPr sz="1200" b="1" i="0">
-                <a:solidFill>
-                  <a:srgbClr val="E09E2F"/>
-                </a:solidFill>
-                <a:latin typeface="Menlo"/>
-              </a:rPr>
-              <a:t>CHECKPOINT · </a:t>
-            </a:r>
-            <a:r>
-              <a:rPr sz="1700" b="0" i="0">
-                <a:solidFill>
-                  <a:srgbClr val="3D444C"/>
-                </a:solidFill>
-                <a:latin typeface="Avenir Next"/>
-              </a:rPr>
-              <a:t>Your turn → Quiz 4, Q4. Multiply the slopes down the chain: 1.0 leaves the loss and is multiplied by 0.5 at each of 5 layers. (a) What reaches layer 1? (b) Vanishing or exploding? (c) What does that mean for the earliest layers? Worked answer in the notes.</a:t>
-            </a:r>
-          </a:p>
-        </p:txBody>
-      </p:sp>
-      <p:sp>
-        <p:nvSpPr>
-          <p:cNvPr id="7" name="Rounded Rectangle 6"/>
-          <p:cNvSpPr/>
-          <p:nvPr/>
-        </p:nvSpPr>
-        <p:spPr>
-          <a:xfrm>
-            <a:off x="548640" y="1908800"/>
-            <a:ext cx="1000000" cy="560000"/>
-          </a:xfrm>
-          <a:prstGeom prst="roundRect">
-            <a:avLst>
-              <a:gd name="adj" fmla="val 8000"/>
-            </a:avLst>
-          </a:prstGeom>
-          <a:solidFill>
-            <a:srgbClr val="FBF1DC"/>
-          </a:solidFill>
-          <a:ln>
-            <a:noFill/>
-          </a:ln>
-          <a:effectLst/>
-        </p:spPr>
-        <p:style>
-          <a:lnRef idx="1">
-            <a:schemeClr val="accent1"/>
-          </a:lnRef>
-          <a:fillRef idx="3">
-            <a:schemeClr val="accent1"/>
-          </a:fillRef>
-          <a:effectRef idx="2">
-            <a:schemeClr val="accent1"/>
-          </a:effectRef>
-          <a:fontRef idx="minor">
-            <a:schemeClr val="lt1"/>
-          </a:fontRef>
-        </p:style>
-        <p:txBody>
-          <a:bodyPr rtlCol="0" anchor="ctr"/>
-          <a:lstStyle/>
-          <a:p>
-            <a:pPr algn="ctr"/>
-            <a:r>
-              <a:rPr sz="1500" b="1">
-                <a:solidFill>
-                  <a:srgbClr val="1B2025"/>
-                </a:solidFill>
-                <a:latin typeface="Avenir Next"/>
-              </a:rPr>
-              <a:t>loss</a:t>
-            </a:r>
-          </a:p>
-        </p:txBody>
-      </p:sp>
-      <p:sp>
-        <p:nvSpPr>
-          <p:cNvPr id="8" name="TextBox 7"/>
-          <p:cNvSpPr txBox="1"/>
-          <p:nvPr/>
-        </p:nvSpPr>
-        <p:spPr>
-          <a:xfrm>
-            <a:off x="97080" y="2488800"/>
-            <a:ext cx="1903120" cy="330000"/>
-          </a:xfrm>
-          <a:prstGeom prst="rect">
-            <a:avLst/>
-          </a:prstGeom>
-          <a:noFill/>
-        </p:spPr>
-        <p:txBody>
-          <a:bodyPr wrap="square" lIns="45720" rIns="45720" tIns="27432" bIns="27432" anchor="t">
-            <a:spAutoFit/>
-          </a:bodyPr>
-          <a:lstStyle/>
-          <a:p>
-            <a:pPr algn="ctr">
-              <a:spcAft>
-                <a:spcPts val="400"/>
-              </a:spcAft>
-            </a:pPr>
-            <a:r>
-              <a:rPr sz="1400" b="1">
-                <a:solidFill>
-                  <a:srgbClr val="3D444C"/>
-                </a:solidFill>
-                <a:latin typeface="Avenir Next"/>
-              </a:rPr>
-              <a:t>gradient 1.0</a:t>
-            </a:r>
-          </a:p>
-        </p:txBody>
-      </p:sp>
-      <p:sp>
-        <p:nvSpPr>
-          <p:cNvPr id="9" name="TextBox 8"/>
-          <p:cNvSpPr txBox="1"/>
-          <p:nvPr/>
-        </p:nvSpPr>
-        <p:spPr>
-          <a:xfrm>
-            <a:off x="1548640" y="1968800"/>
-            <a:ext cx="903120" cy="440000"/>
-          </a:xfrm>
-          <a:prstGeom prst="rect">
-            <a:avLst/>
-          </a:prstGeom>
-          <a:noFill/>
-        </p:spPr>
-        <p:txBody>
-          <a:bodyPr wrap="square" lIns="45720" rIns="45720" tIns="27432" bIns="27432" anchor="ctr">
-            <a:spAutoFit/>
-          </a:bodyPr>
-          <a:lstStyle/>
-          <a:p>
-            <a:pPr algn="ctr">
-              <a:spcAft>
-                <a:spcPts val="400"/>
-              </a:spcAft>
-            </a:pPr>
-            <a:r>
-              <a:rPr sz="1500" b="1">
-                <a:solidFill>
-                  <a:srgbClr val="0E7C7B"/>
-                </a:solidFill>
-                <a:latin typeface="Menlo"/>
-              </a:rPr>
-              <a:t>× 0.5</a:t>
-            </a:r>
-          </a:p>
-        </p:txBody>
-      </p:sp>
-      <p:sp>
-        <p:nvSpPr>
-          <p:cNvPr id="10" name="Rounded Rectangle 9"/>
-          <p:cNvSpPr/>
-          <p:nvPr/>
-        </p:nvSpPr>
-        <p:spPr>
-          <a:xfrm>
-            <a:off x="2451760" y="1908800"/>
-            <a:ext cx="1000000" cy="560000"/>
-          </a:xfrm>
-          <a:prstGeom prst="roundRect">
-            <a:avLst>
-              <a:gd name="adj" fmla="val 8000"/>
-            </a:avLst>
-          </a:prstGeom>
-          <a:solidFill>
-            <a:srgbClr val="E3F0EF"/>
-          </a:solidFill>
-          <a:ln>
-            <a:noFill/>
-          </a:ln>
-          <a:effectLst/>
-        </p:spPr>
-        <p:style>
-          <a:lnRef idx="1">
-            <a:schemeClr val="accent1"/>
-          </a:lnRef>
-          <a:fillRef idx="3">
-            <a:schemeClr val="accent1"/>
-          </a:fillRef>
-          <a:effectRef idx="2">
-            <a:schemeClr val="accent1"/>
-          </a:effectRef>
-          <a:fontRef idx="minor">
-            <a:schemeClr val="lt1"/>
-          </a:fontRef>
-        </p:style>
-        <p:txBody>
-          <a:bodyPr rtlCol="0" anchor="ctr"/>
-          <a:lstStyle/>
-          <a:p>
-            <a:pPr algn="ctr"/>
-            <a:r>
-              <a:rPr sz="1500" b="1">
-                <a:solidFill>
-                  <a:srgbClr val="1B2025"/>
-                </a:solidFill>
-                <a:latin typeface="Avenir Next"/>
-              </a:rPr>
-              <a:t>layer 5</a:t>
-            </a:r>
-          </a:p>
-        </p:txBody>
-      </p:sp>
-      <p:sp>
-        <p:nvSpPr>
-          <p:cNvPr id="11" name="TextBox 10"/>
-          <p:cNvSpPr txBox="1"/>
-          <p:nvPr/>
-        </p:nvSpPr>
-        <p:spPr>
-          <a:xfrm>
-            <a:off x="3451760" y="1968800"/>
-            <a:ext cx="903120" cy="440000"/>
-          </a:xfrm>
-          <a:prstGeom prst="rect">
-            <a:avLst/>
-          </a:prstGeom>
-          <a:noFill/>
-        </p:spPr>
-        <p:txBody>
-          <a:bodyPr wrap="square" lIns="45720" rIns="45720" tIns="27432" bIns="27432" anchor="ctr">
-            <a:spAutoFit/>
-          </a:bodyPr>
-          <a:lstStyle/>
-          <a:p>
-            <a:pPr algn="ctr">
-              <a:spcAft>
-                <a:spcPts val="400"/>
-              </a:spcAft>
-            </a:pPr>
-            <a:r>
-              <a:rPr sz="1500" b="1">
-                <a:solidFill>
-                  <a:srgbClr val="0E7C7B"/>
-                </a:solidFill>
-                <a:latin typeface="Menlo"/>
-              </a:rPr>
-              <a:t>× 0.5</a:t>
-            </a:r>
-          </a:p>
-        </p:txBody>
-      </p:sp>
-      <p:sp>
-        <p:nvSpPr>
-          <p:cNvPr id="12" name="Rounded Rectangle 11"/>
-          <p:cNvSpPr/>
-          <p:nvPr/>
-        </p:nvSpPr>
-        <p:spPr>
-          <a:xfrm>
-            <a:off x="4354880" y="1908800"/>
-            <a:ext cx="1000000" cy="560000"/>
-          </a:xfrm>
-          <a:prstGeom prst="roundRect">
-            <a:avLst>
-              <a:gd name="adj" fmla="val 8000"/>
-            </a:avLst>
-          </a:prstGeom>
-          <a:solidFill>
-            <a:srgbClr val="E3F0EF"/>
-          </a:solidFill>
-          <a:ln>
-            <a:noFill/>
-          </a:ln>
-          <a:effectLst/>
-        </p:spPr>
-        <p:style>
-          <a:lnRef idx="1">
-            <a:schemeClr val="accent1"/>
-          </a:lnRef>
-          <a:fillRef idx="3">
-            <a:schemeClr val="accent1"/>
-          </a:fillRef>
-          <a:effectRef idx="2">
-            <a:schemeClr val="accent1"/>
-          </a:effectRef>
-          <a:fontRef idx="minor">
-            <a:schemeClr val="lt1"/>
-          </a:fontRef>
-        </p:style>
-        <p:txBody>
-          <a:bodyPr rtlCol="0" anchor="ctr"/>
-          <a:lstStyle/>
-          <a:p>
-            <a:pPr algn="ctr"/>
-            <a:r>
-              <a:rPr sz="1500" b="1">
-                <a:solidFill>
-                  <a:srgbClr val="1B2025"/>
-                </a:solidFill>
-                <a:latin typeface="Avenir Next"/>
-              </a:rPr>
-              <a:t>layer 4</a:t>
-            </a:r>
-          </a:p>
-        </p:txBody>
-      </p:sp>
-      <p:sp>
-        <p:nvSpPr>
-          <p:cNvPr id="13" name="TextBox 12"/>
-          <p:cNvSpPr txBox="1"/>
-          <p:nvPr/>
-        </p:nvSpPr>
-        <p:spPr>
-          <a:xfrm>
-            <a:off x="5354880" y="1968800"/>
-            <a:ext cx="903120" cy="440000"/>
-          </a:xfrm>
-          <a:prstGeom prst="rect">
-            <a:avLst/>
-          </a:prstGeom>
-          <a:noFill/>
-        </p:spPr>
-        <p:txBody>
-          <a:bodyPr wrap="square" lIns="45720" rIns="45720" tIns="27432" bIns="27432" anchor="ctr">
-            <a:spAutoFit/>
-          </a:bodyPr>
-          <a:lstStyle/>
-          <a:p>
-            <a:pPr algn="ctr">
-              <a:spcAft>
-                <a:spcPts val="400"/>
-              </a:spcAft>
-            </a:pPr>
-            <a:r>
-              <a:rPr sz="1500" b="1">
-                <a:solidFill>
-                  <a:srgbClr val="0E7C7B"/>
-                </a:solidFill>
-                <a:latin typeface="Menlo"/>
-              </a:rPr>
-              <a:t>× 0.5</a:t>
-            </a:r>
-          </a:p>
-        </p:txBody>
-      </p:sp>
-      <p:sp>
-        <p:nvSpPr>
-          <p:cNvPr id="14" name="Rounded Rectangle 13"/>
-          <p:cNvSpPr/>
-          <p:nvPr/>
-        </p:nvSpPr>
-        <p:spPr>
-          <a:xfrm>
-            <a:off x="6258000" y="1908800"/>
-            <a:ext cx="1000000" cy="560000"/>
-          </a:xfrm>
-          <a:prstGeom prst="roundRect">
-            <a:avLst>
-              <a:gd name="adj" fmla="val 8000"/>
-            </a:avLst>
-          </a:prstGeom>
-          <a:solidFill>
-            <a:srgbClr val="E3F0EF"/>
-          </a:solidFill>
-          <a:ln>
-            <a:noFill/>
-          </a:ln>
-          <a:effectLst/>
-        </p:spPr>
-        <p:style>
-          <a:lnRef idx="1">
-            <a:schemeClr val="accent1"/>
-          </a:lnRef>
-          <a:fillRef idx="3">
-            <a:schemeClr val="accent1"/>
-          </a:fillRef>
-          <a:effectRef idx="2">
-            <a:schemeClr val="accent1"/>
-          </a:effectRef>
-          <a:fontRef idx="minor">
-            <a:schemeClr val="lt1"/>
-          </a:fontRef>
-        </p:style>
-        <p:txBody>
-          <a:bodyPr rtlCol="0" anchor="ctr"/>
-          <a:lstStyle/>
-          <a:p>
-            <a:pPr algn="ctr"/>
-            <a:r>
-              <a:rPr sz="1500" b="1">
-                <a:solidFill>
-                  <a:srgbClr val="1B2025"/>
-                </a:solidFill>
-                <a:latin typeface="Avenir Next"/>
-              </a:rPr>
-              <a:t>layer 3</a:t>
-            </a:r>
-          </a:p>
-        </p:txBody>
-      </p:sp>
-      <p:sp>
-        <p:nvSpPr>
-          <p:cNvPr id="15" name="TextBox 14"/>
-          <p:cNvSpPr txBox="1"/>
-          <p:nvPr/>
-        </p:nvSpPr>
-        <p:spPr>
-          <a:xfrm>
-            <a:off x="7258000" y="1968800"/>
-            <a:ext cx="903120" cy="440000"/>
-          </a:xfrm>
-          <a:prstGeom prst="rect">
-            <a:avLst/>
-          </a:prstGeom>
-          <a:noFill/>
-        </p:spPr>
-        <p:txBody>
-          <a:bodyPr wrap="square" lIns="45720" rIns="45720" tIns="27432" bIns="27432" anchor="ctr">
-            <a:spAutoFit/>
-          </a:bodyPr>
-          <a:lstStyle/>
-          <a:p>
-            <a:pPr algn="ctr">
-              <a:spcAft>
-                <a:spcPts val="400"/>
-              </a:spcAft>
-            </a:pPr>
-            <a:r>
-              <a:rPr sz="1500" b="1">
-                <a:solidFill>
-                  <a:srgbClr val="0E7C7B"/>
-                </a:solidFill>
-                <a:latin typeface="Menlo"/>
-              </a:rPr>
-              <a:t>× 0.5</a:t>
-            </a:r>
-          </a:p>
-        </p:txBody>
-      </p:sp>
-      <p:sp>
-        <p:nvSpPr>
-          <p:cNvPr id="16" name="Rounded Rectangle 15"/>
-          <p:cNvSpPr/>
-          <p:nvPr/>
-        </p:nvSpPr>
-        <p:spPr>
-          <a:xfrm>
-            <a:off x="8161120" y="1908800"/>
-            <a:ext cx="1000000" cy="560000"/>
-          </a:xfrm>
-          <a:prstGeom prst="roundRect">
-            <a:avLst>
-              <a:gd name="adj" fmla="val 8000"/>
-            </a:avLst>
-          </a:prstGeom>
-          <a:solidFill>
-            <a:srgbClr val="E3F0EF"/>
-          </a:solidFill>
-          <a:ln>
-            <a:noFill/>
-          </a:ln>
-          <a:effectLst/>
-        </p:spPr>
-        <p:style>
-          <a:lnRef idx="1">
-            <a:schemeClr val="accent1"/>
-          </a:lnRef>
-          <a:fillRef idx="3">
-            <a:schemeClr val="accent1"/>
-          </a:fillRef>
-          <a:effectRef idx="2">
-            <a:schemeClr val="accent1"/>
-          </a:effectRef>
-          <a:fontRef idx="minor">
-            <a:schemeClr val="lt1"/>
-          </a:fontRef>
-        </p:style>
-        <p:txBody>
-          <a:bodyPr rtlCol="0" anchor="ctr"/>
-          <a:lstStyle/>
-          <a:p>
-            <a:pPr algn="ctr"/>
-            <a:r>
-              <a:rPr sz="1500" b="1">
-                <a:solidFill>
-                  <a:srgbClr val="1B2025"/>
-                </a:solidFill>
-                <a:latin typeface="Avenir Next"/>
-              </a:rPr>
-              <a:t>layer 2</a:t>
-            </a:r>
-          </a:p>
-        </p:txBody>
-      </p:sp>
-      <p:sp>
-        <p:nvSpPr>
-          <p:cNvPr id="17" name="TextBox 16"/>
-          <p:cNvSpPr txBox="1"/>
-          <p:nvPr/>
-        </p:nvSpPr>
-        <p:spPr>
-          <a:xfrm>
-            <a:off x="9161120" y="1968800"/>
-            <a:ext cx="903120" cy="440000"/>
-          </a:xfrm>
-          <a:prstGeom prst="rect">
-            <a:avLst/>
-          </a:prstGeom>
-          <a:noFill/>
-        </p:spPr>
-        <p:txBody>
-          <a:bodyPr wrap="square" lIns="45720" rIns="45720" tIns="27432" bIns="27432" anchor="ctr">
-            <a:spAutoFit/>
-          </a:bodyPr>
-          <a:lstStyle/>
-          <a:p>
-            <a:pPr algn="ctr">
-              <a:spcAft>
-                <a:spcPts val="400"/>
-              </a:spcAft>
-            </a:pPr>
-            <a:r>
-              <a:rPr sz="1500" b="1">
-                <a:solidFill>
-                  <a:srgbClr val="0E7C7B"/>
-                </a:solidFill>
-                <a:latin typeface="Menlo"/>
-              </a:rPr>
-              <a:t>× 0.5</a:t>
-            </a:r>
-          </a:p>
-        </p:txBody>
-      </p:sp>
-      <p:sp>
-        <p:nvSpPr>
-          <p:cNvPr id="18" name="Rounded Rectangle 17"/>
-          <p:cNvSpPr/>
-          <p:nvPr/>
-        </p:nvSpPr>
-        <p:spPr>
-          <a:xfrm>
-            <a:off x="10064240" y="1908800"/>
-            <a:ext cx="1000000" cy="560000"/>
-          </a:xfrm>
-          <a:prstGeom prst="roundRect">
-            <a:avLst>
-              <a:gd name="adj" fmla="val 8000"/>
-            </a:avLst>
-          </a:prstGeom>
-          <a:solidFill>
-            <a:srgbClr val="FBF1DC"/>
-          </a:solidFill>
-          <a:ln>
-            <a:noFill/>
-          </a:ln>
-          <a:effectLst/>
-        </p:spPr>
-        <p:style>
-          <a:lnRef idx="1">
-            <a:schemeClr val="accent1"/>
-          </a:lnRef>
-          <a:fillRef idx="3">
-            <a:schemeClr val="accent1"/>
-          </a:fillRef>
-          <a:effectRef idx="2">
-            <a:schemeClr val="accent1"/>
-          </a:effectRef>
-          <a:fontRef idx="minor">
-            <a:schemeClr val="lt1"/>
-          </a:fontRef>
-        </p:style>
-        <p:txBody>
-          <a:bodyPr rtlCol="0" anchor="ctr"/>
-          <a:lstStyle/>
-          <a:p>
-            <a:pPr algn="ctr"/>
-            <a:r>
-              <a:rPr sz="1500" b="1">
-                <a:solidFill>
-                  <a:srgbClr val="1B2025"/>
-                </a:solidFill>
-                <a:latin typeface="Avenir Next"/>
-              </a:rPr>
-              <a:t>layer 1</a:t>
-            </a:r>
-          </a:p>
-        </p:txBody>
-      </p:sp>
-      <p:sp>
-        <p:nvSpPr>
-          <p:cNvPr id="19" name="TextBox 18"/>
-          <p:cNvSpPr txBox="1"/>
-          <p:nvPr/>
-        </p:nvSpPr>
-        <p:spPr>
-          <a:xfrm>
-            <a:off x="9612680" y="2488800"/>
-            <a:ext cx="1903120" cy="330000"/>
-          </a:xfrm>
-          <a:prstGeom prst="rect">
-            <a:avLst/>
-          </a:prstGeom>
-          <a:noFill/>
-        </p:spPr>
-        <p:txBody>
-          <a:bodyPr wrap="square" lIns="45720" rIns="45720" tIns="27432" bIns="27432" anchor="t">
-            <a:spAutoFit/>
-          </a:bodyPr>
-          <a:lstStyle/>
-          <a:p>
-            <a:pPr algn="ctr">
-              <a:spcAft>
-                <a:spcPts val="400"/>
-              </a:spcAft>
-            </a:pPr>
-            <a:r>
-              <a:rPr sz="1400" b="1">
-                <a:solidFill>
-                  <a:srgbClr val="E09E2F"/>
-                </a:solidFill>
-                <a:latin typeface="Avenir Next"/>
-              </a:rPr>
-              <a:t>gradient ?</a:t>
-            </a:r>
-          </a:p>
-        </p:txBody>
-      </p:sp>
-      <p:sp>
-        <p:nvSpPr>
-          <p:cNvPr id="20" name="TextBox 19"/>
-          <p:cNvSpPr txBox="1"/>
-          <p:nvPr/>
-        </p:nvSpPr>
-        <p:spPr>
-          <a:xfrm>
-            <a:off x="548640" y="2888800"/>
-            <a:ext cx="10515600" cy="1900000"/>
-          </a:xfrm>
-          <a:prstGeom prst="rect">
-            <a:avLst/>
-          </a:prstGeom>
-          <a:noFill/>
-        </p:spPr>
-        <p:txBody>
-          <a:bodyPr wrap="square" lIns="45720" rIns="45720" tIns="27432" bIns="27432" anchor="t">
-            <a:spAutoFit/>
-          </a:bodyPr>
-          <a:lstStyle/>
-          <a:p>
-            <a:pPr algn="l">
-              <a:spcAft>
-                <a:spcPts val="600"/>
-              </a:spcAft>
-            </a:pPr>
-            <a:r>
-              <a:rPr sz="1600" b="0">
-                <a:solidFill>
-                  <a:srgbClr val="1B2025"/>
-                </a:solidFill>
-                <a:latin typeface="Avenir Next"/>
-              </a:rPr>
-              <a:t>A gradient is the PRODUCT of the local slopes along the path back to a weight (Lecture 2). Here it passes back through 5 layers, each multiplying it by a slope of 0.5.</a:t>
-            </a:r>
-          </a:p>
-          <a:p>
-            <a:pPr algn="l">
-              <a:spcAft>
-                <a:spcPts val="600"/>
-              </a:spcAft>
-            </a:pPr>
-            <a:r>
-              <a:rPr sz="1600" b="1">
-                <a:solidFill>
-                  <a:srgbClr val="0E7C7B"/>
-                </a:solidFill>
-                <a:latin typeface="Avenir Next"/>
-              </a:rPr>
-              <a:t>(a)  </a:t>
-            </a:r>
-            <a:r>
-              <a:rPr sz="1600" b="0">
-                <a:solidFill>
-                  <a:srgbClr val="1B2025"/>
-                </a:solidFill>
-                <a:latin typeface="Avenir Next"/>
-              </a:rPr>
-              <a:t>What gradient reaches the first layer?   1.0 × 0.5⁵ =</a:t>
-            </a:r>
-            <a:r>
-              <a:rPr sz="1600" b="1">
-                <a:solidFill>
-                  <a:srgbClr val="0E7C7B"/>
-                </a:solidFill>
-                <a:latin typeface="Avenir Next"/>
-              </a:rPr>
-              <a:t>  ________</a:t>
-            </a:r>
-          </a:p>
-          <a:p>
-            <a:pPr algn="l">
-              <a:spcAft>
-                <a:spcPts val="600"/>
-              </a:spcAft>
-            </a:pPr>
-            <a:r>
-              <a:rPr sz="1600" b="1">
-                <a:solidFill>
-                  <a:srgbClr val="0E7C7B"/>
-                </a:solidFill>
-                <a:latin typeface="Avenir Next"/>
-              </a:rPr>
-              <a:t>(b)  </a:t>
-            </a:r>
-            <a:r>
-              <a:rPr sz="1600" b="0">
-                <a:solidFill>
-                  <a:srgbClr val="1B2025"/>
-                </a:solidFill>
-                <a:latin typeface="Avenir Next"/>
-              </a:rPr>
-              <a:t>Is this vanishing or exploding?</a:t>
-            </a:r>
-            <a:r>
-              <a:rPr sz="1600" b="1">
-                <a:solidFill>
-                  <a:srgbClr val="0E7C7B"/>
-                </a:solidFill>
-                <a:latin typeface="Avenir Next"/>
-              </a:rPr>
-              <a:t>  ________</a:t>
-            </a:r>
-          </a:p>
-          <a:p>
-            <a:pPr algn="l">
-              <a:spcAft>
-                <a:spcPts val="600"/>
-              </a:spcAft>
-            </a:pPr>
-            <a:r>
-              <a:rPr sz="1600" b="1">
-                <a:solidFill>
-                  <a:srgbClr val="0E7C7B"/>
-                </a:solidFill>
-                <a:latin typeface="Avenir Next"/>
-              </a:rPr>
-              <a:t>(c)  </a:t>
-            </a:r>
-            <a:r>
-              <a:rPr sz="1600" b="0">
-                <a:solidFill>
-                  <a:srgbClr val="1B2025"/>
-                </a:solidFill>
-                <a:latin typeface="Avenir Next"/>
-              </a:rPr>
-              <a:t>In one line: what does that mean for how the earliest layers learn?</a:t>
             </a:r>
           </a:p>
         </p:txBody>

</xml_diff>

<commit_message>
Add script to generate diffusion sampling figure for MNIST digits
This script utilizes a pretrained diffusion model to transform pure noise into new images of digits. It captures the intermediate steps of the diffusion process and saves the results as a PNG file for presentation purposes. The implementation includes necessary imports, model loading, and visualization of the sampling trajectory.
</commit_message>
<xml_diff>
--- a/slides/pptx/lecture04_training_practice.pptx
+++ b/slides/pptx/lecture04_training_practice.pptx
@@ -5,7 +5,7 @@
     <p:sldMasterId id="2147483658" r:id="rId1"/>
   </p:sldMasterIdLst>
   <p:notesMasterIdLst>
-    <p:notesMasterId r:id="rId35"/>
+    <p:notesMasterId r:id="rId36"/>
   </p:notesMasterIdLst>
   <p:sldIdLst>
     <p:sldId id="256" r:id="rId2"/>
@@ -15,8 +15,8 @@
     <p:sldId id="261" r:id="rId6"/>
     <p:sldId id="260" r:id="rId7"/>
     <p:sldId id="286" r:id="rId8"/>
-    <p:sldId id="287" r:id="rId9"/>
-    <p:sldId id="262" r:id="rId10"/>
+    <p:sldId id="262" r:id="rId9"/>
+    <p:sldId id="287" r:id="rId10"/>
     <p:sldId id="263" r:id="rId11"/>
     <p:sldId id="264" r:id="rId12"/>
     <p:sldId id="288" r:id="rId13"/>
@@ -26,22 +26,22 @@
     <p:sldId id="266" r:id="rId17"/>
     <p:sldId id="267" r:id="rId18"/>
     <p:sldId id="268" r:id="rId19"/>
-    <p:sldId id="269" r:id="rId20"/>
-    <p:sldId id="291" r:id="rId40"/>
-    <p:sldId id="271" r:id="rId21"/>
-    <p:sldId id="272" r:id="rId22"/>
-    <p:sldId id="273" r:id="rId23"/>
-    <p:sldId id="274" r:id="rId24"/>
-    <p:sldId id="275" r:id="rId25"/>
-    <p:sldId id="276" r:id="rId26"/>
-    <p:sldId id="277" r:id="rId27"/>
-    <p:sldId id="278" r:id="rId28"/>
-    <p:sldId id="279" r:id="rId29"/>
-    <p:sldId id="280" r:id="rId30"/>
-    <p:sldId id="281" r:id="rId31"/>
-    <p:sldId id="282" r:id="rId32"/>
-    <p:sldId id="283" r:id="rId33"/>
-    <p:sldId id="285" r:id="rId34"/>
+    <p:sldId id="292" r:id="rId20"/>
+    <p:sldId id="269" r:id="rId21"/>
+    <p:sldId id="291" r:id="rId22"/>
+    <p:sldId id="271" r:id="rId23"/>
+    <p:sldId id="272" r:id="rId24"/>
+    <p:sldId id="273" r:id="rId25"/>
+    <p:sldId id="274" r:id="rId26"/>
+    <p:sldId id="275" r:id="rId27"/>
+    <p:sldId id="276" r:id="rId28"/>
+    <p:sldId id="277" r:id="rId29"/>
+    <p:sldId id="278" r:id="rId30"/>
+    <p:sldId id="280" r:id="rId31"/>
+    <p:sldId id="281" r:id="rId32"/>
+    <p:sldId id="282" r:id="rId33"/>
+    <p:sldId id="283" r:id="rId34"/>
+    <p:sldId id="285" r:id="rId35"/>
   </p:sldIdLst>
   <p:sldSz cx="12192000" cy="6858000"/>
   <p:notesSz cx="6858000" cy="9144000"/>
@@ -843,18 +843,6 @@
       </p:grpSpPr>
       <p:sp>
         <p:nvSpPr>
-          <p:cNvPr id="2" name="Slide Image Placeholder 1"/>
-          <p:cNvSpPr>
-            <a:spLocks noGrp="1" noRot="1" noChangeAspect="1"/>
-          </p:cNvSpPr>
-          <p:nvPr>
-            <p:ph type="sldImg" idx="2"/>
-          </p:nvPr>
-        </p:nvSpPr>
-        <p:spPr/>
-      </p:sp>
-      <p:sp>
-        <p:nvSpPr>
           <p:cNvPr id="3" name="Notes Placeholder 2"/>
           <p:cNvSpPr>
             <a:spLocks noGrp="1"/>
@@ -869,25 +857,10 @@
           <a:lstStyle/>
           <a:p>
             <a:r>
-              <a:t>Set expectations honestly: the list of things you COULD tune is enormous — depth and width, activation, the optimizer and its momentum, dropout rate, weight-decay strength, the schedule, batch size, epochs, and more. Nobody sweeps all of them. The skill is knowing the handful that move the needle, and we cover only those basics. Define hyperparameter cleanly: a setting YOU pick before training, versus the weights the loop LEARNS. Then the ranking: the learning rate dominates (callback to Lecture 2's three bowls, the loss-curve diagnosis, and the schedule two slides back) — get it in the right ballpark before touching anything else; then batch size (its trade- off and loss-curve fingerprint are the next two slides); then model size and epochs. Give the order-of-attack line as the practical recipe. Regularization strength (dropout, weight decay) is also a hyperparameter, but we meet those as OVERFITTING fixes in Part 3, so they are off this list. Bullets are genuine list content here (an agenda of knobs), not a mechanic — the mechanics get pictures. Bridge: batch size next.</a:t>
-            </a:r>
-          </a:p>
-          <a:p>
-            <a:endParaRPr/>
-          </a:p>
-        </p:txBody>
-      </p:sp>
-      <p:sp>
-        <p:nvSpPr>
-          <p:cNvPr id="4" name="Slide Number Placeholder 3"/>
-          <p:cNvSpPr>
-            <a:spLocks noGrp="1"/>
-          </p:cNvSpPr>
-          <p:nvPr>
-            <p:ph type="sldNum" sz="quarter" idx="5"/>
-          </p:nvPr>
-        </p:nvSpPr>
-        <p:spPr/>
+              <a:t>YOU-DO = Quiz 4 Q4, straight after the whisper-down-the-lane I-do. Worked answer: (a) 1.0×0.5^5=0.5^5=0.03125≈0.03. (b) Vanishing — every factor is below 1, so the product shrinks fast. (c) The gradient reaching the earliest layers is almost zero, so those layers barely update / learn while layers near the output learn fine — which is why very deep plain networks are hard to train (the fix, ResNet skip connections, is Lecture 5). If each slope were instead about 2, the product 2^5=32 would explode and the loss would go to NaN.</a:t>
+            </a:r>
+          </a:p>
+        </p:txBody>
       </p:sp>
     </p:spTree>
   </p:cSld>
@@ -942,7 +915,7 @@
           <a:lstStyle/>
           <a:p>
             <a:r>
-              <a:t>I-DO for the batch-size trade-off — cover BOTH what a bigger batch buys AND the too-big problem (Quiz 4 Q3). Read the figure as one shared landscape seen from above (contour rings = equal loss). LEFT, small batch: each mini- batch gives a noisy, slightly-wrong gradient estimate, so every step is small and points a bit differently — many short jittery hops that wander into a wide, FLAT basin (loss stays low over a broad area). RIGHT, large batch: averaging over many examples gives a clean, accurate gradient, so each step is long and nearly straight — a few big strides into a narrow, SHARP basin. The generalization point (Keskar et al.): a flat basin is forgiving — a small shift between training data and new data barely changes the loss there — while a sharp basin is unforgiving, so the same shift sends the loss up the wall (a "generalization gap"). So a bigger batch buys a less noisy gradient and better hardware use, but too big costs you. Next slide you name those costs — Quiz 4 Q3 — reading the loss-curve fingerprint.</a:t>
+              <a:t>Set expectations honestly: the list of things you COULD tune is enormous — depth and width, activation, the optimizer and its momentum, dropout rate, weight-decay strength, the schedule, batch size, epochs, and more. Nobody sweeps all of them. The skill is knowing the handful that move the needle, and we cover only those basics. Define hyperparameter cleanly: a setting YOU pick before training, versus the weights the loop LEARNS. Then the ranking: the learning rate dominates (callback to Lecture 2's three bowls, the loss-curve diagnosis, and the schedule two slides back) — get it in the right ballpark before touching anything else; then batch size (its trade- off and loss-curve fingerprint are the next two slides); then model size and epochs. Give the order-of-attack line as the practical recipe. Regularization strength (dropout, weight decay) is also a hyperparameter, but we meet those as OVERFITTING fixes in Part 3, so they are off this list. Bullets are genuine list content here (an agenda of knobs), not a mechanic — the mechanics get pictures. Bridge: batch size next.</a:t>
             </a:r>
           </a:p>
           <a:p>
@@ -1015,7 +988,7 @@
           <a:lstStyle/>
           <a:p>
             <a:r>
-              <a:t>YOU-DO = Quiz 4 Q3 — a symptom→cause diagnosis, NOT a list-the-tradeoffs recall. Each symptom points at one cause and one fix, all covered on the last two slides. (a) 'CUDA out of memory' before training even starts → the batch is simply TOO BIG TO FIT IN GPU MEMORY → shrink the batch (or keep it and use gradient accumulation). (b) smooth curve that PLATEAUS HIGHER than batch-32 (exactly the teal curve on screen) → with a very large batch you take FAR FEWER weight updates per epoch AND the too-clean gradient settles into a SHARP minimum that generalizes worse, so the loss stalls high → lower the batch toward ~32 (or train more epochs). (c) the trap, say it aloud: the smooth run is NOT automatically the better one — judge a run by where it ENDS UP and by validation, never by how steady the curve looks. Have a pair name each cause before revealing, then fill Q3.</a:t>
+              <a:t>I-DO for the batch-size trade-off — cover BOTH what a bigger batch buys AND the too-big problem (Quiz 4 Q3). Read the figure as one shared landscape seen from above (contour rings = equal loss). LEFT, small batch: each mini- batch gives a noisy, slightly-wrong gradient estimate, so every step is small and points a bit differently — many short jittery hops that wander into a wide, FLAT basin (loss stays low over a broad area). RIGHT, large batch: averaging over many examples gives a clean, accurate gradient, so each step is long and nearly straight — a few big strides into a narrow, SHARP basin. The generalization point (Keskar et al.): a flat basin is forgiving — a small shift between training data and new data barely changes the loss there — while a sharp basin is unforgiving, so the same shift sends the loss up the wall (a "generalization gap"). So a bigger batch buys a less noisy gradient and better hardware use, but too big costs you. Next slide you name those costs — Quiz 4 Q3 — reading the loss-curve fingerprint.</a:t>
             </a:r>
           </a:p>
           <a:p>
@@ -1088,7 +1061,7 @@
           <a:lstStyle/>
           <a:p>
             <a:r>
-              <a:t>Explain the ladder: grid → random → Bayesian. Grid: pick a few values per hyperparameter and try every combination — tidy, but 4 learning rates × 4 batch sizes = 16 runs yet only 4 distinct learning rates ever tested. Random: same 16-run budget, sample each hyperparameter randomly, so you test 16 different learning rates AND 16 batch sizes; since usually one knob (the learning rate) dominates, sampling it densely — which random does for free, because its points don't line up in columns — finds a better model sooner. Then the state-of-the-art correction: it is NOT purely random. Bayesian optimization keeps a running model of how settings map to validation score, fit to the trials you've already run, and uses it to pick the next trial intelligently — exploiting regions that scored well while still exploring uncertain ones. Name the tools (Optuna, Ray Tune, scikit- optimize); the math (Gaussian processes, acquisition functions) is beyond today. In Lab 2 they run a small structured search themselves. Bridge to Part 3: even perfectly tuned, a model can still fail the real test — generalizing to new samples.</a:t>
+              <a:t>YOU-DO = Quiz 4 Q3 — a symptom→cause diagnosis, NOT a list-the-tradeoffs recall. Each symptom points at one cause and one fix, all covered on the last two slides. (a) 'CUDA out of memory' before training even starts → the batch is simply TOO BIG TO FIT IN GPU MEMORY → shrink the batch (or keep it and use gradient accumulation). (b) smooth curve that PLATEAUS HIGHER than batch-32 (exactly the teal curve on screen) → with a very large batch you take FAR FEWER weight updates per epoch AND the too-clean gradient settles into a SHARP minimum that generalizes worse, so the loss stalls high → lower the batch toward ~32 (or train more epochs). (c) the trap, say it aloud: the smooth run is NOT automatically the better one — judge a run by where it ENDS UP and by validation, never by how steady the curve looks. Have a pair name each cause before revealing, then fill Q3.</a:t>
             </a:r>
           </a:p>
           <a:p>
@@ -1234,7 +1207,7 @@
           <a:lstStyle/>
           <a:p>
             <a:r>
-              <a:t>Part three of three, and the most practically important skill. The single question: does your model actually generalize to new samples, or has it just memorized the training set? The answer lives in the gap between the training curve and the validation curve. We build the intuition with the classic fit picture, learn to read the two loss curves (the Quiz 4 Q2 you-do), anchor it in a real MS failure, then fix with more data, early stopping, dropout, and weight decay.</a:t>
+              <a:t>Explain the ladder: grid → random → Bayesian. Grid: pick a few values per hyperparameter and try every combination — tidy, but 4 learning rates × 4 batch sizes = 16 runs yet only 4 distinct learning rates ever tested. Random: same 16-run budget, sample each hyperparameter randomly, so you test 16 different learning rates AND 16 batch sizes; since usually one knob (the learning rate) dominates, sampling it densely — which random does for free, because its points don't line up in columns — finds a better model sooner. Then the state-of-the-art correction: it is NOT purely random. Bayesian optimization keeps a running model of how settings map to validation score, fit to the trials you've already run, and uses it to pick the next trial intelligently — exploiting regions that scored well while still exploring uncertain ones. Name the tools (Optuna, Ray Tune, scikit- optimize); the math (Gaussian processes, acquisition functions) is beyond today. In Lab 2 they run a small structured search themselves. Bridge to Part 3: even perfectly tuned, a model can still fail the real test — generalizing to new samples.</a:t>
             </a:r>
           </a:p>
           <a:p>
@@ -1307,7 +1280,7 @@
           <a:lstStyle/>
           <a:p>
             <a:r>
-              <a:t>Lead Part 3 with the picture everyone pictures for over/underfitting — more intuitive than loss curves, so it comes first. Same seven noisy points in all three panels; only the model differs. Left, underfitting: a straight line, too simple to bend with the data, so it misses the obvious trend ("high bias"). Middle, just right: a smooth curve that follows the underlying trend while ignoring the little up-and-down jitter — that jitter is noise, not signal. Right, overfitting: a wiggly curve contorted to pass exactly through every point, including the noise; it scores perfectly on these seven yet lurches wildly between them, so on the very next measurement it will be badly wrong. Say the lesson plainly: a perfect score on the training points is not the goal — capturing the trend that transfers to new data is. This is exactly the spectra story coming two slides on, and it is what the loss curves next detect.</a:t>
+              <a:t>Part three of three, and the most practically important skill. The single question: does your model actually generalize to new samples, or has it just memorized the training set? The answer lives in the gap between the training curve and the validation curve. We build the intuition with the classic fit picture, learn to read the two loss curves (the Quiz 4 Q2 you-do), anchor it in a real MS failure, then fix with more data, early stopping, dropout, and weight decay.</a:t>
             </a:r>
           </a:p>
           <a:p>
@@ -1380,7 +1353,7 @@
           <a:lstStyle/>
           <a:p>
             <a:r>
-              <a:t>I-DO — the diagnostic outcome, and the set-up for Quiz 4 Q2. Teach the reading protocol: always plot BOTH curves — training loss (teal, on data the model learns from) and validation loss (red dashed, on held-out data it never trains on). Three signatures. Underfitting: both curves stuck high and close — the model literally cannot fit the data yet (too small/simple or trained too briefly); the fix is MORE capacity or MORE training, not less. Just right: both fall low and stay close — validation follows training down; the target. Overfitting: training loss keeps dropping toward zero while validation bottoms out then climbs — the model is memorizing the training set's noise; the amber dot marks where validation was best. The one number to watch is the GAP: small and stable is healthy, wide and growing is overfitting. Next slide you diagnose four curves yourself, and one of them is a different problem entirely — Quiz 4 Q2.</a:t>
+              <a:t>Lead Part 3 with the picture everyone pictures for over/underfitting — more intuitive than loss curves, so it comes first. Same seven noisy points in all three panels; only the model differs. Left, underfitting: a straight line, too simple to bend with the data, so it misses the obvious trend ("high bias"). Middle, just right: a smooth curve that follows the underlying trend while ignoring the little up-and-down jitter — that jitter is noise, not signal. Right, overfitting: a wiggly curve contorted to pass exactly through every point, including the noise; it scores perfectly on these seven yet lurches wildly between them, so on the very next measurement it will be badly wrong. Say the lesson plainly: a perfect score on the training points is not the goal — capturing the trend that transfers to new data is. This is exactly the spectra story coming two slides on, and it is what the loss curves next detect.</a:t>
             </a:r>
           </a:p>
           <a:p>
@@ -1453,7 +1426,7 @@
           <a:lstStyle/>
           <a:p>
             <a:r>
-              <a:t>YOU-DO = Quiz 4 Q2 (the same four pairs as the sheet, tagged a–d). Answers: (a) UNDERFITTING → make the model bigger / train longer — both curves sit high and close and barely move, so it hasn't fit even the training data yet. (b) JUST RIGHT → keep it (ship it) — both drop low and stay close with only a small gap. (c) OVERFITTING → regularize — training loss keeps falling toward zero while validation turns back up (the dot marks the best epoch); add dropout / weight decay, stop early, or get more/varied data. (d) LEARNING RATE FAR TOO HIGH → lower it — the (training) loss swings wildly and CLIMBS; the steps are overshooting, a bad-LR problem, not a capacity or memorizing problem. The tell that separates (c) from the rest: only in (c) do the two curves SPLIT APART — training good, validation bad. Harvest a couple of pairs, then have them fill Q2.</a:t>
+              <a:t>I-DO — the diagnostic outcome, and the set-up for Quiz 4 Q2. Teach the reading protocol: always plot BOTH curves — training loss (teal, on data the model learns from) and validation loss (red dashed, on held-out data it never trains on). Three signatures. Underfitting: both curves stuck high and close — the model literally cannot fit the data yet (too small/simple or trained too briefly); the fix is MORE capacity or MORE training, not less. Just right: both fall low and stay close — validation follows training down; the target. Overfitting: training loss keeps dropping toward zero while validation bottoms out then climbs — the model is memorizing the training set's noise; the amber dot marks where validation was best. The one number to watch is the GAP: small and stable is healthy, wide and growing is overfitting. Next slide you diagnose four curves yourself, and one of them is a different problem entirely — Quiz 4 Q2.</a:t>
             </a:r>
           </a:p>
           <a:p>
@@ -1526,7 +1499,7 @@
           <a:lstStyle/>
           <a:p>
             <a:r>
-              <a:t>Ground the abstract idea in their reality, then run a fast show-of-hands (kept to ~30 seconds, not a full turn-to-neighbour, so Part 3's three interactive beats don't crowd out the 0:55 quiz-walkthrough slot — the graded pair discussion is Q5 just ahead). The mass-spec anchor: a network trained on spectra from a single instrument can reach near-perfect training accuracy by latching onto that instrument's fingerprint — its particular baseline drift, detector noise, calibration offset — none of which is the biological signal. It looks brilliant until you deploy on another machine or another site's reagent lot, where those quirks differ, and accuracy craters. Foreshadow Lecture 10's cautionary tale (DRIAMS models losing AUROC across sites). The real MALDI-TOF spectra on the left (Wikimedia, CC BY 4.0) are the "one instrument's output" the model must not memorize. Prompt: 99% train, 70% new — classic overfitting; two minutes. Harvest answers and validate the whole toolkit coming up: more / more-varied data (multiple instruments!), regularization (dropout, weight decay), early stopping, a simpler model — and always evaluate on a truly held-out, ideally external, set. No single right answer; the point is they now reach for these tools.</a:t>
+              <a:t>YOU-DO = Quiz 4 Q2 (the same four pairs as the sheet, tagged a–d). Answers: (a) UNDERFITTING → make the model bigger / train longer — both curves sit high and close and barely move, so it hasn't fit even the training data yet. (b) JUST RIGHT → keep it (ship it) — both drop low and stay close with only a small gap. (c) OVERFITTING → regularize — training loss keeps falling toward zero while validation turns back up (the dot marks the best epoch); add dropout / weight decay, stop early, or get more/varied data. (d) LEARNING RATE FAR TOO HIGH → lower it — the (training) loss swings wildly and CLIMBS; the steps are overshooting, a bad-LR problem, not a capacity or memorizing problem. The tell that separates (c) from the rest: only in (c) do the two curves SPLIT APART — training good, validation bad. Harvest a couple of pairs, then have them fill Q2.</a:t>
             </a:r>
           </a:p>
           <a:p>
@@ -1992,52 +1965,6 @@
 </p:notes>
 </file>
 
-<file path=ppt/notesSlides/notesSlide30.xml><?xml version="1.0" encoding="utf-8"?>
-<p:notes xmlns:a="http://schemas.openxmlformats.org/drawingml/2006/main" xmlns:p="http://schemas.openxmlformats.org/presentationml/2006/main" xmlns:r="http://schemas.openxmlformats.org/officeDocument/2006/relationships">
-  <p:cSld>
-    <p:spTree>
-      <p:nvGrpSpPr>
-        <p:cNvPr id="1" name=""/>
-        <p:cNvGrpSpPr/>
-        <p:nvPr/>
-      </p:nvGrpSpPr>
-      <p:grpSpPr>
-        <a:xfrm>
-          <a:off x="0" y="0"/>
-          <a:ext cx="0" cy="0"/>
-          <a:chOff x="0" y="0"/>
-          <a:chExt cx="0" cy="0"/>
-        </a:xfrm>
-      </p:grpSpPr>
-      <p:sp>
-        <p:nvSpPr>
-          <p:cNvPr id="3" name="Notes Placeholder 2"/>
-          <p:cNvSpPr>
-            <a:spLocks noGrp="1"/>
-          </p:cNvSpPr>
-          <p:nvPr>
-            <p:ph type="body" sz="quarter" idx="3"/>
-          </p:nvPr>
-        </p:nvSpPr>
-        <p:spPr/>
-        <p:txBody>
-          <a:bodyPr/>
-          <a:lstStyle/>
-          <a:p>
-            <a:r>
-              <a:t>YOU-DO = Quiz 4 Q4, straight after the whisper-down-the-lane I-do. Worked answer: (a) 1.0×0.5^5=0.5^5=0.03125≈0.03. (b) Vanishing — every factor is below 1, so the product shrinks fast. (c) The gradient reaching the earliest layers is almost zero, so those layers barely update / learn while layers near the output learn fine — which is why very deep plain networks are hard to train (the fix, ResNet skip connections, is Lecture 5). If each slope were instead about 2, the product 2^5=32 would explode and the loss would go to NaN.</a:t>
-            </a:r>
-          </a:p>
-        </p:txBody>
-      </p:sp>
-    </p:spTree>
-  </p:cSld>
-  <p:clrMapOvr>
-    <a:masterClrMapping/>
-  </p:clrMapOvr>
-</p:notes>
-</file>
-
 <file path=ppt/notesSlides/notesSlide4.xml><?xml version="1.0" encoding="utf-8"?>
 <p:notes xmlns:a="http://schemas.openxmlformats.org/drawingml/2006/main" xmlns:r="http://schemas.openxmlformats.org/officeDocument/2006/relationships" xmlns:p="http://schemas.openxmlformats.org/presentationml/2006/main">
   <p:cSld>
@@ -2302,11 +2229,28 @@
           <a:lstStyle/>
           <a:p>
             <a:r>
-              <a:t>The worked example — concrete numbers, straight from the formula. The truth is R (resistant). Model A puts 0.90 on R, so CE = −ln(0.90) = 0.105 — tiny. Model B ALSO calls R — it puts 0.55 on R and 0.45 on S, so its argmax is still R and accuracy counts it "correct" too — but it barely committed; CE = −ln(0.55) = 0.598, about 5.7 times larger. Both numbers come straight from the previous slide's formula CE = −ln(p_true) — exact, not eyeballed. Say the takeaway aloud: accuracy sees only the call (both R), so it cannot tell the sure bet from the hedge — cross-entropy grades the confidence and does, which is why we train on it. Close with the one-line rule of thumb and note a relative, focal loss, tilts this toward rare/hard cases — we meet it again under class imbalance. Leave the two penalties blank on the next slide — that is the you-do (Quiz 4 Q1): the room plugs 0.8 and 0.2 into −ln(p_true), then Part 2's knobs make training converge.</a:t>
-            </a:r>
-          </a:p>
-          <a:p>
-            <a:endParaRPr/>
+              <a:rPr dirty="0"/>
+              <a:t>The worked example — concrete numbers, straight from the formula. The truth is R (resistant). Model A puts 0.90 on R, so CE = −ln(0.90) = 0.105 — tiny. Model B ALSO calls R — it puts 0.55 on R and 0.45 on S, so its argmax is still R and accuracy counts it "correct" too — but it barely committed; CE = −ln(0.55) = 0.598, about 5.7 times larger. Both numbers come straight from the previous slide's formula CE = −ln(</a:t>
+            </a:r>
+            <a:r>
+              <a:rPr dirty="0" err="1"/>
+              <a:t>p_true</a:t>
+            </a:r>
+            <a:r>
+              <a:rPr dirty="0"/>
+              <a:t>) — exact, not eyeballed. Say the takeaway aloud: accuracy sees only the call (both R), so it cannot tell the sure bet from the hedge — cross-entropy grades the confidence and does, which is why we train on it. Close with the one-line rule of thumb and note a relative, focal loss, tilts this toward rare/hard cases — we meet it again under class imbalance. Leave the two penalties blank on the next slide — that is the you-do (Quiz 4 Q1): the room plugs 0.8 and 0.2 into −ln(</a:t>
+            </a:r>
+            <a:r>
+              <a:rPr dirty="0" err="1"/>
+              <a:t>p_true</a:t>
+            </a:r>
+            <a:r>
+              <a:rPr dirty="0"/>
+              <a:t>), then Part 2's knobs make training converge.</a:t>
+            </a:r>
+          </a:p>
+          <a:p>
+            <a:endParaRPr dirty="0"/>
           </a:p>
         </p:txBody>
       </p:sp>
@@ -3697,7 +3641,7 @@
           <a:lstStyle/>
           <a:p>
             <a:r>
-              <a:rPr sz="4400" b="1" i="0">
+              <a:rPr sz="4400" b="1" i="0" dirty="0">
                 <a:solidFill>
                   <a:srgbClr val="1B2025"/>
                 </a:solidFill>
@@ -3713,7 +3657,7 @@
               </a:spcBef>
             </a:pPr>
             <a:r>
-              <a:rPr sz="2200" b="0" i="0">
+              <a:rPr sz="2200" b="0" i="0" dirty="0">
                 <a:solidFill>
                   <a:srgbClr val="0E7C7B"/>
                 </a:solidFill>
@@ -3975,7 +3919,7 @@
           <a:p>
             <a:pPr algn="ctr"/>
             <a:r>
-              <a:rPr sz="1200" b="1" i="0">
+              <a:rPr sz="1200" b="1" i="0" dirty="0">
                 <a:solidFill>
                   <a:srgbClr val="E09E2F"/>
                 </a:solidFill>
@@ -3984,13 +3928,31 @@
               <a:t>CHECKPOINT · </a:t>
             </a:r>
             <a:r>
-              <a:rPr sz="1700" b="0" i="0">
+              <a:rPr sz="1700" b="0" i="0" dirty="0">
                 <a:solidFill>
                   <a:srgbClr val="3D444C"/>
                 </a:solidFill>
                 <a:latin typeface="Avenir Next"/>
               </a:rPr>
-              <a:t>Your turn → Quiz 4, Q1. (a) Predicting an oxacillin MIC (a NUMBER) vs. calling R/S (a CLASS) — which loss for each? (b) Truth is R: Model A put 0.8 on R, Model B put 0.2 — use CE = −ln(p_true) to compute each loss; which is bigger? Worked answer in the notes.</a:t>
+              <a:t>Your turn → Quiz 4, Q1. (a) Predicting an oxacillin MIC (a NUMBER) vs. calling R/S (a CLASS) — which loss for each? (b) Truth is R: Model A put 0.8 on R, Model B put 0.2 — use CE = −ln(</a:t>
+            </a:r>
+            <a:r>
+              <a:rPr sz="1700" b="0" i="0" dirty="0" err="1">
+                <a:solidFill>
+                  <a:srgbClr val="3D444C"/>
+                </a:solidFill>
+                <a:latin typeface="Avenir Next"/>
+              </a:rPr>
+              <a:t>p_true</a:t>
+            </a:r>
+            <a:r>
+              <a:rPr sz="1700" b="0" i="0" dirty="0">
+                <a:solidFill>
+                  <a:srgbClr val="3D444C"/>
+                </a:solidFill>
+                <a:latin typeface="Avenir Next"/>
+              </a:rPr>
+              <a:t>) to compute each loss; which is bigger? Worked answer in the notes.</a:t>
             </a:r>
           </a:p>
         </p:txBody>
@@ -4370,8 +4332,8 @@
         </p:nvSpPr>
         <p:spPr>
           <a:xfrm>
-            <a:off x="777240" y="1167016"/>
-            <a:ext cx="10515600" cy="841248"/>
+            <a:off x="777240" y="1471047"/>
+            <a:ext cx="10515600" cy="490157"/>
           </a:xfrm>
           <a:prstGeom prst="rect">
             <a:avLst/>
@@ -4799,13 +4761,31 @@
           <a:p>
             <a:pPr algn="ctr"/>
             <a:r>
-              <a:rPr sz="1700" b="0" i="0">
+              <a:rPr sz="1700" b="0" i="0" dirty="0">
                 <a:solidFill>
                   <a:srgbClr val="3D444C"/>
                 </a:solidFill>
                 <a:latin typeface="Avenir Next"/>
               </a:rPr>
-              <a:t>Split the data into mini-batches (say 32) and take one step after EACH batch — don't wait to see all the data. This is mini-batch SGD, a data-feeding choice, not an optimizer. 20 batches = 20 updates per epoch (vs. 1 for full-batch): faster, and the noise finds flatter, better-generalizing solutions.</a:t>
+              <a:t>Split the data into mini-batches (say 32) and take one step after EACH batch — don't wait to see all the data. This is mini-batch SGD, a data-feeding choice, not an optimizer. 20 batches = 20 updates per </a:t>
+            </a:r>
+            <a:r>
+              <a:rPr sz="1700" b="1" i="0" dirty="0">
+                <a:solidFill>
+                  <a:srgbClr val="3D444C"/>
+                </a:solidFill>
+                <a:latin typeface="Avenir Next"/>
+              </a:rPr>
+              <a:t>epoch</a:t>
+            </a:r>
+            <a:r>
+              <a:rPr sz="1700" b="0" i="0" dirty="0">
+                <a:solidFill>
+                  <a:srgbClr val="3D444C"/>
+                </a:solidFill>
+                <a:latin typeface="Avenir Next"/>
+              </a:rPr>
+              <a:t> (vs. 1 for full-batch): faster, and the noise finds flatter, better-generalizing solutions.</a:t>
             </a:r>
           </a:p>
         </p:txBody>
@@ -5831,137 +5811,32 @@
           <a:chExt cx="0" cy="0"/>
         </a:xfrm>
       </p:grpSpPr>
-      <p:sp>
-        <p:nvSpPr>
-          <p:cNvPr id="2" name="Rectangle 1"/>
-          <p:cNvSpPr/>
-          <p:nvPr/>
-        </p:nvSpPr>
-        <p:spPr>
-          <a:xfrm>
-            <a:off x="0" y="0"/>
-            <a:ext cx="12191695" cy="6858000"/>
-          </a:xfrm>
-          <a:prstGeom prst="rect">
-            <a:avLst/>
-          </a:prstGeom>
-          <a:solidFill>
-            <a:srgbClr val="FBFBF8"/>
-          </a:solidFill>
-          <a:ln>
-            <a:noFill/>
-          </a:ln>
-          <a:effectLst/>
-        </p:spPr>
-        <p:style>
-          <a:lnRef idx="1">
-            <a:schemeClr val="accent1"/>
-          </a:lnRef>
-          <a:fillRef idx="3">
-            <a:schemeClr val="accent1"/>
-          </a:fillRef>
-          <a:effectRef idx="2">
-            <a:schemeClr val="accent1"/>
-          </a:effectRef>
-          <a:fontRef idx="minor">
-            <a:schemeClr val="lt1"/>
-          </a:fontRef>
-        </p:style>
-        <p:txBody>
-          <a:bodyPr rtlCol="0" anchor="ctr"/>
-          <a:lstStyle/>
-          <a:p>
-            <a:pPr algn="ctr"/>
-            <a:endParaRPr/>
-          </a:p>
-        </p:txBody>
-      </p:sp>
-      <p:sp>
-        <p:nvSpPr>
-          <p:cNvPr id="3" name="TextBox 2"/>
-          <p:cNvSpPr txBox="1"/>
-          <p:nvPr/>
-        </p:nvSpPr>
-        <p:spPr>
-          <a:xfrm>
-            <a:off x="548640" y="320040"/>
-            <a:ext cx="10972800" cy="365760"/>
-          </a:xfrm>
-          <a:prstGeom prst="rect">
-            <a:avLst/>
-          </a:prstGeom>
-          <a:noFill/>
-        </p:spPr>
-        <p:txBody>
-          <a:bodyPr wrap="square" anchor="t">
-            <a:spAutoFit/>
-          </a:bodyPr>
-          <a:lstStyle/>
-          <a:p>
-            <a:r>
-              <a:rPr sz="1300" b="1" i="0">
-                <a:solidFill>
-                  <a:srgbClr val="8A9099"/>
-                </a:solidFill>
-                <a:latin typeface="Menlo"/>
-              </a:rPr>
-              <a:t>PART 2 · TUNING · WHY DEEP NETS ARE HARDER (I-DO)</a:t>
-            </a:r>
-          </a:p>
-        </p:txBody>
-      </p:sp>
-      <p:sp>
-        <p:nvSpPr>
-          <p:cNvPr id="4" name="TextBox 3"/>
-          <p:cNvSpPr txBox="1"/>
-          <p:nvPr/>
-        </p:nvSpPr>
-        <p:spPr>
-          <a:xfrm>
-            <a:off x="548640" y="731520"/>
-            <a:ext cx="11064240" cy="1127760"/>
-          </a:xfrm>
-          <a:prstGeom prst="rect">
-            <a:avLst/>
-          </a:prstGeom>
-          <a:noFill/>
-        </p:spPr>
-        <p:txBody>
-          <a:bodyPr wrap="square" anchor="t">
-            <a:spAutoFit/>
-          </a:bodyPr>
-          <a:lstStyle/>
-          <a:p>
-            <a:r>
-              <a:rPr sz="3400" b="1" i="0">
-                <a:solidFill>
-                  <a:srgbClr val="1B2025"/>
-                </a:solidFill>
-                <a:latin typeface="Avenir Next"/>
-              </a:rPr>
-              <a:t>Whisper down the lane: the gradient fades or blows up</a:t>
-            </a:r>
-          </a:p>
-        </p:txBody>
-      </p:sp>
       <p:pic>
         <p:nvPicPr>
-          <p:cNvPr id="5" name="Picture 4" descr="fig_vanishing_ido.png"/>
+          <p:cNvPr id="5" name="Content Placeholder 4" descr="AI generated image">
+            <a:extLst>
+              <a:ext uri="{FF2B5EF4-FFF2-40B4-BE49-F238E27FC236}">
+                <a16:creationId xmlns:a16="http://schemas.microsoft.com/office/drawing/2014/main" id="{3E5E982F-B207-0BED-1CB8-8B28F85AB7AE}"/>
+              </a:ext>
+            </a:extLst>
+          </p:cNvPr>
           <p:cNvPicPr>
-            <a:picLocks noChangeAspect="1"/>
+            <a:picLocks noGrp="1" noChangeAspect="1"/>
           </p:cNvPicPr>
-          <p:nvPr/>
+          <p:nvPr>
+            <p:ph idx="1"/>
+          </p:nvPr>
         </p:nvPicPr>
         <p:blipFill>
-          <a:blip r:embed="rId3"/>
+          <a:blip r:embed="rId2"/>
           <a:stretch>
             <a:fillRect/>
           </a:stretch>
         </p:blipFill>
         <p:spPr>
           <a:xfrm>
-            <a:off x="1135330" y="1828800"/>
-            <a:ext cx="9890860" cy="3200400"/>
+            <a:off x="855567" y="821124"/>
+            <a:ext cx="10480865" cy="5716836"/>
           </a:xfrm>
           <a:prstGeom prst="rect">
             <a:avLst/>
@@ -5970,60 +5845,44 @@
       </p:pic>
       <p:sp>
         <p:nvSpPr>
-          <p:cNvPr id="6" name="Rectangle 5"/>
-          <p:cNvSpPr/>
-          <p:nvPr/>
-        </p:nvSpPr>
-        <p:spPr>
-          <a:xfrm>
-            <a:off x="548640" y="5120640"/>
-            <a:ext cx="10515600" cy="1182624"/>
-          </a:xfrm>
-          <a:prstGeom prst="rect">
-            <a:avLst/>
-          </a:prstGeom>
-          <a:solidFill>
-            <a:srgbClr val="F1F1EC"/>
-          </a:solidFill>
-          <a:ln w="12700">
-            <a:solidFill>
-              <a:srgbClr val="3D444C"/>
-            </a:solidFill>
-          </a:ln>
-          <a:effectLst/>
-        </p:spPr>
-        <p:style>
-          <a:lnRef idx="1">
-            <a:schemeClr val="accent1"/>
-          </a:lnRef>
-          <a:fillRef idx="3">
-            <a:schemeClr val="accent1"/>
-          </a:fillRef>
-          <a:effectRef idx="2">
-            <a:schemeClr val="accent1"/>
-          </a:effectRef>
-          <a:fontRef idx="minor">
-            <a:schemeClr val="lt1"/>
-          </a:fontRef>
-        </p:style>
-        <p:txBody>
-          <a:bodyPr wrap="square" lIns="182880" rIns="182880" rtlCol="0" anchor="ctr"/>
-          <a:lstStyle/>
-          <a:p>
-            <a:pPr algn="ctr"/>
-            <a:r>
-              <a:rPr sz="1700" b="0" i="0">
-                <a:solidFill>
-                  <a:srgbClr val="3D444C"/>
-                </a:solidFill>
-                <a:latin typeface="Avenir Next"/>
-              </a:rPr>
-              <a:t>From Lecture 2: a weight's gradient is the PRODUCT of the local slopes along its path back from the loss. In a deep net that path crosses every layer — so a factor a bit below 1 shrinks the gradient to nothing (vanishing), and a bit above 1 blows it up (exploding). No optimizer fully fixes this.</a:t>
+          <p:cNvPr id="4" name="Text Placeholder 3">
+            <a:extLst>
+              <a:ext uri="{FF2B5EF4-FFF2-40B4-BE49-F238E27FC236}">
+                <a16:creationId xmlns:a16="http://schemas.microsoft.com/office/drawing/2014/main" id="{3F502917-3E6B-C657-CF90-6B2F79E96246}"/>
+              </a:ext>
+            </a:extLst>
+          </p:cNvPr>
+          <p:cNvSpPr>
+            <a:spLocks noGrp="1"/>
+          </p:cNvSpPr>
+          <p:nvPr>
+            <p:ph type="body" sz="quarter" idx="13"/>
+          </p:nvPr>
+        </p:nvSpPr>
+        <p:spPr/>
+        <p:txBody>
+          <a:bodyPr>
+            <a:normAutofit/>
+          </a:bodyPr>
+          <a:lstStyle/>
+          <a:p>
+            <a:r>
+              <a:rPr lang="en-US" dirty="0">
+                <a:solidFill>
+                  <a:srgbClr val="8A9099"/>
+                </a:solidFill>
+              </a:rPr>
+              <a:t>PART 2 · TUNING · WHY DEEP NETS ARE HARDER (I-DO)</a:t>
             </a:r>
           </a:p>
         </p:txBody>
       </p:sp>
     </p:spTree>
+    <p:extLst>
+      <p:ext uri="{BB962C8B-B14F-4D97-AF65-F5344CB8AC3E}">
+        <p14:creationId xmlns:p14="http://schemas.microsoft.com/office/powerpoint/2010/main" val="1927233508"/>
+      </p:ext>
+    </p:extLst>
   </p:cSld>
   <p:clrMapOvr>
     <a:masterClrMapping/>
@@ -6496,7 +6355,7 @@
 </file>
 
 <file path=ppt/slides/slide20.xml><?xml version="1.0" encoding="utf-8"?>
-<p:sld xmlns:a="http://schemas.openxmlformats.org/drawingml/2006/main" xmlns:p="http://schemas.openxmlformats.org/presentationml/2006/main" xmlns:r="http://schemas.openxmlformats.org/officeDocument/2006/relationships">
+<p:sld xmlns:a="http://schemas.openxmlformats.org/drawingml/2006/main" xmlns:r="http://schemas.openxmlformats.org/officeDocument/2006/relationships" xmlns:p="http://schemas.openxmlformats.org/presentationml/2006/main">
   <p:cSld>
     <p:spTree>
       <p:nvGrpSpPr>
@@ -6504,7 +6363,14 @@
         <p:cNvGrpSpPr/>
         <p:nvPr/>
       </p:nvGrpSpPr>
-      <p:grpSpPr/>
+      <p:grpSpPr>
+        <a:xfrm>
+          <a:off x="0" y="0"/>
+          <a:ext cx="0" cy="0"/>
+          <a:chOff x="0" y="0"/>
+          <a:chExt cx="0" cy="0"/>
+        </a:xfrm>
+      </p:grpSpPr>
       <p:sp>
         <p:nvSpPr>
           <p:cNvPr id="2" name="Rectangle 1"/>
@@ -6573,13 +6439,13 @@
           <a:lstStyle/>
           <a:p>
             <a:r>
-              <a:rPr sz="1300" b="1" i="0">
+              <a:rPr sz="1300" b="1" i="0" dirty="0">
                 <a:solidFill>
                   <a:srgbClr val="8A9099"/>
                 </a:solidFill>
                 <a:latin typeface="Menlo"/>
               </a:rPr>
-              <a:t>PART 2 · TUNING · YOUR TURN (YOU-DO = Q4)</a:t>
+              <a:t>PART 2 · TUNING · WHY DEEP NETS ARE HARDER (I-DO)</a:t>
             </a:r>
           </a:p>
         </p:txBody>
@@ -6593,7 +6459,7 @@
         <p:spPr>
           <a:xfrm>
             <a:off x="548640" y="731520"/>
-            <a:ext cx="11064240" cy="1005840"/>
+            <a:ext cx="11064240" cy="1127760"/>
           </a:xfrm>
           <a:prstGeom prst="rect">
             <a:avLst/>
@@ -6613,11 +6479,35 @@
                 </a:solidFill>
                 <a:latin typeface="Avenir Next"/>
               </a:rPr>
-              <a:t>Your turn — what gradient reaches layer 1?</a:t>
-            </a:r>
-          </a:p>
-        </p:txBody>
-      </p:sp>
+              <a:t>Whisper down the lane: the gradient fades or blows up</a:t>
+            </a:r>
+          </a:p>
+        </p:txBody>
+      </p:sp>
+      <p:pic>
+        <p:nvPicPr>
+          <p:cNvPr id="5" name="Picture 4" descr="fig_vanishing_ido.png"/>
+          <p:cNvPicPr>
+            <a:picLocks noChangeAspect="1"/>
+          </p:cNvPicPr>
+          <p:nvPr/>
+        </p:nvPicPr>
+        <p:blipFill>
+          <a:blip r:embed="rId3"/>
+          <a:stretch>
+            <a:fillRect/>
+          </a:stretch>
+        </p:blipFill>
+        <p:spPr>
+          <a:xfrm>
+            <a:off x="1135330" y="1828800"/>
+            <a:ext cx="9890860" cy="3200400"/>
+          </a:xfrm>
+          <a:prstGeom prst="rect">
+            <a:avLst/>
+          </a:prstGeom>
+        </p:spPr>
+      </p:pic>
       <p:sp>
         <p:nvSpPr>
           <p:cNvPr id="6" name="Rectangle 5"/>
@@ -6626,7 +6516,7 @@
         </p:nvSpPr>
         <p:spPr>
           <a:xfrm>
-            <a:off x="548640" y="5538216"/>
+            <a:off x="548640" y="5120640"/>
             <a:ext cx="10515600" cy="1182624"/>
           </a:xfrm>
           <a:prstGeom prst="rect">
@@ -6637,7 +6527,7 @@
           </a:solidFill>
           <a:ln w="12700">
             <a:solidFill>
-              <a:srgbClr val="E09E2F"/>
+              <a:srgbClr val="3D444C"/>
             </a:solidFill>
           </a:ln>
           <a:effectLst/>
@@ -6662,757 +6552,13 @@
           <a:p>
             <a:pPr algn="ctr"/>
             <a:r>
-              <a:rPr sz="1200" b="1" i="0">
-                <a:solidFill>
-                  <a:srgbClr val="E09E2F"/>
-                </a:solidFill>
-                <a:latin typeface="Menlo"/>
-              </a:rPr>
-              <a:t>CHECKPOINT · </a:t>
-            </a:r>
-            <a:r>
               <a:rPr sz="1700" b="0" i="0">
                 <a:solidFill>
                   <a:srgbClr val="3D444C"/>
                 </a:solidFill>
                 <a:latin typeface="Avenir Next"/>
               </a:rPr>
-              <a:t>Your turn → Quiz 4, Q4. Multiply the slopes down the chain: 1.0 leaves the loss and is multiplied by 0.5 at each of 5 layers. (a) What reaches layer 1? (b) Vanishing or exploding? (c) What does that mean for the earliest layers? Worked answer in the notes.</a:t>
-            </a:r>
-          </a:p>
-        </p:txBody>
-      </p:sp>
-      <p:sp>
-        <p:nvSpPr>
-          <p:cNvPr id="7" name="Rounded Rectangle 6"/>
-          <p:cNvSpPr/>
-          <p:nvPr/>
-        </p:nvSpPr>
-        <p:spPr>
-          <a:xfrm>
-            <a:off x="548640" y="1908800"/>
-            <a:ext cx="1000000" cy="560000"/>
-          </a:xfrm>
-          <a:prstGeom prst="roundRect">
-            <a:avLst>
-              <a:gd name="adj" fmla="val 8000"/>
-            </a:avLst>
-          </a:prstGeom>
-          <a:solidFill>
-            <a:srgbClr val="FBF1DC"/>
-          </a:solidFill>
-          <a:ln>
-            <a:noFill/>
-          </a:ln>
-          <a:effectLst/>
-        </p:spPr>
-        <p:style>
-          <a:lnRef idx="1">
-            <a:schemeClr val="accent1"/>
-          </a:lnRef>
-          <a:fillRef idx="3">
-            <a:schemeClr val="accent1"/>
-          </a:fillRef>
-          <a:effectRef idx="2">
-            <a:schemeClr val="accent1"/>
-          </a:effectRef>
-          <a:fontRef idx="minor">
-            <a:schemeClr val="lt1"/>
-          </a:fontRef>
-        </p:style>
-        <p:txBody>
-          <a:bodyPr rtlCol="0" anchor="ctr"/>
-          <a:lstStyle/>
-          <a:p>
-            <a:pPr algn="ctr"/>
-            <a:r>
-              <a:rPr sz="1500" b="1">
-                <a:solidFill>
-                  <a:srgbClr val="1B2025"/>
-                </a:solidFill>
-                <a:latin typeface="Avenir Next"/>
-              </a:rPr>
-              <a:t>loss</a:t>
-            </a:r>
-          </a:p>
-        </p:txBody>
-      </p:sp>
-      <p:sp>
-        <p:nvSpPr>
-          <p:cNvPr id="8" name="TextBox 7"/>
-          <p:cNvSpPr txBox="1"/>
-          <p:nvPr/>
-        </p:nvSpPr>
-        <p:spPr>
-          <a:xfrm>
-            <a:off x="97080" y="2488800"/>
-            <a:ext cx="1903120" cy="330000"/>
-          </a:xfrm>
-          <a:prstGeom prst="rect">
-            <a:avLst/>
-          </a:prstGeom>
-          <a:noFill/>
-        </p:spPr>
-        <p:txBody>
-          <a:bodyPr wrap="square" lIns="45720" rIns="45720" tIns="27432" bIns="27432" anchor="t">
-            <a:spAutoFit/>
-          </a:bodyPr>
-          <a:lstStyle/>
-          <a:p>
-            <a:pPr algn="ctr">
-              <a:spcAft>
-                <a:spcPts val="400"/>
-              </a:spcAft>
-            </a:pPr>
-            <a:r>
-              <a:rPr sz="1400" b="1">
-                <a:solidFill>
-                  <a:srgbClr val="3D444C"/>
-                </a:solidFill>
-                <a:latin typeface="Avenir Next"/>
-              </a:rPr>
-              <a:t>gradient 1.0</a:t>
-            </a:r>
-          </a:p>
-        </p:txBody>
-      </p:sp>
-      <p:sp>
-        <p:nvSpPr>
-          <p:cNvPr id="9" name="TextBox 8"/>
-          <p:cNvSpPr txBox="1"/>
-          <p:nvPr/>
-        </p:nvSpPr>
-        <p:spPr>
-          <a:xfrm>
-            <a:off x="1548640" y="1968800"/>
-            <a:ext cx="903120" cy="440000"/>
-          </a:xfrm>
-          <a:prstGeom prst="rect">
-            <a:avLst/>
-          </a:prstGeom>
-          <a:noFill/>
-        </p:spPr>
-        <p:txBody>
-          <a:bodyPr wrap="square" lIns="45720" rIns="45720" tIns="27432" bIns="27432" anchor="ctr">
-            <a:spAutoFit/>
-          </a:bodyPr>
-          <a:lstStyle/>
-          <a:p>
-            <a:pPr algn="ctr">
-              <a:spcAft>
-                <a:spcPts val="400"/>
-              </a:spcAft>
-            </a:pPr>
-            <a:r>
-              <a:rPr sz="1500" b="1">
-                <a:solidFill>
-                  <a:srgbClr val="0E7C7B"/>
-                </a:solidFill>
-                <a:latin typeface="Menlo"/>
-              </a:rPr>
-              <a:t>× 0.5</a:t>
-            </a:r>
-          </a:p>
-        </p:txBody>
-      </p:sp>
-      <p:sp>
-        <p:nvSpPr>
-          <p:cNvPr id="10" name="Rounded Rectangle 9"/>
-          <p:cNvSpPr/>
-          <p:nvPr/>
-        </p:nvSpPr>
-        <p:spPr>
-          <a:xfrm>
-            <a:off x="2451760" y="1908800"/>
-            <a:ext cx="1000000" cy="560000"/>
-          </a:xfrm>
-          <a:prstGeom prst="roundRect">
-            <a:avLst>
-              <a:gd name="adj" fmla="val 8000"/>
-            </a:avLst>
-          </a:prstGeom>
-          <a:solidFill>
-            <a:srgbClr val="E3F0EF"/>
-          </a:solidFill>
-          <a:ln>
-            <a:noFill/>
-          </a:ln>
-          <a:effectLst/>
-        </p:spPr>
-        <p:style>
-          <a:lnRef idx="1">
-            <a:schemeClr val="accent1"/>
-          </a:lnRef>
-          <a:fillRef idx="3">
-            <a:schemeClr val="accent1"/>
-          </a:fillRef>
-          <a:effectRef idx="2">
-            <a:schemeClr val="accent1"/>
-          </a:effectRef>
-          <a:fontRef idx="minor">
-            <a:schemeClr val="lt1"/>
-          </a:fontRef>
-        </p:style>
-        <p:txBody>
-          <a:bodyPr rtlCol="0" anchor="ctr"/>
-          <a:lstStyle/>
-          <a:p>
-            <a:pPr algn="ctr"/>
-            <a:r>
-              <a:rPr sz="1500" b="1">
-                <a:solidFill>
-                  <a:srgbClr val="1B2025"/>
-                </a:solidFill>
-                <a:latin typeface="Avenir Next"/>
-              </a:rPr>
-              <a:t>layer 5</a:t>
-            </a:r>
-          </a:p>
-        </p:txBody>
-      </p:sp>
-      <p:sp>
-        <p:nvSpPr>
-          <p:cNvPr id="11" name="TextBox 10"/>
-          <p:cNvSpPr txBox="1"/>
-          <p:nvPr/>
-        </p:nvSpPr>
-        <p:spPr>
-          <a:xfrm>
-            <a:off x="3451760" y="1968800"/>
-            <a:ext cx="903120" cy="440000"/>
-          </a:xfrm>
-          <a:prstGeom prst="rect">
-            <a:avLst/>
-          </a:prstGeom>
-          <a:noFill/>
-        </p:spPr>
-        <p:txBody>
-          <a:bodyPr wrap="square" lIns="45720" rIns="45720" tIns="27432" bIns="27432" anchor="ctr">
-            <a:spAutoFit/>
-          </a:bodyPr>
-          <a:lstStyle/>
-          <a:p>
-            <a:pPr algn="ctr">
-              <a:spcAft>
-                <a:spcPts val="400"/>
-              </a:spcAft>
-            </a:pPr>
-            <a:r>
-              <a:rPr sz="1500" b="1">
-                <a:solidFill>
-                  <a:srgbClr val="0E7C7B"/>
-                </a:solidFill>
-                <a:latin typeface="Menlo"/>
-              </a:rPr>
-              <a:t>× 0.5</a:t>
-            </a:r>
-          </a:p>
-        </p:txBody>
-      </p:sp>
-      <p:sp>
-        <p:nvSpPr>
-          <p:cNvPr id="12" name="Rounded Rectangle 11"/>
-          <p:cNvSpPr/>
-          <p:nvPr/>
-        </p:nvSpPr>
-        <p:spPr>
-          <a:xfrm>
-            <a:off x="4354880" y="1908800"/>
-            <a:ext cx="1000000" cy="560000"/>
-          </a:xfrm>
-          <a:prstGeom prst="roundRect">
-            <a:avLst>
-              <a:gd name="adj" fmla="val 8000"/>
-            </a:avLst>
-          </a:prstGeom>
-          <a:solidFill>
-            <a:srgbClr val="E3F0EF"/>
-          </a:solidFill>
-          <a:ln>
-            <a:noFill/>
-          </a:ln>
-          <a:effectLst/>
-        </p:spPr>
-        <p:style>
-          <a:lnRef idx="1">
-            <a:schemeClr val="accent1"/>
-          </a:lnRef>
-          <a:fillRef idx="3">
-            <a:schemeClr val="accent1"/>
-          </a:fillRef>
-          <a:effectRef idx="2">
-            <a:schemeClr val="accent1"/>
-          </a:effectRef>
-          <a:fontRef idx="minor">
-            <a:schemeClr val="lt1"/>
-          </a:fontRef>
-        </p:style>
-        <p:txBody>
-          <a:bodyPr rtlCol="0" anchor="ctr"/>
-          <a:lstStyle/>
-          <a:p>
-            <a:pPr algn="ctr"/>
-            <a:r>
-              <a:rPr sz="1500" b="1">
-                <a:solidFill>
-                  <a:srgbClr val="1B2025"/>
-                </a:solidFill>
-                <a:latin typeface="Avenir Next"/>
-              </a:rPr>
-              <a:t>layer 4</a:t>
-            </a:r>
-          </a:p>
-        </p:txBody>
-      </p:sp>
-      <p:sp>
-        <p:nvSpPr>
-          <p:cNvPr id="13" name="TextBox 12"/>
-          <p:cNvSpPr txBox="1"/>
-          <p:nvPr/>
-        </p:nvSpPr>
-        <p:spPr>
-          <a:xfrm>
-            <a:off x="5354880" y="1968800"/>
-            <a:ext cx="903120" cy="440000"/>
-          </a:xfrm>
-          <a:prstGeom prst="rect">
-            <a:avLst/>
-          </a:prstGeom>
-          <a:noFill/>
-        </p:spPr>
-        <p:txBody>
-          <a:bodyPr wrap="square" lIns="45720" rIns="45720" tIns="27432" bIns="27432" anchor="ctr">
-            <a:spAutoFit/>
-          </a:bodyPr>
-          <a:lstStyle/>
-          <a:p>
-            <a:pPr algn="ctr">
-              <a:spcAft>
-                <a:spcPts val="400"/>
-              </a:spcAft>
-            </a:pPr>
-            <a:r>
-              <a:rPr sz="1500" b="1">
-                <a:solidFill>
-                  <a:srgbClr val="0E7C7B"/>
-                </a:solidFill>
-                <a:latin typeface="Menlo"/>
-              </a:rPr>
-              <a:t>× 0.5</a:t>
-            </a:r>
-          </a:p>
-        </p:txBody>
-      </p:sp>
-      <p:sp>
-        <p:nvSpPr>
-          <p:cNvPr id="14" name="Rounded Rectangle 13"/>
-          <p:cNvSpPr/>
-          <p:nvPr/>
-        </p:nvSpPr>
-        <p:spPr>
-          <a:xfrm>
-            <a:off x="6258000" y="1908800"/>
-            <a:ext cx="1000000" cy="560000"/>
-          </a:xfrm>
-          <a:prstGeom prst="roundRect">
-            <a:avLst>
-              <a:gd name="adj" fmla="val 8000"/>
-            </a:avLst>
-          </a:prstGeom>
-          <a:solidFill>
-            <a:srgbClr val="E3F0EF"/>
-          </a:solidFill>
-          <a:ln>
-            <a:noFill/>
-          </a:ln>
-          <a:effectLst/>
-        </p:spPr>
-        <p:style>
-          <a:lnRef idx="1">
-            <a:schemeClr val="accent1"/>
-          </a:lnRef>
-          <a:fillRef idx="3">
-            <a:schemeClr val="accent1"/>
-          </a:fillRef>
-          <a:effectRef idx="2">
-            <a:schemeClr val="accent1"/>
-          </a:effectRef>
-          <a:fontRef idx="minor">
-            <a:schemeClr val="lt1"/>
-          </a:fontRef>
-        </p:style>
-        <p:txBody>
-          <a:bodyPr rtlCol="0" anchor="ctr"/>
-          <a:lstStyle/>
-          <a:p>
-            <a:pPr algn="ctr"/>
-            <a:r>
-              <a:rPr sz="1500" b="1">
-                <a:solidFill>
-                  <a:srgbClr val="1B2025"/>
-                </a:solidFill>
-                <a:latin typeface="Avenir Next"/>
-              </a:rPr>
-              <a:t>layer 3</a:t>
-            </a:r>
-          </a:p>
-        </p:txBody>
-      </p:sp>
-      <p:sp>
-        <p:nvSpPr>
-          <p:cNvPr id="15" name="TextBox 14"/>
-          <p:cNvSpPr txBox="1"/>
-          <p:nvPr/>
-        </p:nvSpPr>
-        <p:spPr>
-          <a:xfrm>
-            <a:off x="7258000" y="1968800"/>
-            <a:ext cx="903120" cy="440000"/>
-          </a:xfrm>
-          <a:prstGeom prst="rect">
-            <a:avLst/>
-          </a:prstGeom>
-          <a:noFill/>
-        </p:spPr>
-        <p:txBody>
-          <a:bodyPr wrap="square" lIns="45720" rIns="45720" tIns="27432" bIns="27432" anchor="ctr">
-            <a:spAutoFit/>
-          </a:bodyPr>
-          <a:lstStyle/>
-          <a:p>
-            <a:pPr algn="ctr">
-              <a:spcAft>
-                <a:spcPts val="400"/>
-              </a:spcAft>
-            </a:pPr>
-            <a:r>
-              <a:rPr sz="1500" b="1">
-                <a:solidFill>
-                  <a:srgbClr val="0E7C7B"/>
-                </a:solidFill>
-                <a:latin typeface="Menlo"/>
-              </a:rPr>
-              <a:t>× 0.5</a:t>
-            </a:r>
-          </a:p>
-        </p:txBody>
-      </p:sp>
-      <p:sp>
-        <p:nvSpPr>
-          <p:cNvPr id="16" name="Rounded Rectangle 15"/>
-          <p:cNvSpPr/>
-          <p:nvPr/>
-        </p:nvSpPr>
-        <p:spPr>
-          <a:xfrm>
-            <a:off x="8161120" y="1908800"/>
-            <a:ext cx="1000000" cy="560000"/>
-          </a:xfrm>
-          <a:prstGeom prst="roundRect">
-            <a:avLst>
-              <a:gd name="adj" fmla="val 8000"/>
-            </a:avLst>
-          </a:prstGeom>
-          <a:solidFill>
-            <a:srgbClr val="E3F0EF"/>
-          </a:solidFill>
-          <a:ln>
-            <a:noFill/>
-          </a:ln>
-          <a:effectLst/>
-        </p:spPr>
-        <p:style>
-          <a:lnRef idx="1">
-            <a:schemeClr val="accent1"/>
-          </a:lnRef>
-          <a:fillRef idx="3">
-            <a:schemeClr val="accent1"/>
-          </a:fillRef>
-          <a:effectRef idx="2">
-            <a:schemeClr val="accent1"/>
-          </a:effectRef>
-          <a:fontRef idx="minor">
-            <a:schemeClr val="lt1"/>
-          </a:fontRef>
-        </p:style>
-        <p:txBody>
-          <a:bodyPr rtlCol="0" anchor="ctr"/>
-          <a:lstStyle/>
-          <a:p>
-            <a:pPr algn="ctr"/>
-            <a:r>
-              <a:rPr sz="1500" b="1">
-                <a:solidFill>
-                  <a:srgbClr val="1B2025"/>
-                </a:solidFill>
-                <a:latin typeface="Avenir Next"/>
-              </a:rPr>
-              <a:t>layer 2</a:t>
-            </a:r>
-          </a:p>
-        </p:txBody>
-      </p:sp>
-      <p:sp>
-        <p:nvSpPr>
-          <p:cNvPr id="17" name="TextBox 16"/>
-          <p:cNvSpPr txBox="1"/>
-          <p:nvPr/>
-        </p:nvSpPr>
-        <p:spPr>
-          <a:xfrm>
-            <a:off x="9161120" y="1968800"/>
-            <a:ext cx="903120" cy="440000"/>
-          </a:xfrm>
-          <a:prstGeom prst="rect">
-            <a:avLst/>
-          </a:prstGeom>
-          <a:noFill/>
-        </p:spPr>
-        <p:txBody>
-          <a:bodyPr wrap="square" lIns="45720" rIns="45720" tIns="27432" bIns="27432" anchor="ctr">
-            <a:spAutoFit/>
-          </a:bodyPr>
-          <a:lstStyle/>
-          <a:p>
-            <a:pPr algn="ctr">
-              <a:spcAft>
-                <a:spcPts val="400"/>
-              </a:spcAft>
-            </a:pPr>
-            <a:r>
-              <a:rPr sz="1500" b="1">
-                <a:solidFill>
-                  <a:srgbClr val="0E7C7B"/>
-                </a:solidFill>
-                <a:latin typeface="Menlo"/>
-              </a:rPr>
-              <a:t>× 0.5</a:t>
-            </a:r>
-          </a:p>
-        </p:txBody>
-      </p:sp>
-      <p:sp>
-        <p:nvSpPr>
-          <p:cNvPr id="18" name="Rounded Rectangle 17"/>
-          <p:cNvSpPr/>
-          <p:nvPr/>
-        </p:nvSpPr>
-        <p:spPr>
-          <a:xfrm>
-            <a:off x="10064240" y="1908800"/>
-            <a:ext cx="1000000" cy="560000"/>
-          </a:xfrm>
-          <a:prstGeom prst="roundRect">
-            <a:avLst>
-              <a:gd name="adj" fmla="val 8000"/>
-            </a:avLst>
-          </a:prstGeom>
-          <a:solidFill>
-            <a:srgbClr val="FBF1DC"/>
-          </a:solidFill>
-          <a:ln>
-            <a:noFill/>
-          </a:ln>
-          <a:effectLst/>
-        </p:spPr>
-        <p:style>
-          <a:lnRef idx="1">
-            <a:schemeClr val="accent1"/>
-          </a:lnRef>
-          <a:fillRef idx="3">
-            <a:schemeClr val="accent1"/>
-          </a:fillRef>
-          <a:effectRef idx="2">
-            <a:schemeClr val="accent1"/>
-          </a:effectRef>
-          <a:fontRef idx="minor">
-            <a:schemeClr val="lt1"/>
-          </a:fontRef>
-        </p:style>
-        <p:txBody>
-          <a:bodyPr rtlCol="0" anchor="ctr"/>
-          <a:lstStyle/>
-          <a:p>
-            <a:pPr algn="ctr"/>
-            <a:r>
-              <a:rPr sz="1500" b="1">
-                <a:solidFill>
-                  <a:srgbClr val="1B2025"/>
-                </a:solidFill>
-                <a:latin typeface="Avenir Next"/>
-              </a:rPr>
-              <a:t>layer 1</a:t>
-            </a:r>
-          </a:p>
-        </p:txBody>
-      </p:sp>
-      <p:sp>
-        <p:nvSpPr>
-          <p:cNvPr id="19" name="TextBox 18"/>
-          <p:cNvSpPr txBox="1"/>
-          <p:nvPr/>
-        </p:nvSpPr>
-        <p:spPr>
-          <a:xfrm>
-            <a:off x="9612680" y="2488800"/>
-            <a:ext cx="1903120" cy="330000"/>
-          </a:xfrm>
-          <a:prstGeom prst="rect">
-            <a:avLst/>
-          </a:prstGeom>
-          <a:noFill/>
-        </p:spPr>
-        <p:txBody>
-          <a:bodyPr wrap="square" lIns="45720" rIns="45720" tIns="27432" bIns="27432" anchor="t">
-            <a:spAutoFit/>
-          </a:bodyPr>
-          <a:lstStyle/>
-          <a:p>
-            <a:pPr algn="ctr">
-              <a:spcAft>
-                <a:spcPts val="400"/>
-              </a:spcAft>
-            </a:pPr>
-            <a:r>
-              <a:rPr sz="1400" b="1">
-                <a:solidFill>
-                  <a:srgbClr val="E09E2F"/>
-                </a:solidFill>
-                <a:latin typeface="Avenir Next"/>
-              </a:rPr>
-              <a:t>gradient ?</a:t>
-            </a:r>
-          </a:p>
-        </p:txBody>
-      </p:sp>
-      <p:sp>
-        <p:nvSpPr>
-          <p:cNvPr id="20" name="TextBox 19"/>
-          <p:cNvSpPr txBox="1"/>
-          <p:nvPr/>
-        </p:nvSpPr>
-        <p:spPr>
-          <a:xfrm>
-            <a:off x="548640" y="2888800"/>
-            <a:ext cx="10515600" cy="1900000"/>
-          </a:xfrm>
-          <a:prstGeom prst="rect">
-            <a:avLst/>
-          </a:prstGeom>
-          <a:noFill/>
-        </p:spPr>
-        <p:txBody>
-          <a:bodyPr wrap="square" lIns="45720" rIns="45720" tIns="27432" bIns="27432" anchor="t">
-            <a:spAutoFit/>
-          </a:bodyPr>
-          <a:lstStyle/>
-          <a:p>
-            <a:pPr algn="l">
-              <a:spcAft>
-                <a:spcPts val="600"/>
-              </a:spcAft>
-            </a:pPr>
-            <a:r>
-              <a:rPr sz="1600" b="0">
-                <a:solidFill>
-                  <a:srgbClr val="1B2025"/>
-                </a:solidFill>
-                <a:latin typeface="Avenir Next"/>
-              </a:rPr>
-              <a:t>A gradient is the PRODUCT of the local slopes along the path back to a weight (Lecture 2). Here it passes back through 5 layers, each multiplying it by a slope of 0.5.</a:t>
-            </a:r>
-          </a:p>
-          <a:p>
-            <a:pPr algn="l">
-              <a:spcAft>
-                <a:spcPts val="600"/>
-              </a:spcAft>
-            </a:pPr>
-            <a:r>
-              <a:rPr sz="1600" b="1">
-                <a:solidFill>
-                  <a:srgbClr val="0E7C7B"/>
-                </a:solidFill>
-                <a:latin typeface="Avenir Next"/>
-              </a:rPr>
-              <a:t>(a)  </a:t>
-            </a:r>
-            <a:r>
-              <a:rPr sz="1600" b="0">
-                <a:solidFill>
-                  <a:srgbClr val="1B2025"/>
-                </a:solidFill>
-                <a:latin typeface="Avenir Next"/>
-              </a:rPr>
-              <a:t>What gradient reaches the first layer?   1.0 × 0.5⁵ =</a:t>
-            </a:r>
-            <a:r>
-              <a:rPr sz="1600" b="1">
-                <a:solidFill>
-                  <a:srgbClr val="0E7C7B"/>
-                </a:solidFill>
-                <a:latin typeface="Avenir Next"/>
-              </a:rPr>
-              <a:t>  ________</a:t>
-            </a:r>
-          </a:p>
-          <a:p>
-            <a:pPr algn="l">
-              <a:spcAft>
-                <a:spcPts val="600"/>
-              </a:spcAft>
-            </a:pPr>
-            <a:r>
-              <a:rPr sz="1600" b="1">
-                <a:solidFill>
-                  <a:srgbClr val="0E7C7B"/>
-                </a:solidFill>
-                <a:latin typeface="Avenir Next"/>
-              </a:rPr>
-              <a:t>(b)  </a:t>
-            </a:r>
-            <a:r>
-              <a:rPr sz="1600" b="0">
-                <a:solidFill>
-                  <a:srgbClr val="1B2025"/>
-                </a:solidFill>
-                <a:latin typeface="Avenir Next"/>
-              </a:rPr>
-              <a:t>Is this vanishing or exploding?</a:t>
-            </a:r>
-            <a:r>
-              <a:rPr sz="1600" b="1">
-                <a:solidFill>
-                  <a:srgbClr val="0E7C7B"/>
-                </a:solidFill>
-                <a:latin typeface="Avenir Next"/>
-              </a:rPr>
-              <a:t>  ________</a:t>
-            </a:r>
-          </a:p>
-          <a:p>
-            <a:pPr algn="l">
-              <a:spcAft>
-                <a:spcPts val="600"/>
-              </a:spcAft>
-            </a:pPr>
-            <a:r>
-              <a:rPr sz="1600" b="1">
-                <a:solidFill>
-                  <a:srgbClr val="0E7C7B"/>
-                </a:solidFill>
-                <a:latin typeface="Avenir Next"/>
-              </a:rPr>
-              <a:t>(c)  </a:t>
-            </a:r>
-            <a:r>
-              <a:rPr sz="1600" b="0">
-                <a:solidFill>
-                  <a:srgbClr val="1B2025"/>
-                </a:solidFill>
-                <a:latin typeface="Avenir Next"/>
-              </a:rPr>
-              <a:t>In one line: what does that mean for how the earliest layers learn?</a:t>
+              <a:t>From Lecture 2: a weight's gradient is the PRODUCT of the local slopes along its path back from the loss. In a deep net that path crosses every layer — so a factor a bit below 1 shrinks the gradient to nothing (vanishing), and a bit above 1 blows it up (exploding). No optimizer fully fixes this.</a:t>
             </a:r>
           </a:p>
         </p:txBody>
@@ -7516,7 +6662,7 @@
                 </a:solidFill>
                 <a:latin typeface="Menlo"/>
               </a:rPr>
-              <a:t>PART 2 · TUNING · THE HYPERPARAMETERS</a:t>
+              <a:t>PART 2 · TUNING · YOUR TURN (YOU-DO = Q4)</a:t>
             </a:r>
           </a:p>
         </p:txBody>
@@ -7530,7 +6676,7 @@
         <p:spPr>
           <a:xfrm>
             <a:off x="548640" y="731520"/>
-            <a:ext cx="11064240" cy="1127760"/>
+            <a:ext cx="11064240" cy="1005840"/>
           </a:xfrm>
           <a:prstGeom prst="rect">
             <a:avLst/>
@@ -7550,155 +6696,7 @@
                 </a:solidFill>
                 <a:latin typeface="Avenir Next"/>
               </a:rPr>
-              <a:t>The knobs you set — tune the learning rate first</a:t>
-            </a:r>
-          </a:p>
-        </p:txBody>
-      </p:sp>
-      <p:sp>
-        <p:nvSpPr>
-          <p:cNvPr id="5" name="TextBox 4"/>
-          <p:cNvSpPr txBox="1"/>
-          <p:nvPr/>
-        </p:nvSpPr>
-        <p:spPr>
-          <a:xfrm>
-            <a:off x="548640" y="1920240"/>
-            <a:ext cx="10789920" cy="3794760"/>
-          </a:xfrm>
-          <a:prstGeom prst="rect">
-            <a:avLst/>
-          </a:prstGeom>
-          <a:noFill/>
-        </p:spPr>
-        <p:txBody>
-          <a:bodyPr wrap="square" anchor="t">
-            <a:spAutoFit/>
-          </a:bodyPr>
-          <a:lstStyle/>
-          <a:p>
-            <a:pPr>
-              <a:spcAft>
-                <a:spcPts val="1800"/>
-              </a:spcAft>
-            </a:pPr>
-            <a:r>
-              <a:rPr sz="2100" b="1" i="0" dirty="0">
-                <a:solidFill>
-                  <a:srgbClr val="0E7C7B"/>
-                </a:solidFill>
-                <a:latin typeface="Avenir Next"/>
-              </a:rPr>
-              <a:t>•  </a:t>
-            </a:r>
-            <a:r>
-              <a:rPr sz="2100" b="0" i="0" dirty="0">
-                <a:solidFill>
-                  <a:srgbClr val="1B2025"/>
-                </a:solidFill>
-                <a:latin typeface="Avenir Next"/>
-              </a:rPr>
-              <a:t>Hyperparameters = settings you choose BEFORE training (the weights are what training learns)</a:t>
-            </a:r>
-          </a:p>
-          <a:p>
-            <a:pPr>
-              <a:spcAft>
-                <a:spcPts val="1800"/>
-              </a:spcAft>
-            </a:pPr>
-            <a:r>
-              <a:rPr sz="2100" b="1" i="0" dirty="0">
-                <a:solidFill>
-                  <a:srgbClr val="0E7C7B"/>
-                </a:solidFill>
-                <a:latin typeface="Avenir Next"/>
-              </a:rPr>
-              <a:t>•  </a:t>
-            </a:r>
-            <a:r>
-              <a:rPr sz="2100" b="0" i="0" dirty="0">
-                <a:solidFill>
-                  <a:srgbClr val="1B2025"/>
-                </a:solidFill>
-                <a:latin typeface="Avenir Next"/>
-              </a:rPr>
-              <a:t>There are a huge number: depth · width · activation · optimizer · dropout · weight decay · schedule · batch size · epochs · …</a:t>
-            </a:r>
-          </a:p>
-          <a:p>
-            <a:pPr>
-              <a:spcAft>
-                <a:spcPts val="1800"/>
-              </a:spcAft>
-            </a:pPr>
-            <a:r>
-              <a:rPr sz="2100" b="1" i="0" dirty="0">
-                <a:solidFill>
-                  <a:srgbClr val="0E7C7B"/>
-                </a:solidFill>
-                <a:latin typeface="Avenir Next"/>
-              </a:rPr>
-              <a:t>•  </a:t>
-            </a:r>
-            <a:r>
-              <a:rPr sz="2100" b="0" i="0" dirty="0">
-                <a:solidFill>
-                  <a:srgbClr val="1B2025"/>
-                </a:solidFill>
-                <a:latin typeface="Avenir Next"/>
-              </a:rPr>
-              <a:t>1 · Learning rate — by far the most impactful (Lecture 2's three bowls)</a:t>
-            </a:r>
-          </a:p>
-          <a:p>
-            <a:pPr>
-              <a:spcAft>
-                <a:spcPts val="1800"/>
-              </a:spcAft>
-            </a:pPr>
-            <a:r>
-              <a:rPr sz="2100" b="1" i="0" dirty="0">
-                <a:solidFill>
-                  <a:srgbClr val="0E7C7B"/>
-                </a:solidFill>
-                <a:latin typeface="Avenir Next"/>
-              </a:rPr>
-              <a:t>•  </a:t>
-            </a:r>
-            <a:r>
-              <a:rPr sz="2100" b="0" i="0" dirty="0">
-                <a:solidFill>
-                  <a:srgbClr val="1B2025"/>
-                </a:solidFill>
-                <a:latin typeface="Avenir Next"/>
-              </a:rPr>
-              <a:t>2 · Batch size — memory and the trade-off, next two slides</a:t>
-            </a:r>
-          </a:p>
-          <a:p>
-            <a:pPr>
-              <a:spcAft>
-                <a:spcPts val="1800"/>
-              </a:spcAft>
-            </a:pPr>
-            <a:r>
-              <a:rPr sz="2100" b="1" i="0" dirty="0">
-                <a:solidFill>
-                  <a:srgbClr val="0E7C7B"/>
-                </a:solidFill>
-                <a:latin typeface="Avenir Next"/>
-              </a:rPr>
-              <a:t>•  </a:t>
-            </a:r>
-            <a:r>
-              <a:rPr sz="2100" b="0" i="0" dirty="0">
-                <a:solidFill>
-                  <a:srgbClr val="1B2025"/>
-                </a:solidFill>
-                <a:latin typeface="Avenir Next"/>
-              </a:rPr>
-              <a:t>3 · Model size / epochs — capacity and how long</a:t>
+              <a:t>Your turn — what gradient reaches layer 1?</a:t>
             </a:r>
           </a:p>
         </p:txBody>
@@ -7711,8 +6709,8 @@
         </p:nvSpPr>
         <p:spPr>
           <a:xfrm>
-            <a:off x="548640" y="5843016"/>
-            <a:ext cx="10515600" cy="923544"/>
+            <a:off x="548640" y="5538216"/>
+            <a:ext cx="10515600" cy="1182624"/>
           </a:xfrm>
           <a:prstGeom prst="rect">
             <a:avLst/>
@@ -7722,7 +6720,7 @@
           </a:solidFill>
           <a:ln w="12700">
             <a:solidFill>
-              <a:srgbClr val="3D444C"/>
+              <a:srgbClr val="E09E2F"/>
             </a:solidFill>
           </a:ln>
           <a:effectLst/>
@@ -7747,13 +6745,757 @@
           <a:p>
             <a:pPr algn="ctr"/>
             <a:r>
+              <a:rPr sz="1200" b="1" i="0">
+                <a:solidFill>
+                  <a:srgbClr val="E09E2F"/>
+                </a:solidFill>
+                <a:latin typeface="Menlo"/>
+              </a:rPr>
+              <a:t>CHECKPOINT · </a:t>
+            </a:r>
+            <a:r>
               <a:rPr sz="1700" b="0" i="0">
                 <a:solidFill>
                   <a:srgbClr val="3D444C"/>
                 </a:solidFill>
                 <a:latin typeface="Avenir Next"/>
               </a:rPr>
-              <a:t>Get the learning rate right and half your problems disappear; everything else can start at its library default. Order of attack: learning rate → batch size → model size / epochs.</a:t>
+              <a:t>Your turn → Quiz 4, Q4. Multiply the slopes down the chain: 1.0 leaves the loss and is multiplied by 0.5 at each of 5 layers. (a) What reaches layer 1? (b) Vanishing or exploding? (c) What does that mean for the earliest layers? Worked answer in the notes.</a:t>
+            </a:r>
+          </a:p>
+        </p:txBody>
+      </p:sp>
+      <p:sp>
+        <p:nvSpPr>
+          <p:cNvPr id="7" name="Rounded Rectangle 6"/>
+          <p:cNvSpPr/>
+          <p:nvPr/>
+        </p:nvSpPr>
+        <p:spPr>
+          <a:xfrm>
+            <a:off x="548640" y="1908800"/>
+            <a:ext cx="1000000" cy="560000"/>
+          </a:xfrm>
+          <a:prstGeom prst="roundRect">
+            <a:avLst>
+              <a:gd name="adj" fmla="val 8000"/>
+            </a:avLst>
+          </a:prstGeom>
+          <a:solidFill>
+            <a:srgbClr val="FBF1DC"/>
+          </a:solidFill>
+          <a:ln>
+            <a:noFill/>
+          </a:ln>
+          <a:effectLst/>
+        </p:spPr>
+        <p:style>
+          <a:lnRef idx="1">
+            <a:schemeClr val="accent1"/>
+          </a:lnRef>
+          <a:fillRef idx="3">
+            <a:schemeClr val="accent1"/>
+          </a:fillRef>
+          <a:effectRef idx="2">
+            <a:schemeClr val="accent1"/>
+          </a:effectRef>
+          <a:fontRef idx="minor">
+            <a:schemeClr val="lt1"/>
+          </a:fontRef>
+        </p:style>
+        <p:txBody>
+          <a:bodyPr rtlCol="0" anchor="ctr"/>
+          <a:lstStyle/>
+          <a:p>
+            <a:pPr algn="ctr"/>
+            <a:r>
+              <a:rPr sz="1500" b="1">
+                <a:solidFill>
+                  <a:srgbClr val="1B2025"/>
+                </a:solidFill>
+                <a:latin typeface="Avenir Next"/>
+              </a:rPr>
+              <a:t>loss</a:t>
+            </a:r>
+          </a:p>
+        </p:txBody>
+      </p:sp>
+      <p:sp>
+        <p:nvSpPr>
+          <p:cNvPr id="8" name="TextBox 7"/>
+          <p:cNvSpPr txBox="1"/>
+          <p:nvPr/>
+        </p:nvSpPr>
+        <p:spPr>
+          <a:xfrm>
+            <a:off x="97080" y="2488800"/>
+            <a:ext cx="1903120" cy="330000"/>
+          </a:xfrm>
+          <a:prstGeom prst="rect">
+            <a:avLst/>
+          </a:prstGeom>
+          <a:noFill/>
+        </p:spPr>
+        <p:txBody>
+          <a:bodyPr wrap="square" lIns="45720" tIns="27432" rIns="45720" bIns="27432" anchor="t">
+            <a:spAutoFit/>
+          </a:bodyPr>
+          <a:lstStyle/>
+          <a:p>
+            <a:pPr algn="ctr">
+              <a:spcAft>
+                <a:spcPts val="400"/>
+              </a:spcAft>
+            </a:pPr>
+            <a:r>
+              <a:rPr sz="1400" b="1">
+                <a:solidFill>
+                  <a:srgbClr val="3D444C"/>
+                </a:solidFill>
+                <a:latin typeface="Avenir Next"/>
+              </a:rPr>
+              <a:t>gradient 1.0</a:t>
+            </a:r>
+          </a:p>
+        </p:txBody>
+      </p:sp>
+      <p:sp>
+        <p:nvSpPr>
+          <p:cNvPr id="9" name="TextBox 8"/>
+          <p:cNvSpPr txBox="1"/>
+          <p:nvPr/>
+        </p:nvSpPr>
+        <p:spPr>
+          <a:xfrm>
+            <a:off x="1548640" y="1968800"/>
+            <a:ext cx="903120" cy="440000"/>
+          </a:xfrm>
+          <a:prstGeom prst="rect">
+            <a:avLst/>
+          </a:prstGeom>
+          <a:noFill/>
+        </p:spPr>
+        <p:txBody>
+          <a:bodyPr wrap="square" lIns="45720" tIns="27432" rIns="45720" bIns="27432" anchor="ctr">
+            <a:spAutoFit/>
+          </a:bodyPr>
+          <a:lstStyle/>
+          <a:p>
+            <a:pPr algn="ctr">
+              <a:spcAft>
+                <a:spcPts val="400"/>
+              </a:spcAft>
+            </a:pPr>
+            <a:r>
+              <a:rPr sz="1500" b="1">
+                <a:solidFill>
+                  <a:srgbClr val="0E7C7B"/>
+                </a:solidFill>
+                <a:latin typeface="Menlo"/>
+              </a:rPr>
+              <a:t>× 0.5</a:t>
+            </a:r>
+          </a:p>
+        </p:txBody>
+      </p:sp>
+      <p:sp>
+        <p:nvSpPr>
+          <p:cNvPr id="10" name="Rounded Rectangle 9"/>
+          <p:cNvSpPr/>
+          <p:nvPr/>
+        </p:nvSpPr>
+        <p:spPr>
+          <a:xfrm>
+            <a:off x="2451760" y="1908800"/>
+            <a:ext cx="1000000" cy="560000"/>
+          </a:xfrm>
+          <a:prstGeom prst="roundRect">
+            <a:avLst>
+              <a:gd name="adj" fmla="val 8000"/>
+            </a:avLst>
+          </a:prstGeom>
+          <a:solidFill>
+            <a:srgbClr val="E3F0EF"/>
+          </a:solidFill>
+          <a:ln>
+            <a:noFill/>
+          </a:ln>
+          <a:effectLst/>
+        </p:spPr>
+        <p:style>
+          <a:lnRef idx="1">
+            <a:schemeClr val="accent1"/>
+          </a:lnRef>
+          <a:fillRef idx="3">
+            <a:schemeClr val="accent1"/>
+          </a:fillRef>
+          <a:effectRef idx="2">
+            <a:schemeClr val="accent1"/>
+          </a:effectRef>
+          <a:fontRef idx="minor">
+            <a:schemeClr val="lt1"/>
+          </a:fontRef>
+        </p:style>
+        <p:txBody>
+          <a:bodyPr rtlCol="0" anchor="ctr"/>
+          <a:lstStyle/>
+          <a:p>
+            <a:pPr algn="ctr"/>
+            <a:r>
+              <a:rPr sz="1500" b="1">
+                <a:solidFill>
+                  <a:srgbClr val="1B2025"/>
+                </a:solidFill>
+                <a:latin typeface="Avenir Next"/>
+              </a:rPr>
+              <a:t>layer 5</a:t>
+            </a:r>
+          </a:p>
+        </p:txBody>
+      </p:sp>
+      <p:sp>
+        <p:nvSpPr>
+          <p:cNvPr id="11" name="TextBox 10"/>
+          <p:cNvSpPr txBox="1"/>
+          <p:nvPr/>
+        </p:nvSpPr>
+        <p:spPr>
+          <a:xfrm>
+            <a:off x="3451760" y="1968800"/>
+            <a:ext cx="903120" cy="440000"/>
+          </a:xfrm>
+          <a:prstGeom prst="rect">
+            <a:avLst/>
+          </a:prstGeom>
+          <a:noFill/>
+        </p:spPr>
+        <p:txBody>
+          <a:bodyPr wrap="square" lIns="45720" tIns="27432" rIns="45720" bIns="27432" anchor="ctr">
+            <a:spAutoFit/>
+          </a:bodyPr>
+          <a:lstStyle/>
+          <a:p>
+            <a:pPr algn="ctr">
+              <a:spcAft>
+                <a:spcPts val="400"/>
+              </a:spcAft>
+            </a:pPr>
+            <a:r>
+              <a:rPr sz="1500" b="1">
+                <a:solidFill>
+                  <a:srgbClr val="0E7C7B"/>
+                </a:solidFill>
+                <a:latin typeface="Menlo"/>
+              </a:rPr>
+              <a:t>× 0.5</a:t>
+            </a:r>
+          </a:p>
+        </p:txBody>
+      </p:sp>
+      <p:sp>
+        <p:nvSpPr>
+          <p:cNvPr id="12" name="Rounded Rectangle 11"/>
+          <p:cNvSpPr/>
+          <p:nvPr/>
+        </p:nvSpPr>
+        <p:spPr>
+          <a:xfrm>
+            <a:off x="4354880" y="1908800"/>
+            <a:ext cx="1000000" cy="560000"/>
+          </a:xfrm>
+          <a:prstGeom prst="roundRect">
+            <a:avLst>
+              <a:gd name="adj" fmla="val 8000"/>
+            </a:avLst>
+          </a:prstGeom>
+          <a:solidFill>
+            <a:srgbClr val="E3F0EF"/>
+          </a:solidFill>
+          <a:ln>
+            <a:noFill/>
+          </a:ln>
+          <a:effectLst/>
+        </p:spPr>
+        <p:style>
+          <a:lnRef idx="1">
+            <a:schemeClr val="accent1"/>
+          </a:lnRef>
+          <a:fillRef idx="3">
+            <a:schemeClr val="accent1"/>
+          </a:fillRef>
+          <a:effectRef idx="2">
+            <a:schemeClr val="accent1"/>
+          </a:effectRef>
+          <a:fontRef idx="minor">
+            <a:schemeClr val="lt1"/>
+          </a:fontRef>
+        </p:style>
+        <p:txBody>
+          <a:bodyPr rtlCol="0" anchor="ctr"/>
+          <a:lstStyle/>
+          <a:p>
+            <a:pPr algn="ctr"/>
+            <a:r>
+              <a:rPr sz="1500" b="1">
+                <a:solidFill>
+                  <a:srgbClr val="1B2025"/>
+                </a:solidFill>
+                <a:latin typeface="Avenir Next"/>
+              </a:rPr>
+              <a:t>layer 4</a:t>
+            </a:r>
+          </a:p>
+        </p:txBody>
+      </p:sp>
+      <p:sp>
+        <p:nvSpPr>
+          <p:cNvPr id="13" name="TextBox 12"/>
+          <p:cNvSpPr txBox="1"/>
+          <p:nvPr/>
+        </p:nvSpPr>
+        <p:spPr>
+          <a:xfrm>
+            <a:off x="5354880" y="1968800"/>
+            <a:ext cx="903120" cy="440000"/>
+          </a:xfrm>
+          <a:prstGeom prst="rect">
+            <a:avLst/>
+          </a:prstGeom>
+          <a:noFill/>
+        </p:spPr>
+        <p:txBody>
+          <a:bodyPr wrap="square" lIns="45720" tIns="27432" rIns="45720" bIns="27432" anchor="ctr">
+            <a:spAutoFit/>
+          </a:bodyPr>
+          <a:lstStyle/>
+          <a:p>
+            <a:pPr algn="ctr">
+              <a:spcAft>
+                <a:spcPts val="400"/>
+              </a:spcAft>
+            </a:pPr>
+            <a:r>
+              <a:rPr sz="1500" b="1">
+                <a:solidFill>
+                  <a:srgbClr val="0E7C7B"/>
+                </a:solidFill>
+                <a:latin typeface="Menlo"/>
+              </a:rPr>
+              <a:t>× 0.5</a:t>
+            </a:r>
+          </a:p>
+        </p:txBody>
+      </p:sp>
+      <p:sp>
+        <p:nvSpPr>
+          <p:cNvPr id="14" name="Rounded Rectangle 13"/>
+          <p:cNvSpPr/>
+          <p:nvPr/>
+        </p:nvSpPr>
+        <p:spPr>
+          <a:xfrm>
+            <a:off x="6258000" y="1908800"/>
+            <a:ext cx="1000000" cy="560000"/>
+          </a:xfrm>
+          <a:prstGeom prst="roundRect">
+            <a:avLst>
+              <a:gd name="adj" fmla="val 8000"/>
+            </a:avLst>
+          </a:prstGeom>
+          <a:solidFill>
+            <a:srgbClr val="E3F0EF"/>
+          </a:solidFill>
+          <a:ln>
+            <a:noFill/>
+          </a:ln>
+          <a:effectLst/>
+        </p:spPr>
+        <p:style>
+          <a:lnRef idx="1">
+            <a:schemeClr val="accent1"/>
+          </a:lnRef>
+          <a:fillRef idx="3">
+            <a:schemeClr val="accent1"/>
+          </a:fillRef>
+          <a:effectRef idx="2">
+            <a:schemeClr val="accent1"/>
+          </a:effectRef>
+          <a:fontRef idx="minor">
+            <a:schemeClr val="lt1"/>
+          </a:fontRef>
+        </p:style>
+        <p:txBody>
+          <a:bodyPr rtlCol="0" anchor="ctr"/>
+          <a:lstStyle/>
+          <a:p>
+            <a:pPr algn="ctr"/>
+            <a:r>
+              <a:rPr sz="1500" b="1">
+                <a:solidFill>
+                  <a:srgbClr val="1B2025"/>
+                </a:solidFill>
+                <a:latin typeface="Avenir Next"/>
+              </a:rPr>
+              <a:t>layer 3</a:t>
+            </a:r>
+          </a:p>
+        </p:txBody>
+      </p:sp>
+      <p:sp>
+        <p:nvSpPr>
+          <p:cNvPr id="15" name="TextBox 14"/>
+          <p:cNvSpPr txBox="1"/>
+          <p:nvPr/>
+        </p:nvSpPr>
+        <p:spPr>
+          <a:xfrm>
+            <a:off x="7258000" y="1968800"/>
+            <a:ext cx="903120" cy="440000"/>
+          </a:xfrm>
+          <a:prstGeom prst="rect">
+            <a:avLst/>
+          </a:prstGeom>
+          <a:noFill/>
+        </p:spPr>
+        <p:txBody>
+          <a:bodyPr wrap="square" lIns="45720" tIns="27432" rIns="45720" bIns="27432" anchor="ctr">
+            <a:spAutoFit/>
+          </a:bodyPr>
+          <a:lstStyle/>
+          <a:p>
+            <a:pPr algn="ctr">
+              <a:spcAft>
+                <a:spcPts val="400"/>
+              </a:spcAft>
+            </a:pPr>
+            <a:r>
+              <a:rPr sz="1500" b="1">
+                <a:solidFill>
+                  <a:srgbClr val="0E7C7B"/>
+                </a:solidFill>
+                <a:latin typeface="Menlo"/>
+              </a:rPr>
+              <a:t>× 0.5</a:t>
+            </a:r>
+          </a:p>
+        </p:txBody>
+      </p:sp>
+      <p:sp>
+        <p:nvSpPr>
+          <p:cNvPr id="16" name="Rounded Rectangle 15"/>
+          <p:cNvSpPr/>
+          <p:nvPr/>
+        </p:nvSpPr>
+        <p:spPr>
+          <a:xfrm>
+            <a:off x="8161120" y="1908800"/>
+            <a:ext cx="1000000" cy="560000"/>
+          </a:xfrm>
+          <a:prstGeom prst="roundRect">
+            <a:avLst>
+              <a:gd name="adj" fmla="val 8000"/>
+            </a:avLst>
+          </a:prstGeom>
+          <a:solidFill>
+            <a:srgbClr val="E3F0EF"/>
+          </a:solidFill>
+          <a:ln>
+            <a:noFill/>
+          </a:ln>
+          <a:effectLst/>
+        </p:spPr>
+        <p:style>
+          <a:lnRef idx="1">
+            <a:schemeClr val="accent1"/>
+          </a:lnRef>
+          <a:fillRef idx="3">
+            <a:schemeClr val="accent1"/>
+          </a:fillRef>
+          <a:effectRef idx="2">
+            <a:schemeClr val="accent1"/>
+          </a:effectRef>
+          <a:fontRef idx="minor">
+            <a:schemeClr val="lt1"/>
+          </a:fontRef>
+        </p:style>
+        <p:txBody>
+          <a:bodyPr rtlCol="0" anchor="ctr"/>
+          <a:lstStyle/>
+          <a:p>
+            <a:pPr algn="ctr"/>
+            <a:r>
+              <a:rPr sz="1500" b="1">
+                <a:solidFill>
+                  <a:srgbClr val="1B2025"/>
+                </a:solidFill>
+                <a:latin typeface="Avenir Next"/>
+              </a:rPr>
+              <a:t>layer 2</a:t>
+            </a:r>
+          </a:p>
+        </p:txBody>
+      </p:sp>
+      <p:sp>
+        <p:nvSpPr>
+          <p:cNvPr id="17" name="TextBox 16"/>
+          <p:cNvSpPr txBox="1"/>
+          <p:nvPr/>
+        </p:nvSpPr>
+        <p:spPr>
+          <a:xfrm>
+            <a:off x="9161120" y="1968800"/>
+            <a:ext cx="903120" cy="440000"/>
+          </a:xfrm>
+          <a:prstGeom prst="rect">
+            <a:avLst/>
+          </a:prstGeom>
+          <a:noFill/>
+        </p:spPr>
+        <p:txBody>
+          <a:bodyPr wrap="square" lIns="45720" tIns="27432" rIns="45720" bIns="27432" anchor="ctr">
+            <a:spAutoFit/>
+          </a:bodyPr>
+          <a:lstStyle/>
+          <a:p>
+            <a:pPr algn="ctr">
+              <a:spcAft>
+                <a:spcPts val="400"/>
+              </a:spcAft>
+            </a:pPr>
+            <a:r>
+              <a:rPr sz="1500" b="1">
+                <a:solidFill>
+                  <a:srgbClr val="0E7C7B"/>
+                </a:solidFill>
+                <a:latin typeface="Menlo"/>
+              </a:rPr>
+              <a:t>× 0.5</a:t>
+            </a:r>
+          </a:p>
+        </p:txBody>
+      </p:sp>
+      <p:sp>
+        <p:nvSpPr>
+          <p:cNvPr id="18" name="Rounded Rectangle 17"/>
+          <p:cNvSpPr/>
+          <p:nvPr/>
+        </p:nvSpPr>
+        <p:spPr>
+          <a:xfrm>
+            <a:off x="10064240" y="1908800"/>
+            <a:ext cx="1000000" cy="560000"/>
+          </a:xfrm>
+          <a:prstGeom prst="roundRect">
+            <a:avLst>
+              <a:gd name="adj" fmla="val 8000"/>
+            </a:avLst>
+          </a:prstGeom>
+          <a:solidFill>
+            <a:srgbClr val="FBF1DC"/>
+          </a:solidFill>
+          <a:ln>
+            <a:noFill/>
+          </a:ln>
+          <a:effectLst/>
+        </p:spPr>
+        <p:style>
+          <a:lnRef idx="1">
+            <a:schemeClr val="accent1"/>
+          </a:lnRef>
+          <a:fillRef idx="3">
+            <a:schemeClr val="accent1"/>
+          </a:fillRef>
+          <a:effectRef idx="2">
+            <a:schemeClr val="accent1"/>
+          </a:effectRef>
+          <a:fontRef idx="minor">
+            <a:schemeClr val="lt1"/>
+          </a:fontRef>
+        </p:style>
+        <p:txBody>
+          <a:bodyPr rtlCol="0" anchor="ctr"/>
+          <a:lstStyle/>
+          <a:p>
+            <a:pPr algn="ctr"/>
+            <a:r>
+              <a:rPr sz="1500" b="1">
+                <a:solidFill>
+                  <a:srgbClr val="1B2025"/>
+                </a:solidFill>
+                <a:latin typeface="Avenir Next"/>
+              </a:rPr>
+              <a:t>layer 1</a:t>
+            </a:r>
+          </a:p>
+        </p:txBody>
+      </p:sp>
+      <p:sp>
+        <p:nvSpPr>
+          <p:cNvPr id="19" name="TextBox 18"/>
+          <p:cNvSpPr txBox="1"/>
+          <p:nvPr/>
+        </p:nvSpPr>
+        <p:spPr>
+          <a:xfrm>
+            <a:off x="9612680" y="2488800"/>
+            <a:ext cx="1903120" cy="330000"/>
+          </a:xfrm>
+          <a:prstGeom prst="rect">
+            <a:avLst/>
+          </a:prstGeom>
+          <a:noFill/>
+        </p:spPr>
+        <p:txBody>
+          <a:bodyPr wrap="square" lIns="45720" tIns="27432" rIns="45720" bIns="27432" anchor="t">
+            <a:spAutoFit/>
+          </a:bodyPr>
+          <a:lstStyle/>
+          <a:p>
+            <a:pPr algn="ctr">
+              <a:spcAft>
+                <a:spcPts val="400"/>
+              </a:spcAft>
+            </a:pPr>
+            <a:r>
+              <a:rPr sz="1400" b="1">
+                <a:solidFill>
+                  <a:srgbClr val="E09E2F"/>
+                </a:solidFill>
+                <a:latin typeface="Avenir Next"/>
+              </a:rPr>
+              <a:t>gradient ?</a:t>
+            </a:r>
+          </a:p>
+        </p:txBody>
+      </p:sp>
+      <p:sp>
+        <p:nvSpPr>
+          <p:cNvPr id="20" name="TextBox 19"/>
+          <p:cNvSpPr txBox="1"/>
+          <p:nvPr/>
+        </p:nvSpPr>
+        <p:spPr>
+          <a:xfrm>
+            <a:off x="548640" y="2888800"/>
+            <a:ext cx="10515600" cy="1900000"/>
+          </a:xfrm>
+          <a:prstGeom prst="rect">
+            <a:avLst/>
+          </a:prstGeom>
+          <a:noFill/>
+        </p:spPr>
+        <p:txBody>
+          <a:bodyPr wrap="square" lIns="45720" tIns="27432" rIns="45720" bIns="27432" anchor="t">
+            <a:spAutoFit/>
+          </a:bodyPr>
+          <a:lstStyle/>
+          <a:p>
+            <a:pPr algn="l">
+              <a:spcAft>
+                <a:spcPts val="600"/>
+              </a:spcAft>
+            </a:pPr>
+            <a:r>
+              <a:rPr sz="1600" b="0">
+                <a:solidFill>
+                  <a:srgbClr val="1B2025"/>
+                </a:solidFill>
+                <a:latin typeface="Avenir Next"/>
+              </a:rPr>
+              <a:t>A gradient is the PRODUCT of the local slopes along the path back to a weight (Lecture 2). Here it passes back through 5 layers, each multiplying it by a slope of 0.5.</a:t>
+            </a:r>
+          </a:p>
+          <a:p>
+            <a:pPr algn="l">
+              <a:spcAft>
+                <a:spcPts val="600"/>
+              </a:spcAft>
+            </a:pPr>
+            <a:r>
+              <a:rPr sz="1600" b="1">
+                <a:solidFill>
+                  <a:srgbClr val="0E7C7B"/>
+                </a:solidFill>
+                <a:latin typeface="Avenir Next"/>
+              </a:rPr>
+              <a:t>(a)  </a:t>
+            </a:r>
+            <a:r>
+              <a:rPr sz="1600" b="0">
+                <a:solidFill>
+                  <a:srgbClr val="1B2025"/>
+                </a:solidFill>
+                <a:latin typeface="Avenir Next"/>
+              </a:rPr>
+              <a:t>What gradient reaches the first layer?   1.0 × 0.5⁵ =</a:t>
+            </a:r>
+            <a:r>
+              <a:rPr sz="1600" b="1">
+                <a:solidFill>
+                  <a:srgbClr val="0E7C7B"/>
+                </a:solidFill>
+                <a:latin typeface="Avenir Next"/>
+              </a:rPr>
+              <a:t>  ________</a:t>
+            </a:r>
+          </a:p>
+          <a:p>
+            <a:pPr algn="l">
+              <a:spcAft>
+                <a:spcPts val="600"/>
+              </a:spcAft>
+            </a:pPr>
+            <a:r>
+              <a:rPr sz="1600" b="1">
+                <a:solidFill>
+                  <a:srgbClr val="0E7C7B"/>
+                </a:solidFill>
+                <a:latin typeface="Avenir Next"/>
+              </a:rPr>
+              <a:t>(b)  </a:t>
+            </a:r>
+            <a:r>
+              <a:rPr sz="1600" b="0">
+                <a:solidFill>
+                  <a:srgbClr val="1B2025"/>
+                </a:solidFill>
+                <a:latin typeface="Avenir Next"/>
+              </a:rPr>
+              <a:t>Is this vanishing or exploding?</a:t>
+            </a:r>
+            <a:r>
+              <a:rPr sz="1600" b="1">
+                <a:solidFill>
+                  <a:srgbClr val="0E7C7B"/>
+                </a:solidFill>
+                <a:latin typeface="Avenir Next"/>
+              </a:rPr>
+              <a:t>  ________</a:t>
+            </a:r>
+          </a:p>
+          <a:p>
+            <a:pPr algn="l">
+              <a:spcAft>
+                <a:spcPts val="600"/>
+              </a:spcAft>
+            </a:pPr>
+            <a:r>
+              <a:rPr sz="1600" b="1">
+                <a:solidFill>
+                  <a:srgbClr val="0E7C7B"/>
+                </a:solidFill>
+                <a:latin typeface="Avenir Next"/>
+              </a:rPr>
+              <a:t>(c)  </a:t>
+            </a:r>
+            <a:r>
+              <a:rPr sz="1600" b="0">
+                <a:solidFill>
+                  <a:srgbClr val="1B2025"/>
+                </a:solidFill>
+                <a:latin typeface="Avenir Next"/>
+              </a:rPr>
+              <a:t>In one line: what does that mean for how the earliest layers learn?</a:t>
             </a:r>
           </a:p>
         </p:txBody>
@@ -7857,7 +7599,7 @@
                 </a:solidFill>
                 <a:latin typeface="Menlo"/>
               </a:rPr>
-              <a:t>PART 2 · TUNING · BATCH SIZE · THE TRADE-OFF (I-DO)</a:t>
+              <a:t>PART 2 · TUNING · THE HYPERPARAMETERS</a:t>
             </a:r>
           </a:p>
         </p:txBody>
@@ -7871,7 +7613,7 @@
         <p:spPr>
           <a:xfrm>
             <a:off x="548640" y="731520"/>
-            <a:ext cx="11064240" cy="1005840"/>
+            <a:ext cx="11064240" cy="1127760"/>
           </a:xfrm>
           <a:prstGeom prst="rect">
             <a:avLst/>
@@ -7891,35 +7633,303 @@
                 </a:solidFill>
                 <a:latin typeface="Avenir Next"/>
               </a:rPr>
-              <a:t>Batch size shapes which valley you land in</a:t>
-            </a:r>
-          </a:p>
-        </p:txBody>
-      </p:sp>
-      <p:pic>
-        <p:nvPicPr>
-          <p:cNvPr id="5" name="Picture 4" descr="fig_batch_tradeoff.png"/>
-          <p:cNvPicPr>
-            <a:picLocks noChangeAspect="1"/>
-          </p:cNvPicPr>
-          <p:nvPr/>
-        </p:nvPicPr>
-        <p:blipFill>
-          <a:blip r:embed="rId3"/>
-          <a:stretch>
-            <a:fillRect/>
-          </a:stretch>
-        </p:blipFill>
-        <p:spPr>
-          <a:xfrm>
-            <a:off x="2169552" y="1828800"/>
-            <a:ext cx="7822415" cy="3383280"/>
-          </a:xfrm>
-          <a:prstGeom prst="rect">
-            <a:avLst/>
-          </a:prstGeom>
-        </p:spPr>
-      </p:pic>
+              <a:t>The knobs you set — tune the learning rate first</a:t>
+            </a:r>
+          </a:p>
+        </p:txBody>
+      </p:sp>
+      <p:sp>
+        <p:nvSpPr>
+          <p:cNvPr id="5" name="TextBox 4"/>
+          <p:cNvSpPr txBox="1"/>
+          <p:nvPr/>
+        </p:nvSpPr>
+        <p:spPr>
+          <a:xfrm>
+            <a:off x="548640" y="1920240"/>
+            <a:ext cx="10789920" cy="3277820"/>
+          </a:xfrm>
+          <a:prstGeom prst="rect">
+            <a:avLst/>
+          </a:prstGeom>
+          <a:noFill/>
+        </p:spPr>
+        <p:txBody>
+          <a:bodyPr wrap="square" anchor="t">
+            <a:spAutoFit/>
+          </a:bodyPr>
+          <a:lstStyle/>
+          <a:p>
+            <a:pPr>
+              <a:spcAft>
+                <a:spcPts val="1800"/>
+              </a:spcAft>
+            </a:pPr>
+            <a:r>
+              <a:rPr sz="2100" b="1" i="0" dirty="0">
+                <a:solidFill>
+                  <a:srgbClr val="0E7C7B"/>
+                </a:solidFill>
+                <a:latin typeface="Avenir Next"/>
+              </a:rPr>
+              <a:t>•  </a:t>
+            </a:r>
+            <a:r>
+              <a:rPr sz="2100" b="0" i="0" dirty="0">
+                <a:solidFill>
+                  <a:srgbClr val="1B2025"/>
+                </a:solidFill>
+                <a:latin typeface="Avenir Next"/>
+              </a:rPr>
+              <a:t>Hyperparameters = settings you choose BEFORE training (the weights are what training learns)</a:t>
+            </a:r>
+          </a:p>
+          <a:p>
+            <a:pPr>
+              <a:spcAft>
+                <a:spcPts val="1800"/>
+              </a:spcAft>
+            </a:pPr>
+            <a:r>
+              <a:rPr sz="2100" b="1" i="0" dirty="0">
+                <a:solidFill>
+                  <a:srgbClr val="0E7C7B"/>
+                </a:solidFill>
+                <a:latin typeface="Avenir Next"/>
+              </a:rPr>
+              <a:t>•  </a:t>
+            </a:r>
+            <a:r>
+              <a:rPr sz="2100" b="0" i="0" dirty="0">
+                <a:solidFill>
+                  <a:srgbClr val="1B2025"/>
+                </a:solidFill>
+                <a:latin typeface="Avenir Next"/>
+              </a:rPr>
+              <a:t>There are a huge number: </a:t>
+            </a:r>
+            <a:r>
+              <a:rPr sz="2100" b="1" i="0" dirty="0">
+                <a:solidFill>
+                  <a:srgbClr val="1B2025"/>
+                </a:solidFill>
+                <a:latin typeface="Avenir Next"/>
+              </a:rPr>
+              <a:t>depth</a:t>
+            </a:r>
+            <a:r>
+              <a:rPr sz="2100" b="0" i="0" dirty="0">
+                <a:solidFill>
+                  <a:srgbClr val="1B2025"/>
+                </a:solidFill>
+                <a:latin typeface="Avenir Next"/>
+              </a:rPr>
+              <a:t> · </a:t>
+            </a:r>
+            <a:r>
+              <a:rPr sz="2100" b="1" i="0" dirty="0">
+                <a:solidFill>
+                  <a:srgbClr val="1B2025"/>
+                </a:solidFill>
+                <a:latin typeface="Avenir Next"/>
+              </a:rPr>
+              <a:t>width</a:t>
+            </a:r>
+            <a:r>
+              <a:rPr sz="2100" b="0" i="0" dirty="0">
+                <a:solidFill>
+                  <a:srgbClr val="1B2025"/>
+                </a:solidFill>
+                <a:latin typeface="Avenir Next"/>
+              </a:rPr>
+              <a:t> · </a:t>
+            </a:r>
+            <a:r>
+              <a:rPr sz="2100" b="1" i="0" dirty="0">
+                <a:solidFill>
+                  <a:srgbClr val="1B2025"/>
+                </a:solidFill>
+                <a:latin typeface="Avenir Next"/>
+              </a:rPr>
+              <a:t>activation</a:t>
+            </a:r>
+            <a:r>
+              <a:rPr sz="2100" b="0" i="0" dirty="0">
+                <a:solidFill>
+                  <a:srgbClr val="1B2025"/>
+                </a:solidFill>
+                <a:latin typeface="Avenir Next"/>
+              </a:rPr>
+              <a:t> · </a:t>
+            </a:r>
+            <a:r>
+              <a:rPr sz="2100" b="1" i="0" dirty="0">
+                <a:solidFill>
+                  <a:srgbClr val="1B2025"/>
+                </a:solidFill>
+                <a:latin typeface="Avenir Next"/>
+              </a:rPr>
+              <a:t>optimizer</a:t>
+            </a:r>
+            <a:r>
+              <a:rPr sz="2100" b="0" i="0" dirty="0">
+                <a:solidFill>
+                  <a:srgbClr val="1B2025"/>
+                </a:solidFill>
+                <a:latin typeface="Avenir Next"/>
+              </a:rPr>
+              <a:t> · dropout · weight decay · </a:t>
+            </a:r>
+            <a:r>
+              <a:rPr sz="2100" b="1" i="0" dirty="0">
+                <a:solidFill>
+                  <a:srgbClr val="1B2025"/>
+                </a:solidFill>
+                <a:latin typeface="Avenir Next"/>
+              </a:rPr>
+              <a:t>schedule</a:t>
+            </a:r>
+            <a:r>
+              <a:rPr sz="2100" b="0" i="0" dirty="0">
+                <a:solidFill>
+                  <a:srgbClr val="1B2025"/>
+                </a:solidFill>
+                <a:latin typeface="Avenir Next"/>
+              </a:rPr>
+              <a:t> · </a:t>
+            </a:r>
+            <a:r>
+              <a:rPr sz="2100" b="1" i="0" dirty="0">
+                <a:solidFill>
+                  <a:srgbClr val="1B2025"/>
+                </a:solidFill>
+                <a:latin typeface="Avenir Next"/>
+              </a:rPr>
+              <a:t>batch</a:t>
+            </a:r>
+            <a:r>
+              <a:rPr sz="2100" b="0" i="0" dirty="0">
+                <a:solidFill>
+                  <a:srgbClr val="1B2025"/>
+                </a:solidFill>
+                <a:latin typeface="Avenir Next"/>
+              </a:rPr>
+              <a:t> </a:t>
+            </a:r>
+            <a:r>
+              <a:rPr sz="2100" b="1" i="0" dirty="0">
+                <a:solidFill>
+                  <a:srgbClr val="1B2025"/>
+                </a:solidFill>
+                <a:latin typeface="Avenir Next"/>
+              </a:rPr>
+              <a:t>size</a:t>
+            </a:r>
+            <a:r>
+              <a:rPr sz="2100" b="0" i="0" dirty="0">
+                <a:solidFill>
+                  <a:srgbClr val="1B2025"/>
+                </a:solidFill>
+                <a:latin typeface="Avenir Next"/>
+              </a:rPr>
+              <a:t> · </a:t>
+            </a:r>
+            <a:r>
+              <a:rPr sz="2100" b="1" i="0" dirty="0">
+                <a:solidFill>
+                  <a:srgbClr val="1B2025"/>
+                </a:solidFill>
+                <a:latin typeface="Avenir Next"/>
+              </a:rPr>
+              <a:t>epochs</a:t>
+            </a:r>
+            <a:r>
+              <a:rPr sz="2100" b="0" i="0" dirty="0">
+                <a:solidFill>
+                  <a:srgbClr val="1B2025"/>
+                </a:solidFill>
+                <a:latin typeface="Avenir Next"/>
+              </a:rPr>
+              <a:t> · …</a:t>
+            </a:r>
+          </a:p>
+          <a:p>
+            <a:pPr>
+              <a:spcAft>
+                <a:spcPts val="1800"/>
+              </a:spcAft>
+            </a:pPr>
+            <a:r>
+              <a:rPr sz="2100" b="1" i="0" dirty="0">
+                <a:solidFill>
+                  <a:srgbClr val="0E7C7B"/>
+                </a:solidFill>
+                <a:latin typeface="Avenir Next"/>
+              </a:rPr>
+              <a:t>•  </a:t>
+            </a:r>
+            <a:r>
+              <a:rPr sz="2100" b="0" i="0" dirty="0">
+                <a:solidFill>
+                  <a:srgbClr val="1B2025"/>
+                </a:solidFill>
+                <a:latin typeface="Avenir Next"/>
+              </a:rPr>
+              <a:t>1 · Learning rate — by far the most impactful (Lecture 2's three bowls)</a:t>
+            </a:r>
+          </a:p>
+          <a:p>
+            <a:pPr>
+              <a:spcAft>
+                <a:spcPts val="1800"/>
+              </a:spcAft>
+            </a:pPr>
+            <a:r>
+              <a:rPr sz="2100" b="1" i="0" dirty="0">
+                <a:solidFill>
+                  <a:srgbClr val="0E7C7B"/>
+                </a:solidFill>
+                <a:latin typeface="Avenir Next"/>
+              </a:rPr>
+              <a:t>•  </a:t>
+            </a:r>
+            <a:r>
+              <a:rPr sz="2100" b="0" i="0" dirty="0">
+                <a:solidFill>
+                  <a:srgbClr val="1B2025"/>
+                </a:solidFill>
+                <a:latin typeface="Avenir Next"/>
+              </a:rPr>
+              <a:t>2 · Batch size — memory and the trade-off, next two slides</a:t>
+            </a:r>
+          </a:p>
+          <a:p>
+            <a:pPr>
+              <a:spcAft>
+                <a:spcPts val="1800"/>
+              </a:spcAft>
+            </a:pPr>
+            <a:r>
+              <a:rPr sz="2100" b="1" i="0" dirty="0">
+                <a:solidFill>
+                  <a:srgbClr val="0E7C7B"/>
+                </a:solidFill>
+                <a:latin typeface="Avenir Next"/>
+              </a:rPr>
+              <a:t>•  </a:t>
+            </a:r>
+            <a:r>
+              <a:rPr sz="2100" b="0" i="0" dirty="0">
+                <a:solidFill>
+                  <a:srgbClr val="1B2025"/>
+                </a:solidFill>
+                <a:latin typeface="Avenir Next"/>
+              </a:rPr>
+              <a:t>3 · Model size / epochs — capacity and how long</a:t>
+            </a:r>
+          </a:p>
+        </p:txBody>
+      </p:sp>
       <p:sp>
         <p:nvSpPr>
           <p:cNvPr id="6" name="Rectangle 5"/>
@@ -7928,8 +7938,8 @@
         </p:nvSpPr>
         <p:spPr>
           <a:xfrm>
-            <a:off x="548640" y="5303520"/>
-            <a:ext cx="10515600" cy="1182624"/>
+            <a:off x="548640" y="5843016"/>
+            <a:ext cx="10515600" cy="923544"/>
           </a:xfrm>
           <a:prstGeom prst="rect">
             <a:avLst/>
@@ -7970,7 +7980,7 @@
                 </a:solidFill>
                 <a:latin typeface="Avenir Next"/>
               </a:rPr>
-              <a:t>Same loss plane, two batch sizes. SMALL batch: noisy gradient → many small, jittery steps into a wide FLAT basin that generalizes. LARGE batch: clean gradient → few big, confident steps into a narrow SHARP basin that generalizes worse. A bigger batch buys a cleaner gradient and better GPU use — but there is a too-big cost.</a:t>
+              <a:t>Get the learning rate right and half your problems disappear; everything else can start at its library default. Order of attack: learning rate → batch size → model size / epochs.</a:t>
             </a:r>
           </a:p>
         </p:txBody>
@@ -8074,7 +8084,7 @@
                 </a:solidFill>
                 <a:latin typeface="Menlo"/>
               </a:rPr>
-              <a:t>PART 2 · TUNING · YOUR TURN (YOU-DO = Q3)</a:t>
+              <a:t>PART 2 · TUNING · BATCH SIZE · THE TRADE-OFF (I-DO)</a:t>
             </a:r>
           </a:p>
         </p:txBody>
@@ -8108,14 +8118,14 @@
                 </a:solidFill>
                 <a:latin typeface="Avenir Next"/>
               </a:rPr>
-              <a:t>Two runs went wrong — diagnose the batch size</a:t>
+              <a:t>Batch size shapes which valley you land in</a:t>
             </a:r>
           </a:p>
         </p:txBody>
       </p:sp>
       <p:pic>
         <p:nvPicPr>
-          <p:cNvPr id="5" name="Picture 4" descr="fig_batch_youdo.png"/>
+          <p:cNvPr id="5" name="Picture 4" descr="fig_batch_tradeoff.png"/>
           <p:cNvPicPr>
             <a:picLocks noChangeAspect="1"/>
           </p:cNvPicPr>
@@ -8129,8 +8139,8 @@
         </p:blipFill>
         <p:spPr>
           <a:xfrm>
-            <a:off x="1699128" y="1828800"/>
-            <a:ext cx="8763263" cy="3617976"/>
+            <a:off x="2169552" y="1828800"/>
+            <a:ext cx="7822415" cy="3383280"/>
           </a:xfrm>
           <a:prstGeom prst="rect">
             <a:avLst/>
@@ -8145,7 +8155,7 @@
         </p:nvSpPr>
         <p:spPr>
           <a:xfrm>
-            <a:off x="548640" y="5538216"/>
+            <a:off x="548640" y="5303520"/>
             <a:ext cx="10515600" cy="1182624"/>
           </a:xfrm>
           <a:prstGeom prst="rect">
@@ -8156,7 +8166,7 @@
           </a:solidFill>
           <a:ln w="12700">
             <a:solidFill>
-              <a:srgbClr val="E09E2F"/>
+              <a:srgbClr val="3D444C"/>
             </a:solidFill>
           </a:ln>
           <a:effectLst/>
@@ -8181,22 +8191,13 @@
           <a:p>
             <a:pPr algn="ctr"/>
             <a:r>
-              <a:rPr sz="1200" b="1" i="0">
-                <a:solidFill>
-                  <a:srgbClr val="E09E2F"/>
-                </a:solidFill>
-                <a:latin typeface="Menlo"/>
-              </a:rPr>
-              <a:t>CHECKPOINT · </a:t>
-            </a:r>
-            <a:r>
               <a:rPr sz="1700" b="0" i="0">
                 <a:solidFill>
                   <a:srgbClr val="3D444C"/>
                 </a:solidFill>
                 <a:latin typeface="Avenir Next"/>
               </a:rPr>
-              <a:t>Your turn → Quiz 4, Q3. A colleague retrained this classifier and hit two problems: (a) batch 1024 → 'CUDA out of memory' before epoch 1; (b) batch 512 → smooth curve, but it plateaus HIGHER than batch-32 did (the picture). For each, say what it reveals about the batch and one change. Worked answer in the notes.</a:t>
+              <a:t>Same loss plane, two batch sizes. SMALL batch: noisy gradient → many small, jittery steps into a wide FLAT basin that generalizes. LARGE batch: clean gradient → few big, confident steps into a narrow SHARP basin that generalizes worse. A bigger batch buys a cleaner gradient and better GPU use — but there is a too-big cost.</a:t>
             </a:r>
           </a:p>
         </p:txBody>
@@ -8300,7 +8301,7 @@
                 </a:solidFill>
                 <a:latin typeface="Menlo"/>
               </a:rPr>
-              <a:t>PART 2 · TUNING · SEARCHING COMBINATIONS</a:t>
+              <a:t>PART 2 · TUNING · YOUR TURN (YOU-DO = Q3)</a:t>
             </a:r>
           </a:p>
         </p:txBody>
@@ -8334,14 +8335,14 @@
                 </a:solidFill>
                 <a:latin typeface="Avenir Next"/>
               </a:rPr>
-              <a:t>Grid vs. random search: random usually wins</a:t>
+              <a:t>Two runs went wrong — diagnose the batch size</a:t>
             </a:r>
           </a:p>
         </p:txBody>
       </p:sp>
       <p:pic>
         <p:nvPicPr>
-          <p:cNvPr id="5" name="Picture 4" descr="fig_search.png"/>
+          <p:cNvPr id="5" name="Picture 4" descr="fig_batch_youdo.png"/>
           <p:cNvPicPr>
             <a:picLocks noChangeAspect="1"/>
           </p:cNvPicPr>
@@ -8355,8 +8356,8 @@
         </p:blipFill>
         <p:spPr>
           <a:xfrm>
-            <a:off x="1619227" y="1828800"/>
-            <a:ext cx="8923066" cy="3358897"/>
+            <a:off x="1699128" y="1828800"/>
+            <a:ext cx="8763263" cy="3617976"/>
           </a:xfrm>
           <a:prstGeom prst="rect">
             <a:avLst/>
@@ -8371,8 +8372,8 @@
         </p:nvSpPr>
         <p:spPr>
           <a:xfrm>
-            <a:off x="548640" y="5279137"/>
-            <a:ext cx="10515600" cy="1441703"/>
+            <a:off x="548640" y="5538216"/>
+            <a:ext cx="10515600" cy="1182624"/>
           </a:xfrm>
           <a:prstGeom prst="rect">
             <a:avLst/>
@@ -8382,7 +8383,7 @@
           </a:solidFill>
           <a:ln w="12700">
             <a:solidFill>
-              <a:srgbClr val="3D444C"/>
+              <a:srgbClr val="E09E2F"/>
             </a:solidFill>
           </a:ln>
           <a:effectLst/>
@@ -8407,13 +8408,22 @@
           <a:p>
             <a:pPr algn="ctr"/>
             <a:r>
+              <a:rPr sz="1200" b="1" i="0">
+                <a:solidFill>
+                  <a:srgbClr val="E09E2F"/>
+                </a:solidFill>
+                <a:latin typeface="Menlo"/>
+              </a:rPr>
+              <a:t>CHECKPOINT · </a:t>
+            </a:r>
+            <a:r>
               <a:rPr sz="1700" b="0" i="0">
                 <a:solidFill>
                   <a:srgbClr val="3D444C"/>
                 </a:solidFill>
                 <a:latin typeface="Avenir Next"/>
               </a:rPr>
-              <a:t>Searching learning rate × batch size for a DRIAMS spectra classifier: when one knob (the learning rate) matters far more than others, random search samples many more values of it for the same budget — so it beats a rigid grid. Smarter still: Bayesian optimization (Optuna, Ray Tune) learns from your past trials and spends its budget where a good score looks most likely.</a:t>
+              <a:t>Your turn → Quiz 4, Q3. A colleague retrained this classifier and hit two problems: (a) batch 1024 → 'CUDA out of memory' before epoch 1; (b) batch 512 → smooth curve, but it plateaus HIGHER than batch-32 did (the picture). For each, say what it reveals about the batch and one change. Worked answer in the notes.</a:t>
             </a:r>
           </a:p>
         </p:txBody>
@@ -8517,7 +8527,7 @@
                 </a:solidFill>
                 <a:latin typeface="Menlo"/>
               </a:rPr>
-              <a:t>LECTURE 4 · PART 3 OF 3</a:t>
+              <a:t>PART 2 · TUNING · SEARCHING COMBINATIONS</a:t>
             </a:r>
           </a:p>
         </p:txBody>
@@ -8530,8 +8540,8 @@
         </p:nvSpPr>
         <p:spPr>
           <a:xfrm>
-            <a:off x="548640" y="2194560"/>
-            <a:ext cx="11064240" cy="2011680"/>
+            <a:off x="548640" y="731520"/>
+            <a:ext cx="11064240" cy="615553"/>
           </a:xfrm>
           <a:prstGeom prst="rect">
             <a:avLst/>
@@ -8539,58 +8549,83 @@
           <a:noFill/>
         </p:spPr>
         <p:txBody>
-          <a:bodyPr wrap="square" anchor="ctr">
+          <a:bodyPr wrap="square" anchor="t">
             <a:spAutoFit/>
           </a:bodyPr>
           <a:lstStyle/>
           <a:p>
             <a:r>
-              <a:rPr sz="4400" b="1" i="0">
+              <a:rPr sz="3400" b="1" i="0" dirty="0">
                 <a:solidFill>
                   <a:srgbClr val="1B2025"/>
                 </a:solidFill>
                 <a:latin typeface="Avenir Next"/>
               </a:rPr>
-              <a:t>Overfitting vs. underfitting</a:t>
-            </a:r>
-          </a:p>
-          <a:p>
-            <a:pPr>
-              <a:spcBef>
-                <a:spcPts val="1600"/>
-              </a:spcBef>
-            </a:pPr>
-            <a:r>
-              <a:rPr sz="2200" b="0" i="0">
-                <a:solidFill>
-                  <a:srgbClr val="0E7C7B"/>
-                </a:solidFill>
-                <a:latin typeface="Avenir Next"/>
-              </a:rPr>
-              <a:t>reading train-vs-validation curves — and four ways to fix a leak</a:t>
-            </a:r>
-          </a:p>
-        </p:txBody>
-      </p:sp>
-      <p:sp>
-        <p:nvSpPr>
-          <p:cNvPr id="5" name="Rectangle 4"/>
+              <a:t>Grid vs. random search</a:t>
+            </a:r>
+            <a:r>
+              <a:rPr lang="en-US" sz="3400" b="1" i="0" dirty="0">
+                <a:solidFill>
+                  <a:srgbClr val="1B2025"/>
+                </a:solidFill>
+                <a:latin typeface="Avenir Next"/>
+              </a:rPr>
+              <a:t> vs. Bayesian</a:t>
+            </a:r>
+            <a:endParaRPr sz="3400" b="1" i="0" dirty="0">
+              <a:solidFill>
+                <a:srgbClr val="1B2025"/>
+              </a:solidFill>
+              <a:latin typeface="Avenir Next"/>
+            </a:endParaRPr>
+          </a:p>
+        </p:txBody>
+      </p:sp>
+      <p:pic>
+        <p:nvPicPr>
+          <p:cNvPr id="5" name="Picture 4" descr="fig_search.png"/>
+          <p:cNvPicPr>
+            <a:picLocks noChangeAspect="1"/>
+          </p:cNvPicPr>
+          <p:nvPr/>
+        </p:nvPicPr>
+        <p:blipFill>
+          <a:blip r:embed="rId3"/>
+          <a:stretch>
+            <a:fillRect/>
+          </a:stretch>
+        </p:blipFill>
+        <p:spPr>
+          <a:xfrm>
+            <a:off x="1619227" y="1828800"/>
+            <a:ext cx="8923066" cy="3358897"/>
+          </a:xfrm>
+          <a:prstGeom prst="rect">
+            <a:avLst/>
+          </a:prstGeom>
+        </p:spPr>
+      </p:pic>
+      <p:sp>
+        <p:nvSpPr>
+          <p:cNvPr id="6" name="Rectangle 5"/>
           <p:cNvSpPr/>
           <p:nvPr/>
         </p:nvSpPr>
         <p:spPr>
           <a:xfrm>
-            <a:off x="548640" y="2057400"/>
-            <a:ext cx="1280160" cy="54864"/>
+            <a:off x="548640" y="5279137"/>
+            <a:ext cx="10515600" cy="1441703"/>
           </a:xfrm>
           <a:prstGeom prst="rect">
             <a:avLst/>
           </a:prstGeom>
           <a:solidFill>
-            <a:srgbClr val="E09E2F"/>
+            <a:srgbClr val="F1F1EC"/>
           </a:solidFill>
-          <a:ln>
-            <a:noFill/>
+          <a:ln w="12700">
+            <a:solidFill>
+              <a:srgbClr val="3D444C"/>
+            </a:solidFill>
           </a:ln>
           <a:effectLst/>
         </p:spPr>
@@ -8609,11 +8644,19 @@
           </a:fontRef>
         </p:style>
         <p:txBody>
-          <a:bodyPr rtlCol="0" anchor="ctr"/>
+          <a:bodyPr wrap="square" lIns="182880" rIns="182880" rtlCol="0" anchor="ctr"/>
           <a:lstStyle/>
           <a:p>
             <a:pPr algn="ctr"/>
-            <a:endParaRPr/>
+            <a:r>
+              <a:rPr sz="1700" b="0" i="0">
+                <a:solidFill>
+                  <a:srgbClr val="3D444C"/>
+                </a:solidFill>
+                <a:latin typeface="Avenir Next"/>
+              </a:rPr>
+              <a:t>Searching learning rate × batch size for a DRIAMS spectra classifier: when one knob (the learning rate) matters far more than others, random search samples many more values of it for the same budget — so it beats a rigid grid. Smarter still: Bayesian optimization (Optuna, Ray Tune) learns from your past trials and spends its budget where a good score looks most likely.</a:t>
+            </a:r>
           </a:p>
         </p:txBody>
       </p:sp>
@@ -8716,7 +8759,7 @@
                 </a:solidFill>
                 <a:latin typeface="Menlo"/>
               </a:rPr>
-              <a:t>PART 3 · OVERFITTING · THE PICTURE EVERYONE MEANS</a:t>
+              <a:t>LECTURE 4 · PART 3 OF 3</a:t>
             </a:r>
           </a:p>
         </p:txBody>
@@ -8729,8 +8772,8 @@
         </p:nvSpPr>
         <p:spPr>
           <a:xfrm>
-            <a:off x="548640" y="731520"/>
-            <a:ext cx="11064240" cy="1005840"/>
+            <a:off x="548640" y="2194560"/>
+            <a:ext cx="11064240" cy="2011680"/>
           </a:xfrm>
           <a:prstGeom prst="rect">
             <a:avLst/>
@@ -8738,68 +8781,58 @@
           <a:noFill/>
         </p:spPr>
         <p:txBody>
-          <a:bodyPr wrap="square" anchor="t">
+          <a:bodyPr wrap="square" anchor="ctr">
             <a:spAutoFit/>
           </a:bodyPr>
           <a:lstStyle/>
           <a:p>
             <a:r>
-              <a:rPr sz="3400" b="1" i="0">
+              <a:rPr sz="4400" b="1" i="0">
                 <a:solidFill>
                   <a:srgbClr val="1B2025"/>
                 </a:solidFill>
                 <a:latin typeface="Avenir Next"/>
               </a:rPr>
-              <a:t>Fit the trend, not the noise</a:t>
-            </a:r>
-          </a:p>
-        </p:txBody>
-      </p:sp>
-      <p:pic>
-        <p:nvPicPr>
-          <p:cNvPr id="5" name="Picture 4" descr="fig_fit_trio.png"/>
-          <p:cNvPicPr>
-            <a:picLocks noChangeAspect="1"/>
-          </p:cNvPicPr>
-          <p:nvPr/>
-        </p:nvPicPr>
-        <p:blipFill>
-          <a:blip r:embed="rId3"/>
-          <a:stretch>
-            <a:fillRect/>
-          </a:stretch>
-        </p:blipFill>
-        <p:spPr>
-          <a:xfrm>
-            <a:off x="1788760" y="1828800"/>
-            <a:ext cx="8584000" cy="3017520"/>
-          </a:xfrm>
-          <a:prstGeom prst="rect">
-            <a:avLst/>
-          </a:prstGeom>
-        </p:spPr>
-      </p:pic>
-      <p:sp>
-        <p:nvSpPr>
-          <p:cNvPr id="6" name="Rectangle 5"/>
+              <a:t>Overfitting vs. underfitting</a:t>
+            </a:r>
+          </a:p>
+          <a:p>
+            <a:pPr>
+              <a:spcBef>
+                <a:spcPts val="1600"/>
+              </a:spcBef>
+            </a:pPr>
+            <a:r>
+              <a:rPr sz="2200" b="0" i="0">
+                <a:solidFill>
+                  <a:srgbClr val="0E7C7B"/>
+                </a:solidFill>
+                <a:latin typeface="Avenir Next"/>
+              </a:rPr>
+              <a:t>reading train-vs-validation curves — and four ways to fix a leak</a:t>
+            </a:r>
+          </a:p>
+        </p:txBody>
+      </p:sp>
+      <p:sp>
+        <p:nvSpPr>
+          <p:cNvPr id="5" name="Rectangle 4"/>
           <p:cNvSpPr/>
           <p:nvPr/>
         </p:nvSpPr>
         <p:spPr>
           <a:xfrm>
-            <a:off x="548640" y="4937760"/>
-            <a:ext cx="10515600" cy="1182624"/>
+            <a:off x="548640" y="2057400"/>
+            <a:ext cx="1280160" cy="54864"/>
           </a:xfrm>
           <a:prstGeom prst="rect">
             <a:avLst/>
           </a:prstGeom>
           <a:solidFill>
-            <a:srgbClr val="F1F1EC"/>
+            <a:srgbClr val="E09E2F"/>
           </a:solidFill>
-          <a:ln w="12700">
-            <a:solidFill>
-              <a:srgbClr val="3D444C"/>
-            </a:solidFill>
+          <a:ln>
+            <a:noFill/>
           </a:ln>
           <a:effectLst/>
         </p:spPr>
@@ -8818,19 +8851,11 @@
           </a:fontRef>
         </p:style>
         <p:txBody>
-          <a:bodyPr wrap="square" lIns="182880" rIns="182880" rtlCol="0" anchor="ctr"/>
+          <a:bodyPr rtlCol="0" anchor="ctr"/>
           <a:lstStyle/>
           <a:p>
             <a:pPr algn="ctr"/>
-            <a:r>
-              <a:rPr sz="1700" b="0" i="0">
-                <a:solidFill>
-                  <a:srgbClr val="3D444C"/>
-                </a:solidFill>
-                <a:latin typeface="Avenir Next"/>
-              </a:rPr>
-              <a:t>Same seven noisy points, three models. Underfitting: a line too simple to catch the trend. Just right: a smooth curve that follows the trend and ignores the wiggle. Overfitting: a curve contorted through every point — 'perfect' on these dots, useless on the NEXT one. The goal is the trend, not a perfect score on the training dots.</a:t>
-            </a:r>
+            <a:endParaRPr/>
           </a:p>
         </p:txBody>
       </p:sp>
@@ -8861,6 +8886,51 @@
       </p:grpSpPr>
       <p:sp>
         <p:nvSpPr>
+          <p:cNvPr id="2" name="Rectangle 1"/>
+          <p:cNvSpPr/>
+          <p:nvPr/>
+        </p:nvSpPr>
+        <p:spPr>
+          <a:xfrm>
+            <a:off x="0" y="0"/>
+            <a:ext cx="12191695" cy="6858000"/>
+          </a:xfrm>
+          <a:prstGeom prst="rect">
+            <a:avLst/>
+          </a:prstGeom>
+          <a:solidFill>
+            <a:srgbClr val="FBFBF8"/>
+          </a:solidFill>
+          <a:ln>
+            <a:noFill/>
+          </a:ln>
+          <a:effectLst/>
+        </p:spPr>
+        <p:style>
+          <a:lnRef idx="1">
+            <a:schemeClr val="accent1"/>
+          </a:lnRef>
+          <a:fillRef idx="3">
+            <a:schemeClr val="accent1"/>
+          </a:fillRef>
+          <a:effectRef idx="2">
+            <a:schemeClr val="accent1"/>
+          </a:effectRef>
+          <a:fontRef idx="minor">
+            <a:schemeClr val="lt1"/>
+          </a:fontRef>
+        </p:style>
+        <p:txBody>
+          <a:bodyPr rtlCol="0" anchor="ctr"/>
+          <a:lstStyle/>
+          <a:p>
+            <a:pPr algn="ctr"/>
+            <a:endParaRPr/>
+          </a:p>
+        </p:txBody>
+      </p:sp>
+      <p:sp>
+        <p:nvSpPr>
           <p:cNvPr id="3" name="TextBox 2"/>
           <p:cNvSpPr txBox="1"/>
           <p:nvPr/>
@@ -8888,7 +8958,7 @@
                 </a:solidFill>
                 <a:latin typeface="Menlo"/>
               </a:rPr>
-              <a:t>PART 3 · OVERFITTING · READ THE TWO CURVES (I-DO)</a:t>
+              <a:t>PART 3 · OVERFITTING · THE PICTURE EVERYONE MEANS</a:t>
             </a:r>
           </a:p>
         </p:txBody>
@@ -8916,20 +8986,20 @@
           <a:lstStyle/>
           <a:p>
             <a:r>
-              <a:rPr sz="3400" b="1" i="0" dirty="0">
+              <a:rPr sz="3400" b="1" i="0">
                 <a:solidFill>
                   <a:srgbClr val="1B2025"/>
                 </a:solidFill>
                 <a:latin typeface="Avenir Next"/>
               </a:rPr>
-              <a:t>Watch training and validation loss together</a:t>
+              <a:t>Fit the trend, not the noise</a:t>
             </a:r>
           </a:p>
         </p:txBody>
       </p:sp>
       <p:pic>
         <p:nvPicPr>
-          <p:cNvPr id="5" name="Picture 4" descr="fig_trainval_ido.png"/>
+          <p:cNvPr id="5" name="Picture 4" descr="fig_fit_trio.png"/>
           <p:cNvPicPr>
             <a:picLocks noChangeAspect="1"/>
           </p:cNvPicPr>
@@ -8943,8 +9013,8 @@
         </p:blipFill>
         <p:spPr>
           <a:xfrm>
-            <a:off x="1793609" y="2337816"/>
-            <a:ext cx="8482862" cy="3017520"/>
+            <a:off x="1788760" y="1828800"/>
+            <a:ext cx="8584000" cy="3017520"/>
           </a:xfrm>
           <a:prstGeom prst="rect">
             <a:avLst/>
@@ -8959,7 +9029,7 @@
         </p:nvSpPr>
         <p:spPr>
           <a:xfrm>
-            <a:off x="548640" y="5355336"/>
+            <a:off x="548640" y="4937760"/>
             <a:ext cx="10515600" cy="1182624"/>
           </a:xfrm>
           <a:prstGeom prst="rect">
@@ -9001,42 +9071,7 @@
                 </a:solidFill>
                 <a:latin typeface="Avenir Next"/>
               </a:rPr>
-              <a:t>Always plot BOTH: training loss (solid) on data the model learns from, validation loss (dashed) on held-out data it never trains on. Underfitting: both stay HIGH. Just right: both LOW, small gap. Overfitting: training keeps dropping while validation turns back UP. The GAP between them is the tell.</a:t>
-            </a:r>
-          </a:p>
-        </p:txBody>
-      </p:sp>
-      <p:sp>
-        <p:nvSpPr>
-          <p:cNvPr id="7" name="TextBox 6">
-            <a:extLst>
-              <a:ext uri="{FF2B5EF4-FFF2-40B4-BE49-F238E27FC236}">
-                <a16:creationId xmlns:a16="http://schemas.microsoft.com/office/drawing/2014/main" id="{B099972D-57FD-F9AD-F913-8476D04D95DB}"/>
-              </a:ext>
-            </a:extLst>
-          </p:cNvPr>
-          <p:cNvSpPr txBox="1"/>
-          <p:nvPr/>
-        </p:nvSpPr>
-        <p:spPr>
-          <a:xfrm>
-            <a:off x="579120" y="1737360"/>
-            <a:ext cx="4017446" cy="400110"/>
-          </a:xfrm>
-          <a:prstGeom prst="rect">
-            <a:avLst/>
-          </a:prstGeom>
-          <a:noFill/>
-        </p:spPr>
-        <p:txBody>
-          <a:bodyPr wrap="none" rtlCol="0">
-            <a:spAutoFit/>
-          </a:bodyPr>
-          <a:lstStyle/>
-          <a:p>
-            <a:r>
-              <a:rPr lang="en-US" sz="2000" dirty="0"/>
-              <a:t>Use a held-out validation dataset</a:t>
+              <a:t>Same seven noisy points, three models. Underfitting: a line too simple to catch the trend. Just right: a smooth curve that follows the trend and ignores the wiggle. Overfitting: a curve contorted through every point — 'perfect' on these dots, useless on the NEXT one. The goal is the trend, not a perfect score on the training dots.</a:t>
             </a:r>
           </a:p>
         </p:txBody>
@@ -9068,51 +9103,6 @@
       </p:grpSpPr>
       <p:sp>
         <p:nvSpPr>
-          <p:cNvPr id="2" name="Rectangle 1"/>
-          <p:cNvSpPr/>
-          <p:nvPr/>
-        </p:nvSpPr>
-        <p:spPr>
-          <a:xfrm>
-            <a:off x="0" y="0"/>
-            <a:ext cx="12191695" cy="6858000"/>
-          </a:xfrm>
-          <a:prstGeom prst="rect">
-            <a:avLst/>
-          </a:prstGeom>
-          <a:solidFill>
-            <a:srgbClr val="FBFBF8"/>
-          </a:solidFill>
-          <a:ln>
-            <a:noFill/>
-          </a:ln>
-          <a:effectLst/>
-        </p:spPr>
-        <p:style>
-          <a:lnRef idx="1">
-            <a:schemeClr val="accent1"/>
-          </a:lnRef>
-          <a:fillRef idx="3">
-            <a:schemeClr val="accent1"/>
-          </a:fillRef>
-          <a:effectRef idx="2">
-            <a:schemeClr val="accent1"/>
-          </a:effectRef>
-          <a:fontRef idx="minor">
-            <a:schemeClr val="lt1"/>
-          </a:fontRef>
-        </p:style>
-        <p:txBody>
-          <a:bodyPr rtlCol="0" anchor="ctr"/>
-          <a:lstStyle/>
-          <a:p>
-            <a:pPr algn="ctr"/>
-            <a:endParaRPr/>
-          </a:p>
-        </p:txBody>
-      </p:sp>
-      <p:sp>
-        <p:nvSpPr>
           <p:cNvPr id="3" name="TextBox 2"/>
           <p:cNvSpPr txBox="1"/>
           <p:nvPr/>
@@ -9140,7 +9130,7 @@
                 </a:solidFill>
                 <a:latin typeface="Menlo"/>
               </a:rPr>
-              <a:t>PART 3 · OVERFITTING · YOUR TURN (YOU-DO = Q2)</a:t>
+              <a:t>PART 3 · OVERFITTING · READ THE TWO CURVES (I-DO)</a:t>
             </a:r>
           </a:p>
         </p:txBody>
@@ -9168,20 +9158,20 @@
           <a:lstStyle/>
           <a:p>
             <a:r>
-              <a:rPr sz="3400" b="1" i="0">
+              <a:rPr sz="3400" b="1" i="0" dirty="0">
                 <a:solidFill>
                   <a:srgbClr val="1B2025"/>
                 </a:solidFill>
                 <a:latin typeface="Avenir Next"/>
               </a:rPr>
-              <a:t>Diagnose four curve pairs — and name the fix</a:t>
+              <a:t>Watch training and validation loss together</a:t>
             </a:r>
           </a:p>
         </p:txBody>
       </p:sp>
       <p:pic>
         <p:nvPicPr>
-          <p:cNvPr id="5" name="Picture 4" descr="fig_trainval_youdo.png"/>
+          <p:cNvPr id="5" name="Picture 4" descr="fig_trainval_ido.png"/>
           <p:cNvPicPr>
             <a:picLocks noChangeAspect="1"/>
           </p:cNvPicPr>
@@ -9195,8 +9185,8 @@
         </p:blipFill>
         <p:spPr>
           <a:xfrm>
-            <a:off x="1604676" y="1828800"/>
-            <a:ext cx="8952167" cy="2743200"/>
+            <a:off x="1793609" y="2337816"/>
+            <a:ext cx="8482862" cy="3017520"/>
           </a:xfrm>
           <a:prstGeom prst="rect">
             <a:avLst/>
@@ -9211,8 +9201,8 @@
         </p:nvSpPr>
         <p:spPr>
           <a:xfrm>
-            <a:off x="548640" y="4663440"/>
-            <a:ext cx="10515600" cy="923544"/>
+            <a:off x="548640" y="5355336"/>
+            <a:ext cx="10515600" cy="1182624"/>
           </a:xfrm>
           <a:prstGeom prst="rect">
             <a:avLst/>
@@ -9222,7 +9212,7 @@
           </a:solidFill>
           <a:ln w="12700">
             <a:solidFill>
-              <a:srgbClr val="E09E2F"/>
+              <a:srgbClr val="3D444C"/>
             </a:solidFill>
           </a:ln>
           <a:effectLst/>
@@ -9247,36 +9237,33 @@
           <a:p>
             <a:pPr algn="ctr"/>
             <a:r>
-              <a:rPr sz="1200" b="1" i="0">
-                <a:solidFill>
-                  <a:srgbClr val="E09E2F"/>
-                </a:solidFill>
-                <a:latin typeface="Menlo"/>
-              </a:rPr>
-              <a:t>CHECKPOINT · </a:t>
-            </a:r>
-            <a:r>
               <a:rPr sz="1700" b="0" i="0">
                 <a:solidFill>
                   <a:srgbClr val="3D444C"/>
                 </a:solidFill>
                 <a:latin typeface="Avenir Next"/>
               </a:rPr>
-              <a:t>Your turn → Quiz 4, Q2. For each pair write the diagnosis and one fix (use the word banks below). Watch out: (d) is NOT an overfitting problem. 2–3 minutes — worked answer in the notes.</a:t>
-            </a:r>
-          </a:p>
-        </p:txBody>
-      </p:sp>
-      <p:sp>
-        <p:nvSpPr>
-          <p:cNvPr id="7" name="TextBox 6"/>
+              <a:t>Always plot BOTH: training loss (solid) on data the model learns from, validation loss (dashed) on held-out data it never trains on. Underfitting: both stay HIGH. Just right: both LOW, small gap. Overfitting: training keeps dropping while validation turns back UP. The GAP between them is the tell.</a:t>
+            </a:r>
+          </a:p>
+        </p:txBody>
+      </p:sp>
+      <p:sp>
+        <p:nvSpPr>
+          <p:cNvPr id="7" name="TextBox 6">
+            <a:extLst>
+              <a:ext uri="{FF2B5EF4-FFF2-40B4-BE49-F238E27FC236}">
+                <a16:creationId xmlns:a16="http://schemas.microsoft.com/office/drawing/2014/main" id="{B099972D-57FD-F9AD-F913-8476D04D95DB}"/>
+              </a:ext>
+            </a:extLst>
+          </p:cNvPr>
           <p:cNvSpPr txBox="1"/>
           <p:nvPr/>
         </p:nvSpPr>
         <p:spPr>
           <a:xfrm>
-            <a:off x="548640" y="5678424"/>
-            <a:ext cx="10515600" cy="820000"/>
+            <a:off x="579120" y="1737360"/>
+            <a:ext cx="4017446" cy="400110"/>
           </a:xfrm>
           <a:prstGeom prst="rect">
             <a:avLst/>
@@ -9284,58 +9271,14 @@
           <a:noFill/>
         </p:spPr>
         <p:txBody>
-          <a:bodyPr wrap="square" lIns="45720" rIns="45720" tIns="27432" bIns="27432" anchor="t">
+          <a:bodyPr wrap="none" rtlCol="0">
             <a:spAutoFit/>
           </a:bodyPr>
           <a:lstStyle/>
           <a:p>
-            <a:pPr algn="l">
-              <a:spcAft>
-                <a:spcPts val="200"/>
-              </a:spcAft>
-            </a:pPr>
-            <a:r>
-              <a:rPr sz="1200" b="1">
-                <a:solidFill>
-                  <a:srgbClr val="0E7C7B"/>
-                </a:solidFill>
-                <a:latin typeface="Avenir Next"/>
-              </a:rPr>
-              <a:t>Diagnosis bank:</a:t>
-            </a:r>
-            <a:r>
-              <a:rPr sz="1200" b="0">
-                <a:solidFill>
-                  <a:srgbClr val="3D444C"/>
-                </a:solidFill>
-                <a:latin typeface="Avenir Next"/>
-              </a:rPr>
-              <a:t>  underfitting  ·  just right  ·  overfitting  ·  learning rate far too high (diverging)</a:t>
-            </a:r>
-          </a:p>
-          <a:p>
-            <a:pPr algn="l">
-              <a:spcAft>
-                <a:spcPts val="200"/>
-              </a:spcAft>
-            </a:pPr>
-            <a:r>
-              <a:rPr sz="1200" b="1">
-                <a:solidFill>
-                  <a:srgbClr val="0E7C7B"/>
-                </a:solidFill>
-                <a:latin typeface="Avenir Next"/>
-              </a:rPr>
-              <a:t>Fix bank:</a:t>
-            </a:r>
-            <a:r>
-              <a:rPr sz="1200" b="0">
-                <a:solidFill>
-                  <a:srgbClr val="3D444C"/>
-                </a:solidFill>
-                <a:latin typeface="Avenir Next"/>
-              </a:rPr>
-              <a:t>  make the model bigger / train longer  ·  keep it (ship it)  ·  regularize (dropout / weight decay / early stopping / more data)  ·  lower the learning rate</a:t>
+            <a:r>
+              <a:rPr lang="en-US" sz="2000" dirty="0"/>
+              <a:t>Use a held-out validation dataset</a:t>
             </a:r>
           </a:p>
         </p:txBody>
@@ -9439,7 +9382,7 @@
                 </a:solidFill>
                 <a:latin typeface="Menlo"/>
               </a:rPr>
-              <a:t>PART 3 · OVERFITTING · WHAT IT MEANS IN YOUR LAB</a:t>
+              <a:t>PART 3 · OVERFITTING · YOUR TURN (YOU-DO = Q2)</a:t>
             </a:r>
           </a:p>
         </p:txBody>
@@ -9453,7 +9396,7 @@
         <p:spPr>
           <a:xfrm>
             <a:off x="548640" y="731520"/>
-            <a:ext cx="11064240" cy="1127760"/>
+            <a:ext cx="11064240" cy="1005840"/>
           </a:xfrm>
           <a:prstGeom prst="rect">
             <a:avLst/>
@@ -9473,14 +9416,14 @@
                 </a:solidFill>
                 <a:latin typeface="Avenir Next"/>
               </a:rPr>
-              <a:t>Memorizing one instrument's quirks vs. learning the chemistry</a:t>
+              <a:t>Diagnose four curve pairs — and name the fix</a:t>
             </a:r>
           </a:p>
         </p:txBody>
       </p:sp>
       <p:pic>
         <p:nvPicPr>
-          <p:cNvPr id="5" name="Picture 4" descr="maldi_tof_real.png"/>
+          <p:cNvPr id="5" name="Picture 4" descr="fig_trainval_youdo.png"/>
           <p:cNvPicPr>
             <a:picLocks noChangeAspect="1"/>
           </p:cNvPicPr>
@@ -9494,8 +9437,8 @@
         </p:blipFill>
         <p:spPr>
           <a:xfrm>
-            <a:off x="548640" y="1965960"/>
-            <a:ext cx="5394960" cy="1285798"/>
+            <a:off x="1604676" y="1828800"/>
+            <a:ext cx="8952167" cy="2743200"/>
           </a:xfrm>
           <a:prstGeom prst="rect">
             <a:avLst/>
@@ -9504,104 +9447,14 @@
       </p:pic>
       <p:sp>
         <p:nvSpPr>
-          <p:cNvPr id="6" name="TextBox 5"/>
-          <p:cNvSpPr txBox="1"/>
-          <p:nvPr/>
-        </p:nvSpPr>
-        <p:spPr>
-          <a:xfrm>
-            <a:off x="548640" y="3306622"/>
-            <a:ext cx="5394960" cy="411480"/>
-          </a:xfrm>
-          <a:prstGeom prst="rect">
-            <a:avLst/>
-          </a:prstGeom>
-          <a:noFill/>
-        </p:spPr>
-        <p:txBody>
-          <a:bodyPr wrap="square" anchor="t">
-            <a:spAutoFit/>
-          </a:bodyPr>
-          <a:lstStyle/>
-          <a:p>
-            <a:pPr algn="ctr"/>
-            <a:r>
-              <a:rPr sz="1200" b="0" i="1">
-                <a:solidFill>
-                  <a:srgbClr val="8A9099"/>
-                </a:solidFill>
-                <a:latin typeface="Avenir Next"/>
-              </a:rPr>
-              <a:t>real MALDI-TOF spectra · Martisius et al. 2020, Wikimedia Commons, CC BY 4.0</a:t>
-            </a:r>
-          </a:p>
-        </p:txBody>
-      </p:sp>
-      <p:sp>
-        <p:nvSpPr>
-          <p:cNvPr id="7" name="TextBox 6"/>
-          <p:cNvSpPr txBox="1"/>
-          <p:nvPr/>
-        </p:nvSpPr>
-        <p:spPr>
-          <a:xfrm>
-            <a:off x="6309360" y="2011680"/>
-            <a:ext cx="5394960" cy="3657600"/>
-          </a:xfrm>
-          <a:prstGeom prst="rect">
-            <a:avLst/>
-          </a:prstGeom>
-          <a:noFill/>
-        </p:spPr>
-        <p:txBody>
-          <a:bodyPr wrap="square" anchor="t">
-            <a:spAutoFit/>
-          </a:bodyPr>
-          <a:lstStyle/>
-          <a:p>
-            <a:pPr>
-              <a:spcAft>
-                <a:spcPts val="1200"/>
-              </a:spcAft>
-            </a:pPr>
-            <a:r>
-              <a:rPr sz="2100" b="0" i="0">
-                <a:solidFill>
-                  <a:srgbClr val="1B2025"/>
-                </a:solidFill>
-                <a:latin typeface="Avenir Next"/>
-              </a:rPr>
-              <a:t>An overfit spectra classifier can learn the baseline wobble and detector noise of your ONE instrument — hitting 99% in-house.</a:t>
-            </a:r>
-          </a:p>
-          <a:p>
-            <a:pPr>
-              <a:spcAft>
-                <a:spcPts val="1200"/>
-              </a:spcAft>
-            </a:pPr>
-            <a:r>
-              <a:rPr sz="2100" b="0" i="0">
-                <a:solidFill>
-                  <a:srgbClr val="1B2025"/>
-                </a:solidFill>
-                <a:latin typeface="Avenir Next"/>
-              </a:rPr>
-              <a:t>Move it to a second instrument, site, or reagent lot and it collapses: it memorized the machine, not the biology.</a:t>
-            </a:r>
-          </a:p>
-        </p:txBody>
-      </p:sp>
-      <p:sp>
-        <p:nvSpPr>
-          <p:cNvPr id="8" name="Rectangle 7"/>
+          <p:cNvPr id="6" name="Rectangle 5"/>
           <p:cNvSpPr/>
           <p:nvPr/>
         </p:nvSpPr>
         <p:spPr>
           <a:xfrm>
-            <a:off x="6309360" y="5324857"/>
-            <a:ext cx="5394960" cy="1441703"/>
+            <a:off x="548640" y="4663440"/>
+            <a:ext cx="10515600" cy="923544"/>
           </a:xfrm>
           <a:prstGeom prst="rect">
             <a:avLst/>
@@ -9642,7 +9495,7 @@
                 </a:solidFill>
                 <a:latin typeface="Menlo"/>
               </a:rPr>
-              <a:t>PAIR · </a:t>
+              <a:t>CHECKPOINT · </a:t>
             </a:r>
             <a:r>
               <a:rPr sz="1700" b="0" i="0">
@@ -9651,7 +9504,80 @@
                 </a:solidFill>
                 <a:latin typeface="Avenir Next"/>
               </a:rPr>
-              <a:t>💬 Quick show of hands (30 sec): your model scores 99% on training data but only 70% on new samples — under- or over-fitting? Shout out the FIRST fix you'd reach for.</a:t>
+              <a:t>Your turn → Quiz 4, Q2. For each pair write the diagnosis and one fix (use the word banks below). Watch out: (d) is NOT an overfitting problem. 2–3 minutes — worked answer in the notes.</a:t>
+            </a:r>
+          </a:p>
+        </p:txBody>
+      </p:sp>
+      <p:sp>
+        <p:nvSpPr>
+          <p:cNvPr id="7" name="TextBox 6"/>
+          <p:cNvSpPr txBox="1"/>
+          <p:nvPr/>
+        </p:nvSpPr>
+        <p:spPr>
+          <a:xfrm>
+            <a:off x="548640" y="5678424"/>
+            <a:ext cx="10515600" cy="820000"/>
+          </a:xfrm>
+          <a:prstGeom prst="rect">
+            <a:avLst/>
+          </a:prstGeom>
+          <a:noFill/>
+        </p:spPr>
+        <p:txBody>
+          <a:bodyPr wrap="square" lIns="45720" tIns="27432" rIns="45720" bIns="27432" anchor="t">
+            <a:spAutoFit/>
+          </a:bodyPr>
+          <a:lstStyle/>
+          <a:p>
+            <a:pPr algn="l">
+              <a:spcAft>
+                <a:spcPts val="200"/>
+              </a:spcAft>
+            </a:pPr>
+            <a:r>
+              <a:rPr sz="1200" b="1">
+                <a:solidFill>
+                  <a:srgbClr val="0E7C7B"/>
+                </a:solidFill>
+                <a:latin typeface="Avenir Next"/>
+              </a:rPr>
+              <a:t>Diagnosis bank:</a:t>
+            </a:r>
+            <a:r>
+              <a:rPr sz="1200" b="0">
+                <a:solidFill>
+                  <a:srgbClr val="3D444C"/>
+                </a:solidFill>
+                <a:latin typeface="Avenir Next"/>
+              </a:rPr>
+              <a:t>  underfitting  ·  just right  ·  overfitting  ·  learning rate far too high (diverging)</a:t>
+            </a:r>
+          </a:p>
+          <a:p>
+            <a:pPr algn="l">
+              <a:spcAft>
+                <a:spcPts val="200"/>
+              </a:spcAft>
+            </a:pPr>
+            <a:r>
+              <a:rPr sz="1200" b="1">
+                <a:solidFill>
+                  <a:srgbClr val="0E7C7B"/>
+                </a:solidFill>
+                <a:latin typeface="Avenir Next"/>
+              </a:rPr>
+              <a:t>Fix bank:</a:t>
+            </a:r>
+            <a:r>
+              <a:rPr sz="1200" b="0">
+                <a:solidFill>
+                  <a:srgbClr val="3D444C"/>
+                </a:solidFill>
+                <a:latin typeface="Avenir Next"/>
+              </a:rPr>
+              <a:t>  make the model bigger / train longer  ·  keep it (ship it)  ·  regularize (dropout / weight decay / early stopping / more data)  ·  lower the learning rate</a:t>
             </a:r>
           </a:p>
         </p:txBody>
@@ -10637,7 +10563,7 @@
         <p:spPr>
           <a:xfrm>
             <a:off x="548640" y="731520"/>
-            <a:ext cx="11064240" cy="1127760"/>
+            <a:ext cx="11064240" cy="615553"/>
           </a:xfrm>
           <a:prstGeom prst="rect">
             <a:avLst/>
@@ -10651,14 +10577,20 @@
           <a:lstStyle/>
           <a:p>
             <a:r>
-              <a:rPr sz="3400" b="1" i="0">
+              <a:rPr lang="en-US" sz="3400" b="1" i="0" dirty="0">
                 <a:solidFill>
                   <a:srgbClr val="1B2025"/>
                 </a:solidFill>
                 <a:latin typeface="Avenir Next"/>
               </a:rPr>
-              <a:t>When plain accuracy lies: the rare resistant isolate</a:t>
-            </a:r>
+              <a:t>Another type of “Overfitting”: Data Imbalance</a:t>
+            </a:r>
+            <a:endParaRPr sz="3400" b="1" i="0" dirty="0">
+              <a:solidFill>
+                <a:srgbClr val="1B2025"/>
+              </a:solidFill>
+              <a:latin typeface="Avenir Next"/>
+            </a:endParaRPr>
           </a:p>
         </p:txBody>
       </p:sp>
@@ -11272,22 +11204,85 @@
           <a:p>
             <a:pPr algn="ctr"/>
             <a:r>
-              <a:rPr sz="1200" b="1" i="0">
+              <a:rPr lang="en-US" sz="1200" b="1" dirty="0">
                 <a:solidFill>
                   <a:srgbClr val="0E7C7B"/>
                 </a:solidFill>
                 <a:latin typeface="Menlo"/>
               </a:rPr>
-              <a:t>MASS SPEC · </a:t>
-            </a:r>
-            <a:r>
-              <a:rPr sz="1700" b="0" i="0">
+              <a:t>MATH </a:t>
+            </a:r>
+            <a:r>
+              <a:rPr sz="1200" b="1" i="0" dirty="0">
+                <a:solidFill>
+                  <a:srgbClr val="0E7C7B"/>
+                </a:solidFill>
+                <a:latin typeface="Menlo"/>
+              </a:rPr>
+              <a:t>· </a:t>
+            </a:r>
+            <a:r>
+              <a:rPr sz="1700" b="0" i="0" dirty="0">
                 <a:solidFill>
                   <a:srgbClr val="3D444C"/>
                 </a:solidFill>
                 <a:latin typeface="Avenir Next"/>
               </a:rPr>
-              <a:t>The definition, once: softmax(s)ᵢ = e^{sᵢ} / Σⱼ e^{sⱼ} — exponentiate every class score (forces it positive), then divide by the total (forces the sum to 1). Scores R=2.0, S=0.5 → e²·⁰=7.39, e⁰·⁵=1.65, sum 9.04 → 0.82, 0.18. 'The answer' is now a CONFIDENCE per class. Remember this function — attention (Lecture 7) is built on the very same softmax.</a:t>
+              <a:t>The definition, once: </a:t>
+            </a:r>
+            <a:r>
+              <a:rPr sz="1700" b="0" i="0" dirty="0" err="1">
+                <a:solidFill>
+                  <a:srgbClr val="3D444C"/>
+                </a:solidFill>
+                <a:latin typeface="Avenir Next"/>
+              </a:rPr>
+              <a:t>softmax</a:t>
+            </a:r>
+            <a:r>
+              <a:rPr sz="1700" b="0" i="0" dirty="0">
+                <a:solidFill>
+                  <a:srgbClr val="3D444C"/>
+                </a:solidFill>
+                <a:latin typeface="Avenir Next"/>
+              </a:rPr>
+              <a:t>(s)ᵢ = e^{sᵢ} / </a:t>
+            </a:r>
+            <a:r>
+              <a:rPr sz="1700" b="0" i="0" dirty="0" err="1">
+                <a:solidFill>
+                  <a:srgbClr val="3D444C"/>
+                </a:solidFill>
+                <a:latin typeface="Avenir Next"/>
+              </a:rPr>
+              <a:t>Σ</a:t>
+            </a:r>
+            <a:r>
+              <a:rPr sz="1700" b="0" i="0" dirty="0">
+                <a:solidFill>
+                  <a:srgbClr val="3D444C"/>
+                </a:solidFill>
+                <a:latin typeface="Avenir Next"/>
+              </a:rPr>
+              <a:t>ⱼ e^{sⱼ} — exponentiate every class score (forces it positive), then divide by the total (forces the sum to 1). 'The answer' is now a CONFIDENCE per class. Remember this function — attention (Lecture 7) is built on the very same </a:t>
+            </a:r>
+            <a:r>
+              <a:rPr sz="1700" b="0" i="0" dirty="0" err="1">
+                <a:solidFill>
+                  <a:srgbClr val="3D444C"/>
+                </a:solidFill>
+                <a:latin typeface="Avenir Next"/>
+              </a:rPr>
+              <a:t>softmax</a:t>
+            </a:r>
+            <a:r>
+              <a:rPr sz="1700" b="0" i="0" dirty="0">
+                <a:solidFill>
+                  <a:srgbClr val="3D444C"/>
+                </a:solidFill>
+                <a:latin typeface="Avenir Next"/>
+              </a:rPr>
+              <a:t>.</a:t>
             </a:r>
           </a:p>
         </p:txBody>
@@ -11799,7 +11794,7 @@
           <a:p>
             <a:r>
               <a:rPr lang="en-US" dirty="0"/>
-              <a:t>Selecting Proper Loss</a:t>
+              <a:t>Why is Cross-Entropy Better?</a:t>
             </a:r>
           </a:p>
         </p:txBody>
@@ -11999,58 +11994,141 @@
       </p:grpSpPr>
       <p:sp>
         <p:nvSpPr>
-          <p:cNvPr id="2" name="Title 1">
-            <a:extLst>
-              <a:ext uri="{FF2B5EF4-FFF2-40B4-BE49-F238E27FC236}">
-                <a16:creationId xmlns:a16="http://schemas.microsoft.com/office/drawing/2014/main" id="{6D74EBAE-791C-0BEF-EE1C-F46E19EF115A}"/>
-              </a:ext>
-            </a:extLst>
-          </p:cNvPr>
-          <p:cNvSpPr>
-            <a:spLocks noGrp="1"/>
-          </p:cNvSpPr>
-          <p:nvPr>
-            <p:ph type="title"/>
-          </p:nvPr>
-        </p:nvSpPr>
-        <p:spPr/>
-        <p:txBody>
-          <a:bodyPr/>
-          <a:lstStyle/>
-          <a:p>
-            <a:r>
-              <a:rPr lang="en-US" dirty="0"/>
-              <a:t>Results</a:t>
-            </a:r>
+          <p:cNvPr id="2" name="Rectangle 1"/>
+          <p:cNvSpPr/>
+          <p:nvPr/>
+        </p:nvSpPr>
+        <p:spPr>
+          <a:xfrm>
+            <a:off x="0" y="0"/>
+            <a:ext cx="12191695" cy="6858000"/>
+          </a:xfrm>
+          <a:prstGeom prst="rect">
+            <a:avLst/>
+          </a:prstGeom>
+          <a:solidFill>
+            <a:srgbClr val="FBFBF8"/>
+          </a:solidFill>
+          <a:ln>
+            <a:noFill/>
+          </a:ln>
+          <a:effectLst/>
+        </p:spPr>
+        <p:style>
+          <a:lnRef idx="1">
+            <a:schemeClr val="accent1"/>
+          </a:lnRef>
+          <a:fillRef idx="3">
+            <a:schemeClr val="accent1"/>
+          </a:fillRef>
+          <a:effectRef idx="2">
+            <a:schemeClr val="accent1"/>
+          </a:effectRef>
+          <a:fontRef idx="minor">
+            <a:schemeClr val="lt1"/>
+          </a:fontRef>
+        </p:style>
+        <p:txBody>
+          <a:bodyPr rtlCol="0" anchor="ctr"/>
+          <a:lstStyle/>
+          <a:p>
+            <a:pPr algn="ctr"/>
+            <a:endParaRPr/>
+          </a:p>
+        </p:txBody>
+      </p:sp>
+      <p:sp>
+        <p:nvSpPr>
+          <p:cNvPr id="3" name="TextBox 2"/>
+          <p:cNvSpPr txBox="1"/>
+          <p:nvPr/>
+        </p:nvSpPr>
+        <p:spPr>
+          <a:xfrm>
+            <a:off x="548640" y="320040"/>
+            <a:ext cx="10972800" cy="292388"/>
+          </a:xfrm>
+          <a:prstGeom prst="rect">
+            <a:avLst/>
+          </a:prstGeom>
+          <a:noFill/>
+        </p:spPr>
+        <p:txBody>
+          <a:bodyPr wrap="square" anchor="t">
+            <a:spAutoFit/>
+          </a:bodyPr>
+          <a:lstStyle/>
+          <a:p>
+            <a:r>
+              <a:rPr sz="1300" b="1" i="0" dirty="0">
+                <a:solidFill>
+                  <a:srgbClr val="8A9099"/>
+                </a:solidFill>
+                <a:latin typeface="Menlo"/>
+              </a:rPr>
+              <a:t>PART 1 · LOSS · STEP 4</a:t>
+            </a:r>
+          </a:p>
+        </p:txBody>
+      </p:sp>
+      <p:sp>
+        <p:nvSpPr>
+          <p:cNvPr id="4" name="TextBox 3"/>
+          <p:cNvSpPr txBox="1"/>
+          <p:nvPr/>
+        </p:nvSpPr>
+        <p:spPr>
+          <a:xfrm>
+            <a:off x="548640" y="731520"/>
+            <a:ext cx="11064240" cy="615553"/>
+          </a:xfrm>
+          <a:prstGeom prst="rect">
+            <a:avLst/>
+          </a:prstGeom>
+          <a:noFill/>
+        </p:spPr>
+        <p:txBody>
+          <a:bodyPr wrap="square" anchor="t">
+            <a:spAutoFit/>
+          </a:bodyPr>
+          <a:lstStyle/>
+          <a:p>
+            <a:r>
+              <a:rPr lang="en-US" sz="3400" b="1" dirty="0">
+                <a:solidFill>
+                  <a:srgbClr val="1B2025"/>
+                </a:solidFill>
+                <a:latin typeface="Avenir Next"/>
+              </a:rPr>
+              <a:t>CE Loss is harsher</a:t>
+            </a:r>
+            <a:endParaRPr sz="3400" b="1" i="0" dirty="0">
+              <a:solidFill>
+                <a:srgbClr val="1B2025"/>
+              </a:solidFill>
+              <a:latin typeface="Avenir Next"/>
+            </a:endParaRPr>
           </a:p>
         </p:txBody>
       </p:sp>
       <p:pic>
         <p:nvPicPr>
-          <p:cNvPr id="5" name="Content Placeholder 4">
-            <a:extLst>
-              <a:ext uri="{FF2B5EF4-FFF2-40B4-BE49-F238E27FC236}">
-                <a16:creationId xmlns:a16="http://schemas.microsoft.com/office/drawing/2014/main" id="{44042133-10B5-D400-5322-FC257FB53889}"/>
-              </a:ext>
-            </a:extLst>
-          </p:cNvPr>
+          <p:cNvPr id="5" name="Picture 4" descr="fig_ce_worked.png"/>
           <p:cNvPicPr>
-            <a:picLocks noGrp="1" noChangeAspect="1"/>
+            <a:picLocks noChangeAspect="1"/>
           </p:cNvPicPr>
-          <p:nvPr>
-            <p:ph idx="1"/>
-          </p:nvPr>
+          <p:nvPr/>
         </p:nvPicPr>
         <p:blipFill>
-          <a:blip r:embed="rId2"/>
+          <a:blip r:embed="rId3"/>
           <a:stretch>
             <a:fillRect/>
           </a:stretch>
         </p:blipFill>
         <p:spPr>
           <a:xfrm>
-            <a:off x="2063578" y="1708122"/>
-            <a:ext cx="7708713" cy="4646641"/>
+            <a:off x="2166463" y="1828800"/>
+            <a:ext cx="7828594" cy="3291840"/>
           </a:xfrm>
           <a:prstGeom prst="rect">
             <a:avLst/>
@@ -12059,103 +12137,141 @@
       </p:pic>
       <p:sp>
         <p:nvSpPr>
-          <p:cNvPr id="4" name="Text Placeholder 3">
-            <a:extLst>
-              <a:ext uri="{FF2B5EF4-FFF2-40B4-BE49-F238E27FC236}">
-                <a16:creationId xmlns:a16="http://schemas.microsoft.com/office/drawing/2014/main" id="{76A118A6-721F-11E9-4CB7-AF8847D49C3C}"/>
-              </a:ext>
-            </a:extLst>
-          </p:cNvPr>
-          <p:cNvSpPr>
-            <a:spLocks noGrp="1"/>
-          </p:cNvSpPr>
-          <p:nvPr>
-            <p:ph type="body" sz="quarter" idx="13"/>
-          </p:nvPr>
-        </p:nvSpPr>
-        <p:spPr/>
-        <p:txBody>
-          <a:bodyPr>
-            <a:normAutofit/>
-          </a:bodyPr>
-          <a:lstStyle/>
-          <a:p>
-            <a:pPr marL="0" marR="0" lvl="0" indent="0" defTabSz="457200" rtl="0" eaLnBrk="1" fontAlgn="auto" latinLnBrk="0" hangingPunct="1">
-              <a:lnSpc>
-                <a:spcPct val="100000"/>
-              </a:lnSpc>
-              <a:spcBef>
-                <a:spcPts val="0"/>
-              </a:spcBef>
-              <a:spcAft>
-                <a:spcPts val="0"/>
-              </a:spcAft>
-              <a:buClrTx/>
-              <a:buSzTx/>
-              <a:buFontTx/>
-              <a:buNone/>
-              <a:tabLst/>
-              <a:defRPr/>
-            </a:pPr>
-            <a:r>
-              <a:rPr sz="1300" b="1" i="0">
-                <a:solidFill>
-                  <a:srgbClr val="8A9099"/>
+          <p:cNvPr id="6" name="Rectangle 5"/>
+          <p:cNvSpPr/>
+          <p:nvPr/>
+        </p:nvSpPr>
+        <p:spPr>
+          <a:xfrm>
+            <a:off x="548640" y="5212080"/>
+            <a:ext cx="10515600" cy="1441703"/>
+          </a:xfrm>
+          <a:prstGeom prst="rect">
+            <a:avLst/>
+          </a:prstGeom>
+          <a:solidFill>
+            <a:srgbClr val="E3F0EF"/>
+          </a:solidFill>
+          <a:ln w="12700">
+            <a:solidFill>
+              <a:srgbClr val="0E7C7B"/>
+            </a:solidFill>
+          </a:ln>
+          <a:effectLst/>
+        </p:spPr>
+        <p:style>
+          <a:lnRef idx="1">
+            <a:schemeClr val="accent1"/>
+          </a:lnRef>
+          <a:fillRef idx="3">
+            <a:schemeClr val="accent1"/>
+          </a:fillRef>
+          <a:effectRef idx="2">
+            <a:schemeClr val="accent1"/>
+          </a:effectRef>
+          <a:fontRef idx="minor">
+            <a:schemeClr val="lt1"/>
+          </a:fontRef>
+        </p:style>
+        <p:txBody>
+          <a:bodyPr wrap="square" lIns="182880" rIns="182880" rtlCol="0" anchor="ctr"/>
+          <a:lstStyle/>
+          <a:p>
+            <a:pPr algn="ctr"/>
+            <a:r>
+              <a:rPr sz="1200" b="1" i="0" dirty="0">
+                <a:solidFill>
+                  <a:srgbClr val="0E7C7B"/>
                 </a:solidFill>
                 <a:latin typeface="Menlo"/>
               </a:rPr>
-              <a:t>PART 1 · LOSS · THE RESULT</a:t>
-            </a:r>
-          </a:p>
-        </p:txBody>
-      </p:sp>
-      <p:sp>
-        <p:nvSpPr>
-          <p:cNvPr id="6" name="TextBox 5">
-            <a:extLst>
-              <a:ext uri="{FF2B5EF4-FFF2-40B4-BE49-F238E27FC236}">
-                <a16:creationId xmlns:a16="http://schemas.microsoft.com/office/drawing/2014/main" id="{8E007FFA-490F-C63F-A898-A747DF58590B}"/>
-              </a:ext>
-            </a:extLst>
-          </p:cNvPr>
-          <p:cNvSpPr txBox="1"/>
-          <p:nvPr/>
-        </p:nvSpPr>
-        <p:spPr>
-          <a:xfrm>
-            <a:off x="7006855" y="6394420"/>
-            <a:ext cx="3601563" cy="307777"/>
-          </a:xfrm>
-          <a:prstGeom prst="rect">
-            <a:avLst/>
-          </a:prstGeom>
-          <a:noFill/>
-        </p:spPr>
-        <p:txBody>
-          <a:bodyPr wrap="none" rtlCol="0">
-            <a:spAutoFit/>
-          </a:bodyPr>
-          <a:lstStyle/>
-          <a:p>
-            <a:r>
-              <a:rPr lang="en-US" sz="1400" i="1" dirty="0">
-                <a:solidFill>
-                  <a:schemeClr val="accent6">
-                    <a:lumMod val="75000"/>
-                  </a:schemeClr>
-                </a:solidFill>
-              </a:rPr>
-              <a:t>cc deep learning in one day from Prof. Lee</a:t>
+              <a:t>MASS SPEC · </a:t>
+            </a:r>
+            <a:r>
+              <a:rPr sz="1700" b="0" i="0" dirty="0">
+                <a:solidFill>
+                  <a:srgbClr val="3D444C"/>
+                </a:solidFill>
+                <a:latin typeface="Avenir Next"/>
+              </a:rPr>
+              <a:t>Same call (both pick R, so accuracy counts both 'correct') — but plug into CE = −ln(p): A = −ln(0.90) = 0.105, B = −ln(0.55) = 0.598, so B's hedge costs 5.7× the loss. Rule of thumb: predict a NUMBER → MSE; choose a CLASS → cross-entropy. In </a:t>
+            </a:r>
+            <a:r>
+              <a:rPr sz="1700" b="0" i="0" dirty="0" err="1">
+                <a:solidFill>
+                  <a:srgbClr val="3D444C"/>
+                </a:solidFill>
+                <a:latin typeface="Avenir Next"/>
+              </a:rPr>
+              <a:t>PyTorch</a:t>
+            </a:r>
+            <a:r>
+              <a:rPr sz="1700" b="0" i="0" dirty="0">
+                <a:solidFill>
+                  <a:srgbClr val="3D444C"/>
+                </a:solidFill>
+                <a:latin typeface="Avenir Next"/>
+              </a:rPr>
+              <a:t>, one line: </a:t>
+            </a:r>
+            <a:r>
+              <a:rPr sz="1700" b="0" i="0" dirty="0" err="1">
+                <a:solidFill>
+                  <a:srgbClr val="3D444C"/>
+                </a:solidFill>
+                <a:latin typeface="Avenir Next"/>
+              </a:rPr>
+              <a:t>nn.MSELoss</a:t>
+            </a:r>
+            <a:r>
+              <a:rPr sz="1700" b="0" i="0" dirty="0">
+                <a:solidFill>
+                  <a:srgbClr val="3D444C"/>
+                </a:solidFill>
+                <a:latin typeface="Avenir Next"/>
+              </a:rPr>
+              <a:t> → </a:t>
+            </a:r>
+            <a:r>
+              <a:rPr sz="1700" b="0" i="0" dirty="0" err="1">
+                <a:solidFill>
+                  <a:srgbClr val="3D444C"/>
+                </a:solidFill>
+                <a:latin typeface="Avenir Next"/>
+              </a:rPr>
+              <a:t>nn.CrossEntropyLoss</a:t>
+            </a:r>
+            <a:r>
+              <a:rPr sz="1700" b="0" i="0" dirty="0">
+                <a:solidFill>
+                  <a:srgbClr val="3D444C"/>
+                </a:solidFill>
+                <a:latin typeface="Avenir Next"/>
+              </a:rPr>
+              <a:t> (it even applies </a:t>
+            </a:r>
+            <a:r>
+              <a:rPr sz="1700" b="0" i="0" dirty="0" err="1">
+                <a:solidFill>
+                  <a:srgbClr val="3D444C"/>
+                </a:solidFill>
+                <a:latin typeface="Avenir Next"/>
+              </a:rPr>
+              <a:t>softmax</a:t>
+            </a:r>
+            <a:r>
+              <a:rPr sz="1700" b="0" i="0" dirty="0">
+                <a:solidFill>
+                  <a:srgbClr val="3D444C"/>
+                </a:solidFill>
+                <a:latin typeface="Avenir Next"/>
+              </a:rPr>
+              <a:t> internally).</a:t>
             </a:r>
           </a:p>
         </p:txBody>
       </p:sp>
     </p:spTree>
-    <p:extLst>
-      <p:ext uri="{BB962C8B-B14F-4D97-AF65-F5344CB8AC3E}">
-        <p14:creationId xmlns:p14="http://schemas.microsoft.com/office/powerpoint/2010/main" val="1697687664"/>
-      </p:ext>
-    </p:extLst>
   </p:cSld>
   <p:clrMapOvr>
     <a:masterClrMapping/>
@@ -12182,144 +12298,58 @@
       </p:grpSpPr>
       <p:sp>
         <p:nvSpPr>
-          <p:cNvPr id="2" name="Rectangle 1"/>
-          <p:cNvSpPr/>
-          <p:nvPr/>
-        </p:nvSpPr>
-        <p:spPr>
-          <a:xfrm>
-            <a:off x="0" y="0"/>
-            <a:ext cx="12191695" cy="6858000"/>
-          </a:xfrm>
-          <a:prstGeom prst="rect">
-            <a:avLst/>
-          </a:prstGeom>
-          <a:solidFill>
-            <a:srgbClr val="FBFBF8"/>
-          </a:solidFill>
-          <a:ln>
-            <a:noFill/>
-          </a:ln>
-          <a:effectLst/>
-        </p:spPr>
-        <p:style>
-          <a:lnRef idx="1">
-            <a:schemeClr val="accent1"/>
-          </a:lnRef>
-          <a:fillRef idx="3">
-            <a:schemeClr val="accent1"/>
-          </a:fillRef>
-          <a:effectRef idx="2">
-            <a:schemeClr val="accent1"/>
-          </a:effectRef>
-          <a:fontRef idx="minor">
-            <a:schemeClr val="lt1"/>
-          </a:fontRef>
-        </p:style>
-        <p:txBody>
-          <a:bodyPr rtlCol="0" anchor="ctr"/>
-          <a:lstStyle/>
-          <a:p>
-            <a:pPr algn="ctr"/>
-            <a:endParaRPr/>
-          </a:p>
-        </p:txBody>
-      </p:sp>
-      <p:sp>
-        <p:nvSpPr>
-          <p:cNvPr id="3" name="TextBox 2"/>
-          <p:cNvSpPr txBox="1"/>
-          <p:nvPr/>
-        </p:nvSpPr>
-        <p:spPr>
-          <a:xfrm>
-            <a:off x="548640" y="320040"/>
-            <a:ext cx="10972800" cy="292388"/>
-          </a:xfrm>
-          <a:prstGeom prst="rect">
-            <a:avLst/>
-          </a:prstGeom>
-          <a:noFill/>
-        </p:spPr>
-        <p:txBody>
-          <a:bodyPr wrap="square" anchor="t">
-            <a:spAutoFit/>
-          </a:bodyPr>
-          <a:lstStyle/>
-          <a:p>
-            <a:r>
-              <a:rPr sz="1300" b="1" i="0" dirty="0">
-                <a:solidFill>
-                  <a:srgbClr val="8A9099"/>
-                </a:solidFill>
-                <a:latin typeface="Menlo"/>
-              </a:rPr>
-              <a:t>PART 1 · LOSS · STEP 4</a:t>
-            </a:r>
-          </a:p>
-        </p:txBody>
-      </p:sp>
-      <p:sp>
-        <p:nvSpPr>
-          <p:cNvPr id="4" name="TextBox 3"/>
-          <p:cNvSpPr txBox="1"/>
-          <p:nvPr/>
-        </p:nvSpPr>
-        <p:spPr>
-          <a:xfrm>
-            <a:off x="548640" y="731520"/>
-            <a:ext cx="11064240" cy="615553"/>
-          </a:xfrm>
-          <a:prstGeom prst="rect">
-            <a:avLst/>
-          </a:prstGeom>
-          <a:noFill/>
-        </p:spPr>
-        <p:txBody>
-          <a:bodyPr wrap="square" anchor="t">
-            <a:spAutoFit/>
-          </a:bodyPr>
-          <a:lstStyle/>
-          <a:p>
-            <a:r>
-              <a:rPr lang="en-US" sz="3400" b="1" dirty="0">
-                <a:solidFill>
-                  <a:srgbClr val="1B2025"/>
-                </a:solidFill>
-                <a:latin typeface="Avenir Next"/>
-              </a:rPr>
-              <a:t>C</a:t>
-            </a:r>
-            <a:r>
-              <a:rPr sz="3400" b="1" i="0" dirty="0">
-                <a:solidFill>
-                  <a:srgbClr val="1B2025"/>
-                </a:solidFill>
-                <a:latin typeface="Avenir Next"/>
-              </a:rPr>
-              <a:t>onfidence changes the loss</a:t>
+          <p:cNvPr id="2" name="Title 1">
+            <a:extLst>
+              <a:ext uri="{FF2B5EF4-FFF2-40B4-BE49-F238E27FC236}">
+                <a16:creationId xmlns:a16="http://schemas.microsoft.com/office/drawing/2014/main" id="{6D74EBAE-791C-0BEF-EE1C-F46E19EF115A}"/>
+              </a:ext>
+            </a:extLst>
+          </p:cNvPr>
+          <p:cNvSpPr>
+            <a:spLocks noGrp="1"/>
+          </p:cNvSpPr>
+          <p:nvPr>
+            <p:ph type="title"/>
+          </p:nvPr>
+        </p:nvSpPr>
+        <p:spPr/>
+        <p:txBody>
+          <a:bodyPr/>
+          <a:lstStyle/>
+          <a:p>
+            <a:r>
+              <a:rPr lang="en-US" dirty="0"/>
+              <a:t>Results</a:t>
             </a:r>
           </a:p>
         </p:txBody>
       </p:sp>
       <p:pic>
         <p:nvPicPr>
-          <p:cNvPr id="5" name="Picture 4" descr="fig_ce_worked.png"/>
+          <p:cNvPr id="5" name="Content Placeholder 4">
+            <a:extLst>
+              <a:ext uri="{FF2B5EF4-FFF2-40B4-BE49-F238E27FC236}">
+                <a16:creationId xmlns:a16="http://schemas.microsoft.com/office/drawing/2014/main" id="{44042133-10B5-D400-5322-FC257FB53889}"/>
+              </a:ext>
+            </a:extLst>
+          </p:cNvPr>
           <p:cNvPicPr>
-            <a:picLocks noChangeAspect="1"/>
+            <a:picLocks noGrp="1" noChangeAspect="1"/>
           </p:cNvPicPr>
-          <p:nvPr/>
+          <p:nvPr>
+            <p:ph idx="1"/>
+          </p:nvPr>
         </p:nvPicPr>
         <p:blipFill>
-          <a:blip r:embed="rId3"/>
+          <a:blip r:embed="rId2"/>
           <a:stretch>
             <a:fillRect/>
           </a:stretch>
         </p:blipFill>
         <p:spPr>
           <a:xfrm>
-            <a:off x="2166463" y="1828800"/>
-            <a:ext cx="7828594" cy="3291840"/>
+            <a:off x="2063578" y="1708122"/>
+            <a:ext cx="7708713" cy="4646641"/>
           </a:xfrm>
           <a:prstGeom prst="rect">
             <a:avLst/>
@@ -12328,141 +12358,103 @@
       </p:pic>
       <p:sp>
         <p:nvSpPr>
-          <p:cNvPr id="6" name="Rectangle 5"/>
-          <p:cNvSpPr/>
-          <p:nvPr/>
-        </p:nvSpPr>
-        <p:spPr>
-          <a:xfrm>
-            <a:off x="548640" y="5212080"/>
-            <a:ext cx="10515600" cy="1441703"/>
-          </a:xfrm>
-          <a:prstGeom prst="rect">
-            <a:avLst/>
-          </a:prstGeom>
-          <a:solidFill>
-            <a:srgbClr val="E3F0EF"/>
-          </a:solidFill>
-          <a:ln w="12700">
-            <a:solidFill>
-              <a:srgbClr val="0E7C7B"/>
-            </a:solidFill>
-          </a:ln>
-          <a:effectLst/>
-        </p:spPr>
-        <p:style>
-          <a:lnRef idx="1">
-            <a:schemeClr val="accent1"/>
-          </a:lnRef>
-          <a:fillRef idx="3">
-            <a:schemeClr val="accent1"/>
-          </a:fillRef>
-          <a:effectRef idx="2">
-            <a:schemeClr val="accent1"/>
-          </a:effectRef>
-          <a:fontRef idx="minor">
-            <a:schemeClr val="lt1"/>
-          </a:fontRef>
-        </p:style>
-        <p:txBody>
-          <a:bodyPr wrap="square" lIns="182880" rIns="182880" rtlCol="0" anchor="ctr"/>
-          <a:lstStyle/>
-          <a:p>
-            <a:pPr algn="ctr"/>
-            <a:r>
-              <a:rPr sz="1200" b="1" i="0" dirty="0">
-                <a:solidFill>
-                  <a:srgbClr val="0E7C7B"/>
+          <p:cNvPr id="4" name="Text Placeholder 3">
+            <a:extLst>
+              <a:ext uri="{FF2B5EF4-FFF2-40B4-BE49-F238E27FC236}">
+                <a16:creationId xmlns:a16="http://schemas.microsoft.com/office/drawing/2014/main" id="{76A118A6-721F-11E9-4CB7-AF8847D49C3C}"/>
+              </a:ext>
+            </a:extLst>
+          </p:cNvPr>
+          <p:cNvSpPr>
+            <a:spLocks noGrp="1"/>
+          </p:cNvSpPr>
+          <p:nvPr>
+            <p:ph type="body" sz="quarter" idx="13"/>
+          </p:nvPr>
+        </p:nvSpPr>
+        <p:spPr/>
+        <p:txBody>
+          <a:bodyPr>
+            <a:normAutofit/>
+          </a:bodyPr>
+          <a:lstStyle/>
+          <a:p>
+            <a:pPr marL="0" marR="0" lvl="0" indent="0" defTabSz="457200" rtl="0" eaLnBrk="1" fontAlgn="auto" latinLnBrk="0" hangingPunct="1">
+              <a:lnSpc>
+                <a:spcPct val="100000"/>
+              </a:lnSpc>
+              <a:spcBef>
+                <a:spcPts val="0"/>
+              </a:spcBef>
+              <a:spcAft>
+                <a:spcPts val="0"/>
+              </a:spcAft>
+              <a:buClrTx/>
+              <a:buSzTx/>
+              <a:buFontTx/>
+              <a:buNone/>
+              <a:tabLst/>
+              <a:defRPr/>
+            </a:pPr>
+            <a:r>
+              <a:rPr sz="1300" b="1" i="0">
+                <a:solidFill>
+                  <a:srgbClr val="8A9099"/>
                 </a:solidFill>
                 <a:latin typeface="Menlo"/>
               </a:rPr>
-              <a:t>MASS SPEC · </a:t>
-            </a:r>
-            <a:r>
-              <a:rPr sz="1700" b="0" i="0" dirty="0">
-                <a:solidFill>
-                  <a:srgbClr val="3D444C"/>
-                </a:solidFill>
-                <a:latin typeface="Avenir Next"/>
-              </a:rPr>
-              <a:t>Same call (both pick R, so accuracy counts both 'correct') — but plug into CE = −ln(p): A = −ln(0.90) = 0.105, B = −ln(0.55) = 0.598, so B's hedge costs 5.7× the loss. Rule of thumb: predict a NUMBER → MSE; choose a CLASS → cross-entropy. In </a:t>
-            </a:r>
-            <a:r>
-              <a:rPr sz="1700" b="0" i="0" dirty="0" err="1">
-                <a:solidFill>
-                  <a:srgbClr val="3D444C"/>
-                </a:solidFill>
-                <a:latin typeface="Avenir Next"/>
-              </a:rPr>
-              <a:t>PyTorch</a:t>
-            </a:r>
-            <a:r>
-              <a:rPr sz="1700" b="0" i="0" dirty="0">
-                <a:solidFill>
-                  <a:srgbClr val="3D444C"/>
-                </a:solidFill>
-                <a:latin typeface="Avenir Next"/>
-              </a:rPr>
-              <a:t>, one line: </a:t>
-            </a:r>
-            <a:r>
-              <a:rPr sz="1700" b="0" i="0" dirty="0" err="1">
-                <a:solidFill>
-                  <a:srgbClr val="3D444C"/>
-                </a:solidFill>
-                <a:latin typeface="Avenir Next"/>
-              </a:rPr>
-              <a:t>nn.MSELoss</a:t>
-            </a:r>
-            <a:r>
-              <a:rPr sz="1700" b="0" i="0" dirty="0">
-                <a:solidFill>
-                  <a:srgbClr val="3D444C"/>
-                </a:solidFill>
-                <a:latin typeface="Avenir Next"/>
-              </a:rPr>
-              <a:t> → </a:t>
-            </a:r>
-            <a:r>
-              <a:rPr sz="1700" b="0" i="0" dirty="0" err="1">
-                <a:solidFill>
-                  <a:srgbClr val="3D444C"/>
-                </a:solidFill>
-                <a:latin typeface="Avenir Next"/>
-              </a:rPr>
-              <a:t>nn.CrossEntropyLoss</a:t>
-            </a:r>
-            <a:r>
-              <a:rPr sz="1700" b="0" i="0" dirty="0">
-                <a:solidFill>
-                  <a:srgbClr val="3D444C"/>
-                </a:solidFill>
-                <a:latin typeface="Avenir Next"/>
-              </a:rPr>
-              <a:t> (it even applies </a:t>
-            </a:r>
-            <a:r>
-              <a:rPr sz="1700" b="0" i="0" dirty="0" err="1">
-                <a:solidFill>
-                  <a:srgbClr val="3D444C"/>
-                </a:solidFill>
-                <a:latin typeface="Avenir Next"/>
-              </a:rPr>
-              <a:t>softmax</a:t>
-            </a:r>
-            <a:r>
-              <a:rPr sz="1700" b="0" i="0" dirty="0">
-                <a:solidFill>
-                  <a:srgbClr val="3D444C"/>
-                </a:solidFill>
-                <a:latin typeface="Avenir Next"/>
-              </a:rPr>
-              <a:t> internally).</a:t>
+              <a:t>PART 1 · LOSS · THE RESULT</a:t>
+            </a:r>
+          </a:p>
+        </p:txBody>
+      </p:sp>
+      <p:sp>
+        <p:nvSpPr>
+          <p:cNvPr id="6" name="TextBox 5">
+            <a:extLst>
+              <a:ext uri="{FF2B5EF4-FFF2-40B4-BE49-F238E27FC236}">
+                <a16:creationId xmlns:a16="http://schemas.microsoft.com/office/drawing/2014/main" id="{8E007FFA-490F-C63F-A898-A747DF58590B}"/>
+              </a:ext>
+            </a:extLst>
+          </p:cNvPr>
+          <p:cNvSpPr txBox="1"/>
+          <p:nvPr/>
+        </p:nvSpPr>
+        <p:spPr>
+          <a:xfrm>
+            <a:off x="7006855" y="6394420"/>
+            <a:ext cx="3601563" cy="307777"/>
+          </a:xfrm>
+          <a:prstGeom prst="rect">
+            <a:avLst/>
+          </a:prstGeom>
+          <a:noFill/>
+        </p:spPr>
+        <p:txBody>
+          <a:bodyPr wrap="none" rtlCol="0">
+            <a:spAutoFit/>
+          </a:bodyPr>
+          <a:lstStyle/>
+          <a:p>
+            <a:r>
+              <a:rPr lang="en-US" sz="1400" i="1" dirty="0">
+                <a:solidFill>
+                  <a:schemeClr val="accent6">
+                    <a:lumMod val="75000"/>
+                  </a:schemeClr>
+                </a:solidFill>
+              </a:rPr>
+              <a:t>cc deep learning in one day from Prof. Lee</a:t>
             </a:r>
           </a:p>
         </p:txBody>
       </p:sp>
     </p:spTree>
+    <p:extLst>
+      <p:ext uri="{BB962C8B-B14F-4D97-AF65-F5344CB8AC3E}">
+        <p14:creationId xmlns:p14="http://schemas.microsoft.com/office/powerpoint/2010/main" val="1697687664"/>
+      </p:ext>
+    </p:extLst>
   </p:cSld>
   <p:clrMapOvr>
     <a:masterClrMapping/>

</xml_diff>